<commit_message>
Add second-look gaps and opportunities to strategy doc and deck
Two new slides and matching markdown sections: six gaps beyond the
founding vision (inbound governance, AI-prompt/clipboard policy,
Angular strangler policy, mapping registry, paradigm bus factor,
pack-equivalence coverage) and four unclaimed opportunities
(absorbing GenAI adopter teams, mock-driven requirements, Spring
extension, desensitizer as an internal platform).

Co-Authored-By: Claude Fable 5 <noreply@anthropic.com>
Claude-Session: https://claude.ai/code/session_01NCQ4pPu4jZQ7AgDqWePsQe
</commit_message>
<xml_diff>
--- a/docs/internet-first-airgap-final.pptx
+++ b/docs/internet-first-airgap-final.pptx
@@ -21,9 +21,11 @@
     <p:sldId id="269" r:id="rId15"/>
     <p:sldId id="270" r:id="rId16"/>
     <p:sldId id="271" r:id="rId17"/>
+    <p:sldId id="272" r:id="rId18"/>
+    <p:sldId id="273" r:id="rId19"/>
   </p:sldIdLst>
   <p:notesMasterIdLst>
-    <p:notesMasterId r:id="rId18"/>
+    <p:notesMasterId r:id="rId20"/>
   </p:notesMasterIdLst>
   <p:sldSz cx="12192000" cy="6858000"/>
   <p:notesSz cx="6858000" cy="12192000"/>
@@ -1157,6 +1159,182 @@
             <a:fld id="{F7021451-1387-4CA6-816F-3879F97B5CBC}" type="slidenum">
               <a:rPr lang="en-US"/>
               <a:t>16</a:t>
+            </a:fld>
+            <a:endParaRPr lang="en-US"/>
+          </a:p>
+        </p:txBody>
+      </p:sp>
+    </p:spTree>
+    <p:extLst>
+      <p:ext uri="{BB962C8B-B14F-4D97-AF65-F5344CB8AC3E}">
+        <p14:creationId xmlns:p14="http://schemas.microsoft.com/office/powerpoint/2010/main" val="1024086991"/>
+      </p:ext>
+    </p:extLst>
+  </p:cSld>
+  <p:clrMapOvr>
+    <a:masterClrMapping/>
+  </p:clrMapOvr>
+</p:notes>
+</file>
+
+<file path=ppt/notesSlides/notesSlide17.xml><?xml version="1.0" encoding="utf-8"?>
+<p:notes xmlns:a="http://schemas.openxmlformats.org/drawingml/2006/main" xmlns:r="http://schemas.openxmlformats.org/officeDocument/2006/relationships" xmlns:p="http://schemas.openxmlformats.org/presentationml/2006/main">
+  <p:cSld>
+    <p:spTree>
+      <p:nvGrpSpPr>
+        <p:cNvPr id="1" name=""/>
+        <p:cNvGrpSpPr/>
+        <p:nvPr/>
+      </p:nvGrpSpPr>
+      <p:grpSpPr>
+        <a:xfrm>
+          <a:off x="0" y="0"/>
+          <a:ext cx="0" cy="0"/>
+          <a:chOff x="0" y="0"/>
+          <a:chExt cx="0" cy="0"/>
+        </a:xfrm>
+      </p:grpSpPr>
+      <p:sp>
+        <p:nvSpPr>
+          <p:cNvPr id="2" name="Slide Image Placeholder 1"/>
+          <p:cNvSpPr>
+            <a:spLocks noGrp="1" noRot="1" noChangeAspect="1"/>
+          </p:cNvSpPr>
+          <p:nvPr>
+            <p:ph type="sldImg"/>
+          </p:nvPr>
+        </p:nvSpPr>
+        <p:spPr/>
+      </p:sp>
+      <p:sp>
+        <p:nvSpPr>
+          <p:cNvPr id="3" name="Notes Placeholder 2"/>
+          <p:cNvSpPr>
+            <a:spLocks noGrp="1"/>
+          </p:cNvSpPr>
+          <p:nvPr>
+            <p:ph type="body" idx="1"/>
+          </p:nvPr>
+        </p:nvSpPr>
+        <p:spPr/>
+        <p:txBody>
+          <a:bodyPr/>
+          <a:lstStyle/>
+          <a:p>
+            <a:r>
+              <a:rPr lang="en-US" dirty="0"/>
+              <a:t/>
+            </a:r>
+            <a:endParaRPr lang="en-US" dirty="0"/>
+          </a:p>
+        </p:txBody>
+      </p:sp>
+      <p:sp>
+        <p:nvSpPr>
+          <p:cNvPr id="4" name="Slide Number Placeholder 3"/>
+          <p:cNvSpPr>
+            <a:spLocks noGrp="1"/>
+          </p:cNvSpPr>
+          <p:nvPr>
+            <p:ph type="sldNum" sz="quarter" idx="10"/>
+          </p:nvPr>
+        </p:nvSpPr>
+        <p:spPr/>
+        <p:txBody>
+          <a:bodyPr/>
+          <a:lstStyle/>
+          <a:p>
+            <a:fld id="{F7021451-1387-4CA6-816F-3879F97B5CBC}" type="slidenum">
+              <a:rPr lang="en-US"/>
+              <a:t>17</a:t>
+            </a:fld>
+            <a:endParaRPr lang="en-US"/>
+          </a:p>
+        </p:txBody>
+      </p:sp>
+    </p:spTree>
+    <p:extLst>
+      <p:ext uri="{BB962C8B-B14F-4D97-AF65-F5344CB8AC3E}">
+        <p14:creationId xmlns:p14="http://schemas.microsoft.com/office/powerpoint/2010/main" val="1024086991"/>
+      </p:ext>
+    </p:extLst>
+  </p:cSld>
+  <p:clrMapOvr>
+    <a:masterClrMapping/>
+  </p:clrMapOvr>
+</p:notes>
+</file>
+
+<file path=ppt/notesSlides/notesSlide18.xml><?xml version="1.0" encoding="utf-8"?>
+<p:notes xmlns:a="http://schemas.openxmlformats.org/drawingml/2006/main" xmlns:r="http://schemas.openxmlformats.org/officeDocument/2006/relationships" xmlns:p="http://schemas.openxmlformats.org/presentationml/2006/main">
+  <p:cSld>
+    <p:spTree>
+      <p:nvGrpSpPr>
+        <p:cNvPr id="1" name=""/>
+        <p:cNvGrpSpPr/>
+        <p:nvPr/>
+      </p:nvGrpSpPr>
+      <p:grpSpPr>
+        <a:xfrm>
+          <a:off x="0" y="0"/>
+          <a:ext cx="0" cy="0"/>
+          <a:chOff x="0" y="0"/>
+          <a:chExt cx="0" cy="0"/>
+        </a:xfrm>
+      </p:grpSpPr>
+      <p:sp>
+        <p:nvSpPr>
+          <p:cNvPr id="2" name="Slide Image Placeholder 1"/>
+          <p:cNvSpPr>
+            <a:spLocks noGrp="1" noRot="1" noChangeAspect="1"/>
+          </p:cNvSpPr>
+          <p:nvPr>
+            <p:ph type="sldImg"/>
+          </p:nvPr>
+        </p:nvSpPr>
+        <p:spPr/>
+      </p:sp>
+      <p:sp>
+        <p:nvSpPr>
+          <p:cNvPr id="3" name="Notes Placeholder 2"/>
+          <p:cNvSpPr>
+            <a:spLocks noGrp="1"/>
+          </p:cNvSpPr>
+          <p:nvPr>
+            <p:ph type="body" idx="1"/>
+          </p:nvPr>
+        </p:nvSpPr>
+        <p:spPr/>
+        <p:txBody>
+          <a:bodyPr/>
+          <a:lstStyle/>
+          <a:p>
+            <a:r>
+              <a:rPr lang="en-US" dirty="0"/>
+              <a:t/>
+            </a:r>
+            <a:endParaRPr lang="en-US" dirty="0"/>
+          </a:p>
+        </p:txBody>
+      </p:sp>
+      <p:sp>
+        <p:nvSpPr>
+          <p:cNvPr id="4" name="Slide Number Placeholder 3"/>
+          <p:cNvSpPr>
+            <a:spLocks noGrp="1"/>
+          </p:cNvSpPr>
+          <p:nvPr>
+            <p:ph type="sldNum" sz="quarter" idx="10"/>
+          </p:nvPr>
+        </p:nvSpPr>
+        <p:spPr/>
+        <p:txBody>
+          <a:bodyPr/>
+          <a:lstStyle/>
+          <a:p>
+            <a:fld id="{F7021451-1387-4CA6-816F-3879F97B5CBC}" type="slidenum">
+              <a:rPr lang="en-US"/>
+              <a:t>18</a:t>
             </a:fld>
             <a:endParaRPr lang="en-US"/>
           </a:p>
@@ -6305,7 +6483,7 @@
                 <a:ea typeface="Calibri" pitchFamily="34" charset="-122"/>
                 <a:cs typeface="Calibri" pitchFamily="34" charset="-120"/>
               </a:rPr>
-              <a:t>EXECUTION · A PRAGMATIC TRANSITION TIMELINE</a:t>
+              <a:t>SECOND LOOK · BEYOND THE FOUNDING VISION</a:t>
             </a:r>
             <a:endParaRPr lang="en-US" sz="1200" dirty="0"/>
           </a:p>
@@ -6344,7 +6522,7 @@
                 <a:ea typeface="Cambria" pitchFamily="34" charset="-122"/>
                 <a:cs typeface="Cambria" pitchFamily="34" charset="-120"/>
               </a:rPr>
-              <a:t>Phase exits are criteria, not dates</a:t>
+              <a:t>Six gaps the current plan does not cover</a:t>
             </a:r>
             <a:endParaRPr lang="en-US" sz="3000" dirty="0"/>
           </a:p>
@@ -6358,12 +6536,12 @@
         </p:nvSpPr>
         <p:spPr>
           <a:xfrm>
-            <a:off x="548640" y="1691640"/>
-            <a:ext cx="2602154" cy="4206240"/>
+            <a:off x="548640" y="1572768"/>
+            <a:ext cx="3527450" cy="2139696"/>
           </a:xfrm>
           <a:prstGeom prst="roundRect">
             <a:avLst>
-              <a:gd name="adj" fmla="val 2811"/>
+              <a:gd name="adj" fmla="val 3419"/>
             </a:avLst>
           </a:prstGeom>
           <a:solidFill>
@@ -6381,14 +6559,58 @@
       </p:sp>
       <p:sp>
         <p:nvSpPr>
-          <p:cNvPr id="7" name="Text 5"/>
-          <p:cNvSpPr/>
-          <p:nvPr/>
-        </p:nvSpPr>
-        <p:spPr>
-          <a:xfrm>
-            <a:off x="731520" y="1828800"/>
-            <a:ext cx="2236394" cy="274320"/>
+          <p:cNvPr id="7" name="Shape 5"/>
+          <p:cNvSpPr/>
+          <p:nvPr/>
+        </p:nvSpPr>
+        <p:spPr>
+          <a:xfrm>
+            <a:off x="731520" y="1737360"/>
+            <a:ext cx="457200" cy="457200"/>
+          </a:xfrm>
+          <a:prstGeom prst="ellipse">
+            <a:avLst/>
+          </a:prstGeom>
+          <a:solidFill>
+            <a:srgbClr val="1E2761"/>
+          </a:solidFill>
+          <a:ln/>
+        </p:spPr>
+      </p:sp>
+      <p:pic>
+        <p:nvPicPr>
+          <p:cNvPr id="8" name="Image 0" descr="preencoded.png">    </p:cNvPr>
+          <p:cNvPicPr>
+            <a:picLocks noChangeAspect="1"/>
+          </p:cNvPicPr>
+          <p:nvPr/>
+        </p:nvPicPr>
+        <p:blipFill>
+          <a:blip r:embed="rId1"/>
+          <a:stretch>
+            <a:fillRect/>
+          </a:stretch>
+        </p:blipFill>
+        <p:spPr>
+          <a:xfrm>
+            <a:off x="850392" y="1856232"/>
+            <a:ext cx="219456" cy="219456"/>
+          </a:xfrm>
+          <a:prstGeom prst="rect">
+            <a:avLst/>
+          </a:prstGeom>
+        </p:spPr>
+      </p:pic>
+      <p:sp>
+        <p:nvSpPr>
+          <p:cNvPr id="9" name="Text 6"/>
+          <p:cNvSpPr/>
+          <p:nvPr/>
+        </p:nvSpPr>
+        <p:spPr>
+          <a:xfrm>
+            <a:off x="1298448" y="1773936"/>
+            <a:ext cx="2658770" cy="384048"/>
           </a:xfrm>
           <a:prstGeom prst="rect">
             <a:avLst/>
@@ -6404,30 +6626,30 @@
               <a:buNone/>
             </a:pPr>
             <a:r>
-              <a:rPr lang="en-US" sz="1100" b="1" spc="200" kern="0" dirty="0">
-                <a:solidFill>
-                  <a:srgbClr val="5A6B8C"/>
-                </a:solidFill>
-                <a:latin typeface="Calibri" pitchFamily="34" charset="0"/>
-                <a:ea typeface="Calibri" pitchFamily="34" charset="-122"/>
-                <a:cs typeface="Calibri" pitchFamily="34" charset="-120"/>
-              </a:rPr>
-              <a:t>PHASE 0</a:t>
-            </a:r>
-            <a:endParaRPr lang="en-US" sz="1100" dirty="0"/>
-          </a:p>
-        </p:txBody>
-      </p:sp>
-      <p:sp>
-        <p:nvSpPr>
-          <p:cNvPr id="8" name="Text 6"/>
-          <p:cNvSpPr/>
-          <p:nvPr/>
-        </p:nvSpPr>
-        <p:spPr>
-          <a:xfrm>
-            <a:off x="731520" y="2103120"/>
-            <a:ext cx="2236394" cy="685800"/>
+              <a:rPr lang="en-US" sz="1300" b="1" dirty="0">
+                <a:solidFill>
+                  <a:srgbClr val="1E2761"/>
+                </a:solidFill>
+                <a:latin typeface="Calibri" pitchFamily="34" charset="0"/>
+                <a:ea typeface="Calibri" pitchFamily="34" charset="-122"/>
+                <a:cs typeface="Calibri" pitchFamily="34" charset="-120"/>
+              </a:rPr>
+              <a:t>Inbound is ungoverned</a:t>
+            </a:r>
+            <a:endParaRPr lang="en-US" sz="1300" dirty="0"/>
+          </a:p>
+        </p:txBody>
+      </p:sp>
+      <p:sp>
+        <p:nvSpPr>
+          <p:cNvPr id="10" name="Text 7"/>
+          <p:cNvSpPr/>
+          <p:nvPr/>
+        </p:nvSpPr>
+        <p:spPr>
+          <a:xfrm>
+            <a:off x="749808" y="2231136"/>
+            <a:ext cx="3125114" cy="1335024"/>
           </a:xfrm>
           <a:prstGeom prst="rect">
             <a:avLst/>
@@ -6443,67 +6665,7 @@
               <a:buNone/>
             </a:pPr>
             <a:r>
-              <a:rPr lang="en-US" sz="1350" b="1" dirty="0">
-                <a:solidFill>
-                  <a:srgbClr val="1E2761"/>
-                </a:solidFill>
-                <a:latin typeface="Calibri" pitchFamily="34" charset="0"/>
-                <a:ea typeface="Calibri" pitchFamily="34" charset="-122"/>
-                <a:cs typeface="Calibri" pitchFamily="34" charset="-120"/>
-              </a:rPr>
-              <a:t>Legitimize &amp; pilot</a:t>
-            </a:r>
-            <a:endParaRPr lang="en-US" sz="1350" dirty="0"/>
-          </a:p>
-          <a:p>
-            <a:pPr indent="0" marL="0">
-              <a:buNone/>
-            </a:pPr>
-            <a:r>
-              <a:rPr lang="en-US" sz="1350" b="1" dirty="0">
-                <a:solidFill>
-                  <a:srgbClr val="1E2761"/>
-                </a:solidFill>
-                <a:latin typeface="Calibri" pitchFamily="34" charset="0"/>
-                <a:ea typeface="Calibri" pitchFamily="34" charset="-122"/>
-                <a:cs typeface="Calibri" pitchFamily="34" charset="-120"/>
-              </a:rPr>
-              <a:t>(mo 0–2)</a:t>
-            </a:r>
-            <a:endParaRPr lang="en-US" sz="1350" dirty="0"/>
-          </a:p>
-        </p:txBody>
-      </p:sp>
-      <p:sp>
-        <p:nvSpPr>
-          <p:cNvPr id="9" name="Text 7"/>
-          <p:cNvSpPr/>
-          <p:nvPr/>
-        </p:nvSpPr>
-        <p:spPr>
-          <a:xfrm>
-            <a:off x="731520" y="2880360"/>
-            <a:ext cx="2236394" cy="2834640"/>
-          </a:xfrm>
-          <a:prstGeom prst="rect">
-            <a:avLst/>
-          </a:prstGeom>
-          <a:noFill/>
-          <a:ln/>
-        </p:spPr>
-        <p:txBody>
-          <a:bodyPr wrap="square" lIns="0" tIns="0" rIns="0" bIns="0" rtlCol="0" anchor="ctr"/>
-          <a:lstStyle/>
-          <a:p>
-            <a:pPr marL="342900" indent="-342900">
-              <a:spcAft>
-                <a:spcPts val="600"/>
-              </a:spcAft>
-              <a:buSzPct val="100000"/>
-              <a:buChar char="•"/>
-            </a:pPr>
-            <a:r>
-              <a:rPr lang="en-US" sz="980" dirty="0">
+              <a:rPr lang="en-US" sz="930" dirty="0">
                 <a:solidFill>
                   <a:srgbClr val="1B2440"/>
                 </a:solidFill>
@@ -6511,89 +6673,26 @@
                 <a:ea typeface="Calibri" pitchFamily="34" charset="-122"/>
                 <a:cs typeface="Calibri" pitchFamily="34" charset="-120"/>
               </a:rPr>
-              <a:t>Written authorization: scope, egress channel, named approvers</a:t>
-            </a:r>
-            <a:endParaRPr lang="en-US" sz="980" dirty="0"/>
-          </a:p>
-          <a:p>
-            <a:pPr marL="342900" indent="-342900">
-              <a:spcAft>
-                <a:spcPts val="600"/>
-              </a:spcAft>
-              <a:buSzPct val="100000"/>
-              <a:buChar char="•"/>
-            </a:pPr>
-            <a:r>
-              <a:rPr lang="en-US" sz="980" dirty="0">
-                <a:solidFill>
-                  <a:srgbClr val="1B2440"/>
-                </a:solidFill>
-                <a:latin typeface="Calibri" pitchFamily="34" charset="0"/>
-                <a:ea typeface="Calibri" pitchFamily="34" charset="-122"/>
-                <a:cs typeface="Calibri" pitchFamily="34" charset="-120"/>
-              </a:rPr>
-              <a:t>Gates 0–3 stood up; denylist co-authored with cyber</a:t>
-            </a:r>
-            <a:endParaRPr lang="en-US" sz="980" dirty="0"/>
-          </a:p>
-          <a:p>
-            <a:pPr marL="342900" indent="-342900">
-              <a:spcAft>
-                <a:spcPts val="600"/>
-              </a:spcAft>
-              <a:buSzPct val="100000"/>
-              <a:buChar char="•"/>
-            </a:pPr>
-            <a:r>
-              <a:rPr lang="en-US" sz="980" dirty="0">
-                <a:solidFill>
-                  <a:srgbClr val="1B2440"/>
-                </a:solidFill>
-                <a:latin typeface="Calibri" pitchFamily="34" charset="0"/>
-                <a:ea typeface="Calibri" pitchFamily="34" charset="-122"/>
-                <a:cs typeface="Calibri" pitchFamily="34" charset="-120"/>
-              </a:rPr>
-              <a:t>World bible v1 + internet org &amp; repos with CI parity</a:t>
-            </a:r>
-            <a:endParaRPr lang="en-US" sz="980" dirty="0"/>
-          </a:p>
-          <a:p>
-            <a:pPr marL="342900" indent="-342900">
-              <a:spcAft>
-                <a:spcPts val="600"/>
-              </a:spcAft>
-              <a:buSzPct val="100000"/>
-              <a:buChar char="•"/>
-            </a:pPr>
-            <a:r>
-              <a:rPr lang="en-US" sz="980" dirty="0">
-                <a:solidFill>
-                  <a:srgbClr val="1B2440"/>
-                </a:solidFill>
-                <a:latin typeface="Calibri" pitchFamily="34" charset="0"/>
-                <a:ea typeface="Calibri" pitchFamily="34" charset="-122"/>
-                <a:cs typeface="Calibri" pitchFamily="34" charset="-120"/>
-              </a:rPr>
-              <a:t>Pilot feature specced and egressed</a:t>
-            </a:r>
-            <a:endParaRPr lang="en-US" sz="980" dirty="0"/>
-          </a:p>
-        </p:txBody>
-      </p:sp>
-      <p:sp>
-        <p:nvSpPr>
-          <p:cNvPr id="10" name="Shape 8"/>
-          <p:cNvSpPr/>
-          <p:nvPr/>
-        </p:nvSpPr>
-        <p:spPr>
-          <a:xfrm>
-            <a:off x="3379394" y="1691640"/>
-            <a:ext cx="2602154" cy="4206240"/>
+              <a:t>All gate energy is outbound, but this is a standing channel INTO a classified network: compromised internet org, poisoned AI code, license contamination. Mirror the gates inbound: signed tags, SCA + license scan, inside diff-review vs. previous tag, rebuild from source, inbound ledger.</a:t>
+            </a:r>
+            <a:endParaRPr lang="en-US" sz="930" dirty="0"/>
+          </a:p>
+        </p:txBody>
+      </p:sp>
+      <p:sp>
+        <p:nvSpPr>
+          <p:cNvPr id="11" name="Shape 8"/>
+          <p:cNvSpPr/>
+          <p:nvPr/>
+        </p:nvSpPr>
+        <p:spPr>
+          <a:xfrm>
+            <a:off x="4332122" y="1572768"/>
+            <a:ext cx="3527450" cy="2139696"/>
           </a:xfrm>
           <a:prstGeom prst="roundRect">
             <a:avLst>
-              <a:gd name="adj" fmla="val 2811"/>
+              <a:gd name="adj" fmla="val 3419"/>
             </a:avLst>
           </a:prstGeom>
           <a:solidFill>
@@ -6611,14 +6710,58 @@
       </p:sp>
       <p:sp>
         <p:nvSpPr>
-          <p:cNvPr id="11" name="Text 9"/>
-          <p:cNvSpPr/>
-          <p:nvPr/>
-        </p:nvSpPr>
-        <p:spPr>
-          <a:xfrm>
-            <a:off x="3562274" y="1828800"/>
-            <a:ext cx="2236394" cy="274320"/>
+          <p:cNvPr id="12" name="Shape 9"/>
+          <p:cNvSpPr/>
+          <p:nvPr/>
+        </p:nvSpPr>
+        <p:spPr>
+          <a:xfrm>
+            <a:off x="4515002" y="1737360"/>
+            <a:ext cx="457200" cy="457200"/>
+          </a:xfrm>
+          <a:prstGeom prst="ellipse">
+            <a:avLst/>
+          </a:prstGeom>
+          <a:solidFill>
+            <a:srgbClr val="1E2761"/>
+          </a:solidFill>
+          <a:ln/>
+        </p:spPr>
+      </p:sp>
+      <p:pic>
+        <p:nvPicPr>
+          <p:cNvPr id="13" name="Image 1" descr="preencoded.png">    </p:cNvPr>
+          <p:cNvPicPr>
+            <a:picLocks noChangeAspect="1"/>
+          </p:cNvPicPr>
+          <p:nvPr/>
+        </p:nvPicPr>
+        <p:blipFill>
+          <a:blip r:embed="rId2"/>
+          <a:stretch>
+            <a:fillRect/>
+          </a:stretch>
+        </p:blipFill>
+        <p:spPr>
+          <a:xfrm>
+            <a:off x="4633874" y="1856232"/>
+            <a:ext cx="219456" cy="219456"/>
+          </a:xfrm>
+          <a:prstGeom prst="rect">
+            <a:avLst/>
+          </a:prstGeom>
+        </p:spPr>
+      </p:pic>
+      <p:sp>
+        <p:nvSpPr>
+          <p:cNvPr id="14" name="Text 10"/>
+          <p:cNvSpPr/>
+          <p:nvPr/>
+        </p:nvSpPr>
+        <p:spPr>
+          <a:xfrm>
+            <a:off x="5081930" y="1773936"/>
+            <a:ext cx="2658770" cy="384048"/>
           </a:xfrm>
           <a:prstGeom prst="rect">
             <a:avLst/>
@@ -6634,30 +6777,30 @@
               <a:buNone/>
             </a:pPr>
             <a:r>
-              <a:rPr lang="en-US" sz="1100" b="1" spc="200" kern="0" dirty="0">
-                <a:solidFill>
-                  <a:srgbClr val="5A6B8C"/>
-                </a:solidFill>
-                <a:latin typeface="Calibri" pitchFamily="34" charset="0"/>
-                <a:ea typeface="Calibri" pitchFamily="34" charset="-122"/>
-                <a:cs typeface="Calibri" pitchFamily="34" charset="-120"/>
-              </a:rPr>
-              <a:t>PHASE 1</a:t>
-            </a:r>
-            <a:endParaRPr lang="en-US" sz="1100" dirty="0"/>
-          </a:p>
-        </p:txBody>
-      </p:sp>
-      <p:sp>
-        <p:nvSpPr>
-          <p:cNvPr id="12" name="Text 10"/>
-          <p:cNvSpPr/>
-          <p:nvPr/>
-        </p:nvSpPr>
-        <p:spPr>
-          <a:xfrm>
-            <a:off x="3562274" y="2103120"/>
-            <a:ext cx="2236394" cy="685800"/>
+              <a:rPr lang="en-US" sz="1300" b="1" dirty="0">
+                <a:solidFill>
+                  <a:srgbClr val="1E2761"/>
+                </a:solidFill>
+                <a:latin typeface="Calibri" pitchFamily="34" charset="0"/>
+                <a:ea typeface="Calibri" pitchFamily="34" charset="-122"/>
+                <a:cs typeface="Calibri" pitchFamily="34" charset="-120"/>
+              </a:rPr>
+              <a:t>The clipboard channel</a:t>
+            </a:r>
+            <a:endParaRPr lang="en-US" sz="1300" dirty="0"/>
+          </a:p>
+        </p:txBody>
+      </p:sp>
+      <p:sp>
+        <p:nvSpPr>
+          <p:cNvPr id="15" name="Text 11"/>
+          <p:cNvSpPr/>
+          <p:nvPr/>
+        </p:nvSpPr>
+        <p:spPr>
+          <a:xfrm>
+            <a:off x="4533290" y="2231136"/>
+            <a:ext cx="3125114" cy="1335024"/>
           </a:xfrm>
           <a:prstGeom prst="rect">
             <a:avLst/>
@@ -6673,67 +6816,7 @@
               <a:buNone/>
             </a:pPr>
             <a:r>
-              <a:rPr lang="en-US" sz="1350" b="1" dirty="0">
-                <a:solidFill>
-                  <a:srgbClr val="1E2761"/>
-                </a:solidFill>
-                <a:latin typeface="Calibri" pitchFamily="34" charset="0"/>
-                <a:ea typeface="Calibri" pitchFamily="34" charset="-122"/>
-                <a:cs typeface="Calibri" pitchFamily="34" charset="-120"/>
-              </a:rPr>
-              <a:t>Internet-first core team</a:t>
-            </a:r>
-            <a:endParaRPr lang="en-US" sz="1350" dirty="0"/>
-          </a:p>
-          <a:p>
-            <a:pPr indent="0" marL="0">
-              <a:buNone/>
-            </a:pPr>
-            <a:r>
-              <a:rPr lang="en-US" sz="1350" b="1" dirty="0">
-                <a:solidFill>
-                  <a:srgbClr val="1E2761"/>
-                </a:solidFill>
-                <a:latin typeface="Calibri" pitchFamily="34" charset="0"/>
-                <a:ea typeface="Calibri" pitchFamily="34" charset="-122"/>
-                <a:cs typeface="Calibri" pitchFamily="34" charset="-120"/>
-              </a:rPr>
-              <a:t>(mo 2–8)</a:t>
-            </a:r>
-            <a:endParaRPr lang="en-US" sz="1350" dirty="0"/>
-          </a:p>
-        </p:txBody>
-      </p:sp>
-      <p:sp>
-        <p:nvSpPr>
-          <p:cNvPr id="13" name="Text 11"/>
-          <p:cNvSpPr/>
-          <p:nvPr/>
-        </p:nvSpPr>
-        <p:spPr>
-          <a:xfrm>
-            <a:off x="3562274" y="2880360"/>
-            <a:ext cx="2236394" cy="2834640"/>
-          </a:xfrm>
-          <a:prstGeom prst="rect">
-            <a:avLst/>
-          </a:prstGeom>
-          <a:noFill/>
-          <a:ln/>
-        </p:spPr>
-        <p:txBody>
-          <a:bodyPr wrap="square" lIns="0" tIns="0" rIns="0" bIns="0" rtlCol="0" anchor="ctr"/>
-          <a:lstStyle/>
-          <a:p>
-            <a:pPr marL="342900" indent="-342900">
-              <a:spcAft>
-                <a:spcPts val="600"/>
-              </a:spcAft>
-              <a:buSzPct val="100000"/>
-              <a:buChar char="•"/>
-            </a:pPr>
-            <a:r>
-              <a:rPr lang="en-US" sz="980" dirty="0">
+              <a:rPr lang="en-US" sz="930" dirty="0">
                 <a:solidFill>
                   <a:srgbClr val="1B2440"/>
                 </a:solidFill>
@@ -6741,89 +6824,26 @@
                 <a:ea typeface="Calibri" pitchFamily="34" charset="-122"/>
                 <a:cs typeface="Calibri" pitchFamily="34" charset="-120"/>
               </a:rPr>
-              <a:t>Core team builds pilot + 2–3 MFEs outside; logic-pack engine v1</a:t>
-            </a:r>
-            <a:endParaRPr lang="en-US" sz="980" dirty="0"/>
-          </a:p>
-          <a:p>
-            <a:pPr marL="342900" indent="-342900">
-              <a:spcAft>
-                <a:spcPts val="600"/>
-              </a:spcAft>
-              <a:buSzPct val="100000"/>
-              <a:buChar char="•"/>
-            </a:pPr>
-            <a:r>
-              <a:rPr lang="en-US" sz="980" dirty="0">
-                <a:solidFill>
-                  <a:srgbClr val="1B2440"/>
-                </a:solidFill>
-                <a:latin typeface="Calibri" pitchFamily="34" charset="0"/>
-                <a:ea typeface="Calibri" pitchFamily="34" charset="-122"/>
-                <a:cs typeface="Calibri" pitchFamily="34" charset="-120"/>
-              </a:rPr>
-              <a:t>Contractors own integration, mappings, env testing, config mgmt; some move to BA/spec roles</a:t>
-            </a:r>
-            <a:endParaRPr lang="en-US" sz="980" dirty="0"/>
-          </a:p>
-          <a:p>
-            <a:pPr marL="342900" indent="-342900">
-              <a:spcAft>
-                <a:spcPts val="600"/>
-              </a:spcAft>
-              <a:buSzPct val="100000"/>
-              <a:buChar char="•"/>
-            </a:pPr>
-            <a:r>
-              <a:rPr lang="en-US" sz="980" dirty="0">
-                <a:solidFill>
-                  <a:srgbClr val="1B2440"/>
-                </a:solidFill>
-                <a:latin typeface="Calibri" pitchFamily="34" charset="0"/>
-                <a:ea typeface="Calibri" pitchFamily="34" charset="-122"/>
-                <a:cs typeface="Calibri" pitchFamily="34" charset="-120"/>
-              </a:rPr>
-              <a:t>Dependency-delta job feeding Confi registry requests</a:t>
-            </a:r>
-            <a:endParaRPr lang="en-US" sz="980" dirty="0"/>
-          </a:p>
-          <a:p>
-            <a:pPr marL="342900" indent="-342900">
-              <a:spcAft>
-                <a:spcPts val="600"/>
-              </a:spcAft>
-              <a:buSzPct val="100000"/>
-              <a:buChar char="•"/>
-            </a:pPr>
-            <a:r>
-              <a:rPr lang="en-US" sz="980" dirty="0">
-                <a:solidFill>
-                  <a:srgbClr val="1B2440"/>
-                </a:solidFill>
-                <a:latin typeface="Calibri" pitchFamily="34" charset="0"/>
-                <a:ea typeface="Calibri" pitchFamily="34" charset="-122"/>
-                <a:cs typeface="Calibri" pitchFamily="34" charset="-120"/>
-              </a:rPr>
-              <a:t>Exit: 2 MFEs shipped through the full loop; integration ≤ 15% of feature effort</a:t>
-            </a:r>
-            <a:endParaRPr lang="en-US" sz="980" dirty="0"/>
-          </a:p>
-        </p:txBody>
-      </p:sp>
-      <p:sp>
-        <p:nvSpPr>
-          <p:cNvPr id="14" name="Shape 12"/>
-          <p:cNvSpPr/>
-          <p:nvPr/>
-        </p:nvSpPr>
-        <p:spPr>
-          <a:xfrm>
-            <a:off x="6210148" y="1691640"/>
-            <a:ext cx="2602154" cy="4206240"/>
+              <a:t>Gates govern packages; daily work is ad-hoc AI chats. The realistic leak is a dev pasting an error or rule “from memory”. Policy: only Gate-3-cleared content in any prompt; org accounts with zero-retention terms; world bible baked into assistant context so the AI speaks the fiction.</a:t>
+            </a:r>
+            <a:endParaRPr lang="en-US" sz="930" dirty="0"/>
+          </a:p>
+        </p:txBody>
+      </p:sp>
+      <p:sp>
+        <p:nvSpPr>
+          <p:cNvPr id="16" name="Shape 12"/>
+          <p:cNvSpPr/>
+          <p:nvPr/>
+        </p:nvSpPr>
+        <p:spPr>
+          <a:xfrm>
+            <a:off x="8115605" y="1572768"/>
+            <a:ext cx="3527450" cy="2139696"/>
           </a:xfrm>
           <a:prstGeom prst="roundRect">
             <a:avLst>
-              <a:gd name="adj" fmla="val 2811"/>
+              <a:gd name="adj" fmla="val 3419"/>
             </a:avLst>
           </a:prstGeom>
           <a:solidFill>
@@ -6841,14 +6861,58 @@
       </p:sp>
       <p:sp>
         <p:nvSpPr>
-          <p:cNvPr id="15" name="Text 13"/>
-          <p:cNvSpPr/>
-          <p:nvPr/>
-        </p:nvSpPr>
-        <p:spPr>
-          <a:xfrm>
-            <a:off x="6393028" y="1828800"/>
-            <a:ext cx="2236394" cy="274320"/>
+          <p:cNvPr id="17" name="Shape 13"/>
+          <p:cNvSpPr/>
+          <p:nvPr/>
+        </p:nvSpPr>
+        <p:spPr>
+          <a:xfrm>
+            <a:off x="8298485" y="1737360"/>
+            <a:ext cx="457200" cy="457200"/>
+          </a:xfrm>
+          <a:prstGeom prst="ellipse">
+            <a:avLst/>
+          </a:prstGeom>
+          <a:solidFill>
+            <a:srgbClr val="1E2761"/>
+          </a:solidFill>
+          <a:ln/>
+        </p:spPr>
+      </p:sp>
+      <p:pic>
+        <p:nvPicPr>
+          <p:cNvPr id="18" name="Image 2" descr="preencoded.png">    </p:cNvPr>
+          <p:cNvPicPr>
+            <a:picLocks noChangeAspect="1"/>
+          </p:cNvPicPr>
+          <p:nvPr/>
+        </p:nvPicPr>
+        <p:blipFill>
+          <a:blip r:embed="rId3"/>
+          <a:stretch>
+            <a:fillRect/>
+          </a:stretch>
+        </p:blipFill>
+        <p:spPr>
+          <a:xfrm>
+            <a:off x="8417357" y="1856232"/>
+            <a:ext cx="219456" cy="219456"/>
+          </a:xfrm>
+          <a:prstGeom prst="rect">
+            <a:avLst/>
+          </a:prstGeom>
+        </p:spPr>
+      </p:pic>
+      <p:sp>
+        <p:nvSpPr>
+          <p:cNvPr id="19" name="Text 14"/>
+          <p:cNvSpPr/>
+          <p:nvPr/>
+        </p:nvSpPr>
+        <p:spPr>
+          <a:xfrm>
+            <a:off x="8865413" y="1773936"/>
+            <a:ext cx="2658770" cy="384048"/>
           </a:xfrm>
           <a:prstGeom prst="rect">
             <a:avLst/>
@@ -6864,30 +6928,30 @@
               <a:buNone/>
             </a:pPr>
             <a:r>
-              <a:rPr lang="en-US" sz="1100" b="1" spc="200" kern="0" dirty="0">
-                <a:solidFill>
-                  <a:srgbClr val="5A6B8C"/>
-                </a:solidFill>
-                <a:latin typeface="Calibri" pitchFamily="34" charset="0"/>
-                <a:ea typeface="Calibri" pitchFamily="34" charset="-122"/>
-                <a:cs typeface="Calibri" pitchFamily="34" charset="-120"/>
-              </a:rPr>
-              <a:t>PHASE 2</a:t>
-            </a:r>
-            <a:endParaRPr lang="en-US" sz="1100" dirty="0"/>
-          </a:p>
-        </p:txBody>
-      </p:sp>
-      <p:sp>
-        <p:nvSpPr>
-          <p:cNvPr id="16" name="Text 14"/>
-          <p:cNvSpPr/>
-          <p:nvPr/>
-        </p:nvSpPr>
-        <p:spPr>
-          <a:xfrm>
-            <a:off x="6393028" y="2103120"/>
-            <a:ext cx="2236394" cy="685800"/>
+              <a:rPr lang="en-US" sz="1300" b="1" dirty="0">
+                <a:solidFill>
+                  <a:srgbClr val="1E2761"/>
+                </a:solidFill>
+                <a:latin typeface="Calibri" pitchFamily="34" charset="0"/>
+                <a:ea typeface="Calibri" pitchFamily="34" charset="-122"/>
+                <a:cs typeface="Calibri" pitchFamily="34" charset="-120"/>
+              </a:rPr>
+              <a:t>Angular keeps running</a:t>
+            </a:r>
+            <a:endParaRPr lang="en-US" sz="1300" dirty="0"/>
+          </a:p>
+        </p:txBody>
+      </p:sp>
+      <p:sp>
+        <p:nvSpPr>
+          <p:cNvPr id="20" name="Text 15"/>
+          <p:cNvSpPr/>
+          <p:nvPr/>
+        </p:nvSpPr>
+        <p:spPr>
+          <a:xfrm>
+            <a:off x="8316773" y="2231136"/>
+            <a:ext cx="3125114" cy="1335024"/>
           </a:xfrm>
           <a:prstGeom prst="rect">
             <a:avLst/>
@@ -6903,67 +6967,7 @@
               <a:buNone/>
             </a:pPr>
             <a:r>
-              <a:rPr lang="en-US" sz="1350" b="1" dirty="0">
-                <a:solidFill>
-                  <a:srgbClr val="1E2761"/>
-                </a:solidFill>
-                <a:latin typeface="Calibri" pitchFamily="34" charset="0"/>
-                <a:ea typeface="Calibri" pitchFamily="34" charset="-122"/>
-                <a:cs typeface="Calibri" pitchFamily="34" charset="-120"/>
-              </a:rPr>
-              <a:t>Outbound spec pipeline at scale</a:t>
-            </a:r>
-            <a:endParaRPr lang="en-US" sz="1350" dirty="0"/>
-          </a:p>
-          <a:p>
-            <a:pPr indent="0" marL="0">
-              <a:buNone/>
-            </a:pPr>
-            <a:r>
-              <a:rPr lang="en-US" sz="1350" b="1" dirty="0">
-                <a:solidFill>
-                  <a:srgbClr val="1E2761"/>
-                </a:solidFill>
-                <a:latin typeface="Calibri" pitchFamily="34" charset="0"/>
-                <a:ea typeface="Calibri" pitchFamily="34" charset="-122"/>
-                <a:cs typeface="Calibri" pitchFamily="34" charset="-120"/>
-              </a:rPr>
-              <a:t>(mo 6–14, overlaps)</a:t>
-            </a:r>
-            <a:endParaRPr lang="en-US" sz="1350" dirty="0"/>
-          </a:p>
-        </p:txBody>
-      </p:sp>
-      <p:sp>
-        <p:nvSpPr>
-          <p:cNvPr id="17" name="Text 15"/>
-          <p:cNvSpPr/>
-          <p:nvPr/>
-        </p:nvSpPr>
-        <p:spPr>
-          <a:xfrm>
-            <a:off x="6393028" y="2880360"/>
-            <a:ext cx="2236394" cy="2834640"/>
-          </a:xfrm>
-          <a:prstGeom prst="rect">
-            <a:avLst/>
-          </a:prstGeom>
-          <a:noFill/>
-          <a:ln/>
-        </p:spPr>
-        <p:txBody>
-          <a:bodyPr wrap="square" lIns="0" tIns="0" rIns="0" bIns="0" rtlCol="0" anchor="ctr"/>
-          <a:lstStyle/>
-          <a:p>
-            <a:pPr marL="342900" indent="-342900">
-              <a:spcAft>
-                <a:spcPts val="600"/>
-              </a:spcAft>
-              <a:buSzPct val="100000"/>
-              <a:buChar char="•"/>
-            </a:pPr>
-            <a:r>
-              <a:rPr lang="en-US" sz="980" dirty="0">
+              <a:rPr lang="en-US" sz="930" dirty="0">
                 <a:solidFill>
                   <a:srgbClr val="1B2440"/>
                 </a:solidFill>
@@ -6971,93 +6975,30 @@
                 <a:ea typeface="Calibri" pitchFamily="34" charset="-122"/>
                 <a:cs typeface="Calibri" pitchFamily="34" charset="-120"/>
               </a:rPr>
-              <a:t>Spec-package tooling hardened; Tier-0 standing approvals in force</a:t>
-            </a:r>
-            <a:endParaRPr lang="en-US" sz="980" dirty="0"/>
-          </a:p>
-          <a:p>
-            <a:pPr marL="342900" indent="-342900">
-              <a:spcAft>
-                <a:spcPts val="600"/>
-              </a:spcAft>
-              <a:buSzPct val="100000"/>
-              <a:buChar char="•"/>
-            </a:pPr>
-            <a:r>
-              <a:rPr lang="en-US" sz="980" dirty="0">
-                <a:solidFill>
-                  <a:srgbClr val="1B2440"/>
-                </a:solidFill>
-                <a:latin typeface="Calibri" pitchFamily="34" charset="0"/>
-                <a:ea typeface="Calibri" pitchFamily="34" charset="-122"/>
-                <a:cs typeface="Calibri" pitchFamily="34" charset="-120"/>
-              </a:rPr>
-              <a:t>Angular inventory complete; migration factory running per-feature</a:t>
-            </a:r>
-            <a:endParaRPr lang="en-US" sz="980" dirty="0"/>
-          </a:p>
-          <a:p>
-            <a:pPr marL="342900" indent="-342900">
-              <a:spcAft>
-                <a:spcPts val="600"/>
-              </a:spcAft>
-              <a:buSzPct val="100000"/>
-              <a:buChar char="•"/>
-            </a:pPr>
-            <a:r>
-              <a:rPr lang="en-US" sz="980" dirty="0">
-                <a:solidFill>
-                  <a:srgbClr val="1B2440"/>
-                </a:solidFill>
-                <a:latin typeface="Calibri" pitchFamily="34" charset="0"/>
-                <a:ea typeface="Calibri" pitchFamily="34" charset="-122"/>
-                <a:cs typeface="Calibri" pitchFamily="34" charset="-120"/>
-              </a:rPr>
-              <a:t>Sensitizer = logic-pack compiler + validators, fully inside</a:t>
-            </a:r>
-            <a:endParaRPr lang="en-US" sz="980" dirty="0"/>
-          </a:p>
-          <a:p>
-            <a:pPr marL="342900" indent="-342900">
-              <a:spcAft>
-                <a:spcPts val="600"/>
-              </a:spcAft>
-              <a:buSzPct val="100000"/>
-              <a:buChar char="•"/>
-            </a:pPr>
-            <a:r>
-              <a:rPr lang="en-US" sz="980" dirty="0">
-                <a:solidFill>
-                  <a:srgbClr val="1B2440"/>
-                </a:solidFill>
-                <a:latin typeface="Calibri" pitchFamily="34" charset="0"/>
-                <a:ea typeface="Calibri" pitchFamily="34" charset="-122"/>
-                <a:cs typeface="Calibri" pitchFamily="34" charset="-120"/>
-              </a:rPr>
-              <a:t>Exit: egress SLA met 90%+; zero security incidents; parity scoreboard trending to done</a:t>
-            </a:r>
-            <a:endParaRPr lang="en-US" sz="980" dirty="0"/>
-          </a:p>
-        </p:txBody>
-      </p:sp>
-      <p:sp>
-        <p:nvSpPr>
-          <p:cNvPr id="18" name="Shape 16"/>
-          <p:cNvSpPr/>
-          <p:nvPr/>
-        </p:nvSpPr>
-        <p:spPr>
-          <a:xfrm>
-            <a:off x="9040901" y="1691640"/>
-            <a:ext cx="2602154" cy="4206240"/>
+              <a:t>The legacy app needs bugfixes and changes for 1–3 more years — unmanaged, it re-absorbs the core team. Strangler policy per feature at inventory: frozen / sustained (a real contractor role) / in-migration (Angular side feature-frozen once the contract egresses). Swap route-by-route via SSPA.</a:t>
+            </a:r>
+            <a:endParaRPr lang="en-US" sz="930" dirty="0"/>
+          </a:p>
+        </p:txBody>
+      </p:sp>
+      <p:sp>
+        <p:nvSpPr>
+          <p:cNvPr id="21" name="Shape 16"/>
+          <p:cNvSpPr/>
+          <p:nvPr/>
+        </p:nvSpPr>
+        <p:spPr>
+          <a:xfrm>
+            <a:off x="548640" y="3858768"/>
+            <a:ext cx="3527450" cy="2139696"/>
           </a:xfrm>
           <a:prstGeom prst="roundRect">
             <a:avLst>
-              <a:gd name="adj" fmla="val 2811"/>
+              <a:gd name="adj" fmla="val 3419"/>
             </a:avLst>
           </a:prstGeom>
           <a:solidFill>
-            <a:srgbClr val="EAF4EF"/>
+            <a:srgbClr val="EDF3FC"/>
           </a:solidFill>
           <a:ln/>
           <a:effectLst>
@@ -7071,14 +7012,58 @@
       </p:sp>
       <p:sp>
         <p:nvSpPr>
-          <p:cNvPr id="19" name="Text 17"/>
-          <p:cNvSpPr/>
-          <p:nvPr/>
-        </p:nvSpPr>
-        <p:spPr>
-          <a:xfrm>
-            <a:off x="9223781" y="1828800"/>
-            <a:ext cx="2236394" cy="274320"/>
+          <p:cNvPr id="22" name="Shape 17"/>
+          <p:cNvSpPr/>
+          <p:nvPr/>
+        </p:nvSpPr>
+        <p:spPr>
+          <a:xfrm>
+            <a:off x="731520" y="4023360"/>
+            <a:ext cx="457200" cy="457200"/>
+          </a:xfrm>
+          <a:prstGeom prst="ellipse">
+            <a:avLst/>
+          </a:prstGeom>
+          <a:solidFill>
+            <a:srgbClr val="1E2761"/>
+          </a:solidFill>
+          <a:ln/>
+        </p:spPr>
+      </p:sp>
+      <p:pic>
+        <p:nvPicPr>
+          <p:cNvPr id="23" name="Image 3" descr="preencoded.png">    </p:cNvPr>
+          <p:cNvPicPr>
+            <a:picLocks noChangeAspect="1"/>
+          </p:cNvPicPr>
+          <p:nvPr/>
+        </p:nvPicPr>
+        <p:blipFill>
+          <a:blip r:embed="rId4"/>
+          <a:stretch>
+            <a:fillRect/>
+          </a:stretch>
+        </p:blipFill>
+        <p:spPr>
+          <a:xfrm>
+            <a:off x="850392" y="4142232"/>
+            <a:ext cx="219456" cy="219456"/>
+          </a:xfrm>
+          <a:prstGeom prst="rect">
+            <a:avLst/>
+          </a:prstGeom>
+        </p:spPr>
+      </p:pic>
+      <p:sp>
+        <p:nvSpPr>
+          <p:cNvPr id="24" name="Text 18"/>
+          <p:cNvSpPr/>
+          <p:nvPr/>
+        </p:nvSpPr>
+        <p:spPr>
+          <a:xfrm>
+            <a:off x="1298448" y="4059936"/>
+            <a:ext cx="2658770" cy="384048"/>
           </a:xfrm>
           <a:prstGeom prst="rect">
             <a:avLst/>
@@ -7094,30 +7079,30 @@
               <a:buNone/>
             </a:pPr>
             <a:r>
-              <a:rPr lang="en-US" sz="1100" b="1" spc="200" kern="0" dirty="0">
-                <a:solidFill>
-                  <a:srgbClr val="2E7D5B"/>
-                </a:solidFill>
-                <a:latin typeface="Calibri" pitchFamily="34" charset="0"/>
-                <a:ea typeface="Calibri" pitchFamily="34" charset="-122"/>
-                <a:cs typeface="Calibri" pitchFamily="34" charset="-120"/>
-              </a:rPr>
-              <a:t>PHASE 3</a:t>
-            </a:r>
-            <a:endParaRPr lang="en-US" sz="1100" dirty="0"/>
-          </a:p>
-        </p:txBody>
-      </p:sp>
-      <p:sp>
-        <p:nvSpPr>
-          <p:cNvPr id="20" name="Text 18"/>
-          <p:cNvSpPr/>
-          <p:nvPr/>
-        </p:nvSpPr>
-        <p:spPr>
-          <a:xfrm>
-            <a:off x="9223781" y="2103120"/>
-            <a:ext cx="2236394" cy="685800"/>
+              <a:rPr lang="en-US" sz="1300" b="1" dirty="0">
+                <a:solidFill>
+                  <a:srgbClr val="1E2761"/>
+                </a:solidFill>
+                <a:latin typeface="Calibri" pitchFamily="34" charset="0"/>
+                <a:ea typeface="Calibri" pitchFamily="34" charset="-122"/>
+                <a:cs typeface="Calibri" pitchFamily="34" charset="-120"/>
+              </a:rPr>
+              <a:t>Mapping at team scale</a:t>
+            </a:r>
+            <a:endParaRPr lang="en-US" sz="1300" dirty="0"/>
+          </a:p>
+        </p:txBody>
+      </p:sp>
+      <p:sp>
+        <p:nvSpPr>
+          <p:cNvPr id="25" name="Text 19"/>
+          <p:cNvSpPr/>
+          <p:nvPr/>
+        </p:nvSpPr>
+        <p:spPr>
+          <a:xfrm>
+            <a:off x="749808" y="4517136"/>
+            <a:ext cx="3125114" cy="1335024"/>
           </a:xfrm>
           <a:prstGeom prst="rect">
             <a:avLst/>
@@ -7133,7 +7118,119 @@
               <a:buNone/>
             </a:pPr>
             <a:r>
-              <a:rPr lang="en-US" sz="1350" b="1" dirty="0">
+              <a:rPr lang="en-US" sz="930" dirty="0">
+                <a:solidFill>
+                  <a:srgbClr val="1B2440"/>
+                </a:solidFill>
+                <a:latin typeface="Calibri" pitchFamily="34" charset="0"/>
+                <a:ea typeface="Calibri" pitchFamily="34" charset="-122"/>
+                <a:cs typeface="Calibri" pitchFamily="34" charset="-120"/>
+              </a:rPr>
+              <a:t>Per-extraction artisanal mappings will collide (two features → “Item”) and contradict, silently corrupting reversals. Build ONE governed mapping registry inside: owner, versioned superset, blocking collision checks, every egress pinned to a registry version.</a:t>
+            </a:r>
+            <a:endParaRPr lang="en-US" sz="930" dirty="0"/>
+          </a:p>
+        </p:txBody>
+      </p:sp>
+      <p:sp>
+        <p:nvSpPr>
+          <p:cNvPr id="26" name="Shape 20"/>
+          <p:cNvSpPr/>
+          <p:nvPr/>
+        </p:nvSpPr>
+        <p:spPr>
+          <a:xfrm>
+            <a:off x="4332122" y="3858768"/>
+            <a:ext cx="3527450" cy="2139696"/>
+          </a:xfrm>
+          <a:prstGeom prst="roundRect">
+            <a:avLst>
+              <a:gd name="adj" fmla="val 3419"/>
+            </a:avLst>
+          </a:prstGeom>
+          <a:solidFill>
+            <a:srgbClr val="EDF3FC"/>
+          </a:solidFill>
+          <a:ln/>
+          <a:effectLst>
+            <a:outerShdw sx="100000" sy="100000" kx="0" ky="0" algn="bl" rotWithShape="0" blurRad="76200" dist="12700" dir="5400000">
+              <a:srgbClr val="9AA7C4">
+                <a:alpha val="25000"/>
+              </a:srgbClr>
+            </a:outerShdw>
+          </a:effectLst>
+        </p:spPr>
+      </p:sp>
+      <p:sp>
+        <p:nvSpPr>
+          <p:cNvPr id="27" name="Shape 21"/>
+          <p:cNvSpPr/>
+          <p:nvPr/>
+        </p:nvSpPr>
+        <p:spPr>
+          <a:xfrm>
+            <a:off x="4515002" y="4023360"/>
+            <a:ext cx="457200" cy="457200"/>
+          </a:xfrm>
+          <a:prstGeom prst="ellipse">
+            <a:avLst/>
+          </a:prstGeom>
+          <a:solidFill>
+            <a:srgbClr val="1E2761"/>
+          </a:solidFill>
+          <a:ln/>
+        </p:spPr>
+      </p:sp>
+      <p:pic>
+        <p:nvPicPr>
+          <p:cNvPr id="28" name="Image 4" descr="preencoded.png">    </p:cNvPr>
+          <p:cNvPicPr>
+            <a:picLocks noChangeAspect="1"/>
+          </p:cNvPicPr>
+          <p:nvPr/>
+        </p:nvPicPr>
+        <p:blipFill>
+          <a:blip r:embed="rId5"/>
+          <a:stretch>
+            <a:fillRect/>
+          </a:stretch>
+        </p:blipFill>
+        <p:spPr>
+          <a:xfrm>
+            <a:off x="4633874" y="4142232"/>
+            <a:ext cx="219456" cy="219456"/>
+          </a:xfrm>
+          <a:prstGeom prst="rect">
+            <a:avLst/>
+          </a:prstGeom>
+        </p:spPr>
+      </p:pic>
+      <p:sp>
+        <p:nvSpPr>
+          <p:cNvPr id="29" name="Text 22"/>
+          <p:cNvSpPr/>
+          <p:nvPr/>
+        </p:nvSpPr>
+        <p:spPr>
+          <a:xfrm>
+            <a:off x="5081930" y="4059936"/>
+            <a:ext cx="2658770" cy="384048"/>
+          </a:xfrm>
+          <a:prstGeom prst="rect">
+            <a:avLst/>
+          </a:prstGeom>
+          <a:noFill/>
+          <a:ln/>
+        </p:spPr>
+        <p:txBody>
+          <a:bodyPr wrap="square" lIns="0" tIns="0" rIns="0" bIns="0" rtlCol="0" anchor="ctr"/>
+          <a:lstStyle/>
+          <a:p>
+            <a:pPr indent="0" marL="0">
+              <a:buNone/>
+            </a:pPr>
+            <a:r>
+              <a:rPr lang="en-US" sz="1300" b="1" dirty="0">
                 <a:solidFill>
                   <a:srgbClr val="1E2761"/>
                 </a:solidFill>
@@ -7141,16 +7238,150 @@
                 <a:ea typeface="Calibri" pitchFamily="34" charset="-122"/>
                 <a:cs typeface="Calibri" pitchFamily="34" charset="-120"/>
               </a:rPr>
-              <a:t>Core-team absorption</a:t>
-            </a:r>
-            <a:endParaRPr lang="en-US" sz="1350" dirty="0"/>
-          </a:p>
+              <a:t>Paradigm bus factor = 2</a:t>
+            </a:r>
+            <a:endParaRPr lang="en-US" sz="1300" dirty="0"/>
+          </a:p>
+        </p:txBody>
+      </p:sp>
+      <p:sp>
+        <p:nvSpPr>
+          <p:cNvPr id="30" name="Text 23"/>
+          <p:cNvSpPr/>
+          <p:nvPr/>
+        </p:nvSpPr>
+        <p:spPr>
+          <a:xfrm>
+            <a:off x="4533290" y="4517136"/>
+            <a:ext cx="3125114" cy="1335024"/>
+          </a:xfrm>
+          <a:prstGeom prst="rect">
+            <a:avLst/>
+          </a:prstGeom>
+          <a:noFill/>
+          <a:ln/>
+        </p:spPr>
+        <p:txBody>
+          <a:bodyPr wrap="square" lIns="0" tIns="0" rIns="0" bIns="0" rtlCol="0" anchor="ctr"/>
+          <a:lstStyle/>
           <a:p>
             <a:pPr indent="0" marL="0">
               <a:buNone/>
             </a:pPr>
             <a:r>
-              <a:rPr lang="en-US" sz="1350" b="1" dirty="0">
+              <a:rPr lang="en-US" sz="930" dirty="0">
+                <a:solidFill>
+                  <a:srgbClr val="1B2440"/>
+                </a:solidFill>
+                <a:latin typeface="Calibri" pitchFamily="34" charset="0"/>
+                <a:ea typeface="Calibri" pitchFamily="34" charset="-122"/>
+                <a:cs typeface="Calibri" pitchFamily="34" charset="-120"/>
+              </a:rPr>
+              <a:t>The workflow lives in two heads while we carefully de-risk contractor knowledge — the irony. Phase 1 exit criterion: gates written into accredited security SOPs, runbooks for every step, and someone outside the founding pair runs a full loop solo.</a:t>
+            </a:r>
+            <a:endParaRPr lang="en-US" sz="930" dirty="0"/>
+          </a:p>
+        </p:txBody>
+      </p:sp>
+      <p:sp>
+        <p:nvSpPr>
+          <p:cNvPr id="31" name="Shape 24"/>
+          <p:cNvSpPr/>
+          <p:nvPr/>
+        </p:nvSpPr>
+        <p:spPr>
+          <a:xfrm>
+            <a:off x="8115605" y="3858768"/>
+            <a:ext cx="3527450" cy="2139696"/>
+          </a:xfrm>
+          <a:prstGeom prst="roundRect">
+            <a:avLst>
+              <a:gd name="adj" fmla="val 3419"/>
+            </a:avLst>
+          </a:prstGeom>
+          <a:solidFill>
+            <a:srgbClr val="EDF3FC"/>
+          </a:solidFill>
+          <a:ln/>
+          <a:effectLst>
+            <a:outerShdw sx="100000" sy="100000" kx="0" ky="0" algn="bl" rotWithShape="0" blurRad="76200" dist="12700" dir="5400000">
+              <a:srgbClr val="9AA7C4">
+                <a:alpha val="25000"/>
+              </a:srgbClr>
+            </a:outerShdw>
+          </a:effectLst>
+        </p:spPr>
+      </p:sp>
+      <p:sp>
+        <p:nvSpPr>
+          <p:cNvPr id="32" name="Shape 25"/>
+          <p:cNvSpPr/>
+          <p:nvPr/>
+        </p:nvSpPr>
+        <p:spPr>
+          <a:xfrm>
+            <a:off x="8298485" y="4023360"/>
+            <a:ext cx="457200" cy="457200"/>
+          </a:xfrm>
+          <a:prstGeom prst="ellipse">
+            <a:avLst/>
+          </a:prstGeom>
+          <a:solidFill>
+            <a:srgbClr val="1E2761"/>
+          </a:solidFill>
+          <a:ln/>
+        </p:spPr>
+      </p:sp>
+      <p:pic>
+        <p:nvPicPr>
+          <p:cNvPr id="33" name="Image 5" descr="preencoded.png">    </p:cNvPr>
+          <p:cNvPicPr>
+            <a:picLocks noChangeAspect="1"/>
+          </p:cNvPicPr>
+          <p:nvPr/>
+        </p:nvPicPr>
+        <p:blipFill>
+          <a:blip r:embed="rId6"/>
+          <a:stretch>
+            <a:fillRect/>
+          </a:stretch>
+        </p:blipFill>
+        <p:spPr>
+          <a:xfrm>
+            <a:off x="8417357" y="4142232"/>
+            <a:ext cx="219456" cy="219456"/>
+          </a:xfrm>
+          <a:prstGeom prst="rect">
+            <a:avLst/>
+          </a:prstGeom>
+        </p:spPr>
+      </p:pic>
+      <p:sp>
+        <p:nvSpPr>
+          <p:cNvPr id="34" name="Text 26"/>
+          <p:cNvSpPr/>
+          <p:nvPr/>
+        </p:nvSpPr>
+        <p:spPr>
+          <a:xfrm>
+            <a:off x="8865413" y="4059936"/>
+            <a:ext cx="2658770" cy="384048"/>
+          </a:xfrm>
+          <a:prstGeom prst="rect">
+            <a:avLst/>
+          </a:prstGeom>
+          <a:noFill/>
+          <a:ln/>
+        </p:spPr>
+        <p:txBody>
+          <a:bodyPr wrap="square" lIns="0" tIns="0" rIns="0" bIns="0" rtlCol="0" anchor="ctr"/>
+          <a:lstStyle/>
+          <a:p>
+            <a:pPr indent="0" marL="0">
+              <a:buNone/>
+            </a:pPr>
+            <a:r>
+              <a:rPr lang="en-US" sz="1300" b="1" dirty="0">
                 <a:solidFill>
                   <a:srgbClr val="1E2761"/>
                 </a:solidFill>
@@ -7158,42 +7389,38 @@
                 <a:ea typeface="Calibri" pitchFamily="34" charset="-122"/>
                 <a:cs typeface="Calibri" pitchFamily="34" charset="-120"/>
               </a:rPr>
-              <a:t>(trigger-based)</a:t>
-            </a:r>
-            <a:endParaRPr lang="en-US" sz="1350" dirty="0"/>
-          </a:p>
-        </p:txBody>
-      </p:sp>
-      <p:sp>
-        <p:nvSpPr>
-          <p:cNvPr id="21" name="Text 19"/>
-          <p:cNvSpPr/>
-          <p:nvPr/>
-        </p:nvSpPr>
-        <p:spPr>
-          <a:xfrm>
-            <a:off x="9223781" y="2880360"/>
-            <a:ext cx="2236394" cy="2834640"/>
-          </a:xfrm>
-          <a:prstGeom prst="rect">
-            <a:avLst/>
-          </a:prstGeom>
-          <a:noFill/>
-          <a:ln/>
-        </p:spPr>
-        <p:txBody>
-          <a:bodyPr wrap="square" lIns="0" tIns="0" rIns="0" bIns="0" rtlCol="0" anchor="ctr"/>
-          <a:lstStyle/>
-          <a:p>
-            <a:pPr marL="342900" indent="-342900">
-              <a:spcAft>
-                <a:spcPts val="600"/>
-              </a:spcAft>
-              <a:buSzPct val="100000"/>
-              <a:buChar char="•"/>
-            </a:pPr>
-            <a:r>
-              <a:rPr lang="en-US" sz="980" dirty="0">
+              <a:t>Fiction ≠ reality coverage</a:t>
+            </a:r>
+            <a:endParaRPr lang="en-US" sz="1300" dirty="0"/>
+          </a:p>
+        </p:txBody>
+      </p:sp>
+      <p:sp>
+        <p:nvSpPr>
+          <p:cNvPr id="35" name="Text 27"/>
+          <p:cNvSpPr/>
+          <p:nvPr/>
+        </p:nvSpPr>
+        <p:spPr>
+          <a:xfrm>
+            <a:off x="8316773" y="4517136"/>
+            <a:ext cx="3125114" cy="1335024"/>
+          </a:xfrm>
+          <a:prstGeom prst="rect">
+            <a:avLst/>
+          </a:prstGeom>
+          <a:noFill/>
+          <a:ln/>
+        </p:spPr>
+        <p:txBody>
+          <a:bodyPr wrap="square" lIns="0" tIns="0" rIns="0" bIns="0" rtlCol="0" anchor="ctr"/>
+          <a:lstStyle/>
+          <a:p>
+            <a:pPr indent="0" marL="0">
+              <a:buNone/>
+            </a:pPr>
+            <a:r>
+              <a:rPr lang="en-US" sz="930" dirty="0">
                 <a:solidFill>
                   <a:srgbClr val="1B2440"/>
                 </a:solidFill>
@@ -7201,85 +7428,22 @@
                 <a:ea typeface="Calibri" pitchFamily="34" charset="-122"/>
                 <a:cs typeface="Calibri" pitchFamily="34" charset="-120"/>
               </a:rPr>
-              <a:t>Trigger: contractor reduction mandate — readiness is built in Phases 1–2, not when the memo lands</a:t>
-            </a:r>
-            <a:endParaRPr lang="en-US" sz="980" dirty="0"/>
-          </a:p>
-          <a:p>
-            <a:pPr marL="342900" indent="-342900">
-              <a:spcAft>
-                <a:spcPts val="600"/>
-              </a:spcAft>
-              <a:buSzPct val="100000"/>
-              <a:buChar char="•"/>
-            </a:pPr>
-            <a:r>
-              <a:rPr lang="en-US" sz="980" dirty="0">
-                <a:solidFill>
-                  <a:srgbClr val="1B2440"/>
-                </a:solidFill>
-                <a:latin typeface="Calibri" pitchFamily="34" charset="0"/>
-                <a:ea typeface="Calibri" pitchFamily="34" charset="-122"/>
-                <a:cs typeface="Calibri" pitchFamily="34" charset="-120"/>
-              </a:rPr>
-              <a:t>Every contractor duty has a documented runbook + a core-team owner who has already done it (rotation in Phase 2)</a:t>
-            </a:r>
-            <a:endParaRPr lang="en-US" sz="980" dirty="0"/>
-          </a:p>
-          <a:p>
-            <a:pPr marL="342900" indent="-342900">
-              <a:spcAft>
-                <a:spcPts val="600"/>
-              </a:spcAft>
-              <a:buSzPct val="100000"/>
-              <a:buChar char="•"/>
-            </a:pPr>
-            <a:r>
-              <a:rPr lang="en-US" sz="980" dirty="0">
-                <a:solidFill>
-                  <a:srgbClr val="1B2440"/>
-                </a:solidFill>
-                <a:latin typeface="Calibri" pitchFamily="34" charset="0"/>
-                <a:ea typeface="Calibri" pitchFamily="34" charset="-122"/>
-                <a:cs typeface="Calibri" pitchFamily="34" charset="-120"/>
-              </a:rPr>
-              <a:t>Automate the residue: integration scripts, mapping validators, config lint</a:t>
-            </a:r>
-            <a:endParaRPr lang="en-US" sz="980" dirty="0"/>
-          </a:p>
-          <a:p>
-            <a:pPr marL="342900" indent="-342900">
-              <a:spcAft>
-                <a:spcPts val="600"/>
-              </a:spcAft>
-              <a:buSzPct val="100000"/>
-              <a:buChar char="•"/>
-            </a:pPr>
-            <a:r>
-              <a:rPr lang="en-US" sz="980" dirty="0">
-                <a:solidFill>
-                  <a:srgbClr val="1B2440"/>
-                </a:solidFill>
-                <a:latin typeface="Calibri" pitchFamily="34" charset="0"/>
-                <a:ea typeface="Calibri" pitchFamily="34" charset="-122"/>
-                <a:cs typeface="Calibri" pitchFamily="34" charset="-120"/>
-              </a:rPr>
-              <a:t>Exit: full loop runs with core team only, one release proven</a:t>
-            </a:r>
-            <a:endParaRPr lang="en-US" sz="980" dirty="0"/>
-          </a:p>
-        </p:txBody>
-      </p:sp>
-      <p:sp>
-        <p:nvSpPr>
-          <p:cNvPr id="22" name="Text 20"/>
-          <p:cNvSpPr/>
-          <p:nvPr/>
-        </p:nvSpPr>
-        <p:spPr>
-          <a:xfrm>
-            <a:off x="548640" y="6035040"/>
-            <a:ext cx="11094415" cy="411480"/>
+              <a:t>Playwright-green outside proves the FICTIONAL pack's branches, not the real ones. Require pack equivalence: same rule count, branch shapes, boundary classes — different values; generate both skeletons from one inside source; audit branch coverage inside on early integrations.</a:t>
+            </a:r>
+            <a:endParaRPr lang="en-US" sz="930" dirty="0"/>
+          </a:p>
+        </p:txBody>
+      </p:sp>
+      <p:sp>
+        <p:nvSpPr>
+          <p:cNvPr id="36" name="Text 28"/>
+          <p:cNvSpPr/>
+          <p:nvPr/>
+        </p:nvSpPr>
+        <p:spPr>
+          <a:xfrm>
+            <a:off x="548640" y="6199632"/>
+            <a:ext cx="11094415" cy="320040"/>
           </a:xfrm>
           <a:prstGeom prst="rect">
             <a:avLst/>
@@ -7295,31 +7459,17 @@
               <a:buNone/>
             </a:pPr>
             <a:r>
-              <a:rPr lang="en-US" sz="1250" b="1" dirty="0">
-                <a:solidFill>
-                  <a:srgbClr val="1E2761"/>
-                </a:solidFill>
-                <a:latin typeface="Calibri" pitchFamily="34" charset="0"/>
-                <a:ea typeface="Calibri" pitchFamily="34" charset="-122"/>
-                <a:cs typeface="Calibri" pitchFamily="34" charset="-120"/>
-              </a:rPr>
-              <a:t>Honest expectation: </a:t>
-            </a:r>
-            <a:pPr algn="ctr" indent="0" marL="0">
-              <a:buNone/>
-            </a:pPr>
-            <a:r>
-              <a:rPr lang="en-US" sz="1250" dirty="0">
-                <a:solidFill>
-                  <a:srgbClr val="1B2440"/>
-                </a:solidFill>
-                <a:latin typeface="Calibri" pitchFamily="34" charset="0"/>
-                <a:ea typeface="Calibri" pitchFamily="34" charset="-122"/>
-                <a:cs typeface="Calibri" pitchFamily="34" charset="-120"/>
-              </a:rPr>
-              <a:t>the first loop will be slower than today — you are building the factory while running it. Speed compounds from MFE #3 onward. Say this out loud on day one, or month 3 will be read as failure.</a:t>
-            </a:r>
-            <a:endParaRPr lang="en-US" sz="1250" dirty="0"/>
+              <a:rPr lang="en-US" sz="1200" i="1" dirty="0">
+                <a:solidFill>
+                  <a:srgbClr val="5A6B8C"/>
+                </a:solidFill>
+                <a:latin typeface="Calibri" pitchFamily="34" charset="0"/>
+                <a:ea typeface="Calibri" pitchFamily="34" charset="-122"/>
+                <a:cs typeface="Calibri" pitchFamily="34" charset="-120"/>
+              </a:rPr>
+              <a:t>Outbound gates protect the mission; inbound gates protect the network. Both directions, or neither is credible.</a:t>
+            </a:r>
+            <a:endParaRPr lang="en-US" sz="1200" dirty="0"/>
           </a:p>
         </p:txBody>
       </p:sp>
@@ -7466,7 +7616,7 @@
                 <a:ea typeface="Calibri" pitchFamily="34" charset="-122"/>
                 <a:cs typeface="Calibri" pitchFamily="34" charset="-120"/>
               </a:rPr>
-              <a:t>MEASURING IT · THE COUNTER-NARRATIVE</a:t>
+              <a:t>SECOND LOOK · UPSIDE NOT YET CLAIMED</a:t>
             </a:r>
             <a:endParaRPr lang="en-US" sz="1200" dirty="0"/>
           </a:p>
@@ -7505,7 +7655,7 @@
                 <a:ea typeface="Cambria" pitchFamily="34" charset="-122"/>
                 <a:cs typeface="Cambria" pitchFamily="34" charset="-120"/>
               </a:rPr>
-              <a:t>The scoreboard that wins the argument</a:t>
+              <a:t>Four opportunities on the table</a:t>
             </a:r>
             <a:endParaRPr lang="en-US" sz="3000" dirty="0"/>
           </a:p>
@@ -7519,16 +7669,16 @@
         </p:nvSpPr>
         <p:spPr>
           <a:xfrm>
-            <a:off x="548640" y="1691640"/>
-            <a:ext cx="3515258" cy="2011680"/>
+            <a:off x="548640" y="1627632"/>
+            <a:ext cx="5400904" cy="2121408"/>
           </a:xfrm>
           <a:prstGeom prst="roundRect">
             <a:avLst>
-              <a:gd name="adj" fmla="val 3636"/>
+              <a:gd name="adj" fmla="val 3448"/>
             </a:avLst>
           </a:prstGeom>
           <a:solidFill>
-            <a:srgbClr val="EDF3FC"/>
+            <a:srgbClr val="EAF4EF"/>
           </a:solidFill>
           <a:ln/>
           <a:effectLst>
@@ -7548,14 +7698,14 @@
         </p:nvSpPr>
         <p:spPr>
           <a:xfrm>
-            <a:off x="749808" y="1892808"/>
-            <a:ext cx="502920" cy="502920"/>
+            <a:off x="749808" y="1810512"/>
+            <a:ext cx="475488" cy="475488"/>
           </a:xfrm>
           <a:prstGeom prst="ellipse">
             <a:avLst/>
           </a:prstGeom>
           <a:solidFill>
-            <a:srgbClr val="1E2761"/>
+            <a:srgbClr val="2E7D5B"/>
           </a:solidFill>
           <a:ln/>
         </p:spPr>
@@ -7576,8 +7726,8 @@
         </p:blipFill>
         <p:spPr>
           <a:xfrm>
-            <a:off x="880567" y="2023567"/>
-            <a:ext cx="241402" cy="241402"/>
+            <a:off x="873435" y="1934139"/>
+            <a:ext cx="228234" cy="228234"/>
           </a:xfrm>
           <a:prstGeom prst="rect">
             <a:avLst/>
@@ -7592,8 +7742,8 @@
         </p:nvSpPr>
         <p:spPr>
           <a:xfrm>
-            <a:off x="1389888" y="1947672"/>
-            <a:ext cx="2509418" cy="384048"/>
+            <a:off x="1353312" y="1856232"/>
+            <a:ext cx="4440784" cy="365760"/>
           </a:xfrm>
           <a:prstGeom prst="rect">
             <a:avLst/>
@@ -7611,13 +7761,13 @@
             <a:r>
               <a:rPr lang="en-US" sz="1450" b="1" dirty="0">
                 <a:solidFill>
-                  <a:srgbClr val="1E2761"/>
-                </a:solidFill>
-                <a:latin typeface="Calibri" pitchFamily="34" charset="0"/>
-                <a:ea typeface="Calibri" pitchFamily="34" charset="-122"/>
-                <a:cs typeface="Calibri" pitchFamily="34" charset="-120"/>
-              </a:rPr>
-              <a:t>Lead time</a:t>
+                  <a:srgbClr val="2E7D5B"/>
+                </a:solidFill>
+                <a:latin typeface="Calibri" pitchFamily="34" charset="0"/>
+                <a:ea typeface="Calibri" pitchFamily="34" charset="-122"/>
+                <a:cs typeface="Calibri" pitchFamily="34" charset="-120"/>
+              </a:rPr>
+              <a:t>Absorb the vibe-coders</a:t>
             </a:r>
             <a:endParaRPr lang="en-US" sz="1450" dirty="0"/>
           </a:p>
@@ -7631,8 +7781,8 @@
         </p:nvSpPr>
         <p:spPr>
           <a:xfrm>
-            <a:off x="777240" y="2468880"/>
-            <a:ext cx="3058058" cy="1051560"/>
+            <a:off x="777240" y="2313432"/>
+            <a:ext cx="4943704" cy="1252728"/>
           </a:xfrm>
           <a:prstGeom prst="rect">
             <a:avLst/>
@@ -7648,7 +7798,7 @@
               <a:buNone/>
             </a:pPr>
             <a:r>
-              <a:rPr lang="en-US" sz="1100" dirty="0">
+              <a:rPr lang="en-US" sz="1060" dirty="0">
                 <a:solidFill>
                   <a:srgbClr val="1B2440"/>
                 </a:solidFill>
@@ -7656,9 +7806,9 @@
                 <a:ea typeface="Calibri" pitchFamily="34" charset="-122"/>
                 <a:cs typeface="Calibri" pitchFamily="34" charset="-120"/>
               </a:rPr>
-              <a:t>Spec-frozen → running in Confi, per feature. The headline number stakeholders compare against “days”. Target: weeks, trending down every quarter.</a:t>
-            </a:r>
-            <a:endParaRPr lang="en-US" sz="1100" dirty="0"/>
+              <a:t>Don't race the GenAI user teams — give them a lane inside the paradigm. Hand them the LTC sandbox, world bible, and mock scaffold; their prototypes become Tier-1 spec inputs flowing through our gate. The loudest political threat becomes the requirements pipeline, and stakeholders see one program, not a rivalry.</a:t>
+            </a:r>
+            <a:endParaRPr lang="en-US" sz="1060" dirty="0"/>
           </a:p>
         </p:txBody>
       </p:sp>
@@ -7670,16 +7820,16 @@
         </p:nvSpPr>
         <p:spPr>
           <a:xfrm>
-            <a:off x="4338218" y="1691640"/>
-            <a:ext cx="3515258" cy="2011680"/>
+            <a:off x="6242152" y="1627632"/>
+            <a:ext cx="5400904" cy="2121408"/>
           </a:xfrm>
           <a:prstGeom prst="roundRect">
             <a:avLst>
-              <a:gd name="adj" fmla="val 3636"/>
+              <a:gd name="adj" fmla="val 3448"/>
             </a:avLst>
           </a:prstGeom>
           <a:solidFill>
-            <a:srgbClr val="EDF3FC"/>
+            <a:srgbClr val="EAF4EF"/>
           </a:solidFill>
           <a:ln/>
           <a:effectLst>
@@ -7699,14 +7849,14 @@
         </p:nvSpPr>
         <p:spPr>
           <a:xfrm>
-            <a:off x="4539386" y="1892808"/>
-            <a:ext cx="502920" cy="502920"/>
+            <a:off x="6443320" y="1810512"/>
+            <a:ext cx="475488" cy="475488"/>
           </a:xfrm>
           <a:prstGeom prst="ellipse">
             <a:avLst/>
           </a:prstGeom>
           <a:solidFill>
-            <a:srgbClr val="1E2761"/>
+            <a:srgbClr val="2E7D5B"/>
           </a:solidFill>
           <a:ln/>
         </p:spPr>
@@ -7727,8 +7877,8 @@
         </p:blipFill>
         <p:spPr>
           <a:xfrm>
-            <a:off x="4670146" y="2023567"/>
-            <a:ext cx="241402" cy="241402"/>
+            <a:off x="6566946" y="1934139"/>
+            <a:ext cx="228234" cy="228234"/>
           </a:xfrm>
           <a:prstGeom prst="rect">
             <a:avLst/>
@@ -7743,8 +7893,8 @@
         </p:nvSpPr>
         <p:spPr>
           <a:xfrm>
-            <a:off x="5179466" y="1947672"/>
-            <a:ext cx="2509418" cy="384048"/>
+            <a:off x="7046824" y="1856232"/>
+            <a:ext cx="4440784" cy="365760"/>
           </a:xfrm>
           <a:prstGeom prst="rect">
             <a:avLst/>
@@ -7762,13 +7912,13 @@
             <a:r>
               <a:rPr lang="en-US" sz="1450" b="1" dirty="0">
                 <a:solidFill>
-                  <a:srgbClr val="1E2761"/>
-                </a:solidFill>
-                <a:latin typeface="Calibri" pitchFamily="34" charset="0"/>
-                <a:ea typeface="Calibri" pitchFamily="34" charset="-122"/>
-                <a:cs typeface="Calibri" pitchFamily="34" charset="-120"/>
-              </a:rPr>
-              <a:t>Integration tax</a:t>
+                  <a:srgbClr val="2E7D5B"/>
+                </a:solidFill>
+                <a:latin typeface="Calibri" pitchFamily="34" charset="0"/>
+                <a:ea typeface="Calibri" pitchFamily="34" charset="-122"/>
+                <a:cs typeface="Calibri" pitchFamily="34" charset="-120"/>
+              </a:rPr>
+              <a:t>Fix requirements with mocks</a:t>
             </a:r>
             <a:endParaRPr lang="en-US" sz="1450" dirty="0"/>
           </a:p>
@@ -7782,8 +7932,8 @@
         </p:nvSpPr>
         <p:spPr>
           <a:xfrm>
-            <a:off x="4566818" y="2468880"/>
-            <a:ext cx="3058058" cy="1051560"/>
+            <a:off x="6470752" y="2313432"/>
+            <a:ext cx="4943704" cy="1252728"/>
           </a:xfrm>
           <a:prstGeom prst="rect">
             <a:avLst/>
@@ -7799,7 +7949,7 @@
               <a:buNone/>
             </a:pPr>
             <a:r>
-              <a:rPr lang="en-US" sz="1100" dirty="0">
+              <a:rPr lang="en-US" sz="1060" dirty="0">
                 <a:solidFill>
                   <a:srgbClr val="1B2440"/>
                 </a:solidFill>
@@ -7807,9 +7957,9 @@
                 <a:ea typeface="Calibri" pitchFamily="34" charset="-122"/>
                 <a:cs typeface="Calibri" pitchFamily="34" charset="-120"/>
               </a:rPr>
-              <a:t>% of feature effort spent inside after the tag lands. The paradigm's core health metric. Target ≤ 15%; rising = spec/mock/pack drift.</a:t>
-            </a:r>
-            <a:endParaRPr lang="en-US" sz="1100" dirty="0"/>
+              <a:t>“Heavy requirements gathering” was a named root cause, and the plan only speeds up what happens after it. A running MSW-backed UI is a requirements instrument: clickable, realistic-data prototypes in front of users in week one — react to behavior, not documents. The legitimate version of exactly what the vibe-coders do.</a:t>
+            </a:r>
+            <a:endParaRPr lang="en-US" sz="1060" dirty="0"/>
           </a:p>
         </p:txBody>
       </p:sp>
@@ -7821,16 +7971,16 @@
         </p:nvSpPr>
         <p:spPr>
           <a:xfrm>
-            <a:off x="8127797" y="1691640"/>
-            <a:ext cx="3515258" cy="2011680"/>
+            <a:off x="548640" y="3913632"/>
+            <a:ext cx="5400904" cy="2121408"/>
           </a:xfrm>
           <a:prstGeom prst="roundRect">
             <a:avLst>
-              <a:gd name="adj" fmla="val 3636"/>
+              <a:gd name="adj" fmla="val 3448"/>
             </a:avLst>
           </a:prstGeom>
           <a:solidFill>
-            <a:srgbClr val="EDF3FC"/>
+            <a:srgbClr val="EAF4EF"/>
           </a:solidFill>
           <a:ln/>
           <a:effectLst>
@@ -7850,14 +8000,14 @@
         </p:nvSpPr>
         <p:spPr>
           <a:xfrm>
-            <a:off x="8328965" y="1892808"/>
-            <a:ext cx="502920" cy="502920"/>
+            <a:off x="749808" y="4096512"/>
+            <a:ext cx="475488" cy="475488"/>
           </a:xfrm>
           <a:prstGeom prst="ellipse">
             <a:avLst/>
           </a:prstGeom>
           <a:solidFill>
-            <a:srgbClr val="1E2761"/>
+            <a:srgbClr val="2E7D5B"/>
           </a:solidFill>
           <a:ln/>
         </p:spPr>
@@ -7878,8 +8028,8 @@
         </p:blipFill>
         <p:spPr>
           <a:xfrm>
-            <a:off x="8459724" y="2023567"/>
-            <a:ext cx="241402" cy="241402"/>
+            <a:off x="873435" y="4220139"/>
+            <a:ext cx="228234" cy="228234"/>
           </a:xfrm>
           <a:prstGeom prst="rect">
             <a:avLst/>
@@ -7894,8 +8044,8 @@
         </p:nvSpPr>
         <p:spPr>
           <a:xfrm>
-            <a:off x="8969045" y="1947672"/>
-            <a:ext cx="2509418" cy="384048"/>
+            <a:off x="1353312" y="4142232"/>
+            <a:ext cx="4440784" cy="365760"/>
           </a:xfrm>
           <a:prstGeom prst="rect">
             <a:avLst/>
@@ -7913,13 +8063,13 @@
             <a:r>
               <a:rPr lang="en-US" sz="1450" b="1" dirty="0">
                 <a:solidFill>
-                  <a:srgbClr val="1E2761"/>
-                </a:solidFill>
-                <a:latin typeface="Calibri" pitchFamily="34" charset="0"/>
-                <a:ea typeface="Calibri" pitchFamily="34" charset="-122"/>
-                <a:cs typeface="Calibri" pitchFamily="34" charset="-120"/>
-              </a:rPr>
-              <a:t>Egress SLA &amp; yield</a:t>
+                  <a:srgbClr val="2E7D5B"/>
+                </a:solidFill>
+                <a:latin typeface="Calibri" pitchFamily="34" charset="0"/>
+                <a:ea typeface="Calibri" pitchFamily="34" charset="-122"/>
+                <a:cs typeface="Calibri" pitchFamily="34" charset="-120"/>
+              </a:rPr>
+              <a:t>Extend to Spring early</a:t>
             </a:r>
             <a:endParaRPr lang="en-US" sz="1450" dirty="0"/>
           </a:p>
@@ -7933,8 +8083,8 @@
         </p:nvSpPr>
         <p:spPr>
           <a:xfrm>
-            <a:off x="8356397" y="2468880"/>
-            <a:ext cx="3058058" cy="1051560"/>
+            <a:off x="777240" y="4599432"/>
+            <a:ext cx="4943704" cy="1252728"/>
           </a:xfrm>
           <a:prstGeom prst="rect">
             <a:avLst/>
@@ -7950,7 +8100,7 @@
               <a:buNone/>
             </a:pPr>
             <a:r>
-              <a:rPr lang="en-US" sz="1100" dirty="0">
+              <a:rPr lang="en-US" sz="1060" dirty="0">
                 <a:solidFill>
                   <a:srgbClr val="1B2440"/>
                 </a:solidFill>
@@ -7958,9 +8108,9 @@
                 <a:ea typeface="Calibri" pitchFamily="34" charset="-122"/>
                 <a:cs typeface="Calibri" pitchFamily="34" charset="-120"/>
               </a:rPr>
-              <a:t>Gate turnaround vs. matrix targets, and % of packages passing Gate 0 clean first try. Falling yield = checklist or tooling gap.</a:t>
-            </a:r>
-            <a:endParaRPr lang="en-US" sz="1100" dirty="0"/>
+              <a:t>The extractor already speaks Java, and “who builds backend in the new model?” is unanswered. Passive-shell has a clean server analogue: services built outside against the same OpenAPI contract, rule values externalized to Spring config, Testcontainers as the outside harness. One backend service through the loop in Phase 1 answers the workforce question with evidence.</a:t>
+            </a:r>
+            <a:endParaRPr lang="en-US" sz="1060" dirty="0"/>
           </a:p>
         </p:txBody>
       </p:sp>
@@ -7972,16 +8122,16 @@
         </p:nvSpPr>
         <p:spPr>
           <a:xfrm>
-            <a:off x="548640" y="3886200"/>
-            <a:ext cx="3515258" cy="2011680"/>
+            <a:off x="6242152" y="3913632"/>
+            <a:ext cx="5400904" cy="2121408"/>
           </a:xfrm>
           <a:prstGeom prst="roundRect">
             <a:avLst>
-              <a:gd name="adj" fmla="val 3636"/>
+              <a:gd name="adj" fmla="val 3448"/>
             </a:avLst>
           </a:prstGeom>
           <a:solidFill>
-            <a:srgbClr val="EDF3FC"/>
+            <a:srgbClr val="EAF4EF"/>
           </a:solidFill>
           <a:ln/>
           <a:effectLst>
@@ -8001,14 +8151,14 @@
         </p:nvSpPr>
         <p:spPr>
           <a:xfrm>
-            <a:off x="749808" y="4087368"/>
-            <a:ext cx="502920" cy="502920"/>
+            <a:off x="6443320" y="4096512"/>
+            <a:ext cx="475488" cy="475488"/>
           </a:xfrm>
           <a:prstGeom prst="ellipse">
             <a:avLst/>
           </a:prstGeom>
           <a:solidFill>
-            <a:srgbClr val="1E2761"/>
+            <a:srgbClr val="2E7D5B"/>
           </a:solidFill>
           <a:ln/>
         </p:spPr>
@@ -8029,8 +8179,8 @@
         </p:blipFill>
         <p:spPr>
           <a:xfrm>
-            <a:off x="880567" y="4218127"/>
-            <a:ext cx="241402" cy="241402"/>
+            <a:off x="6566946" y="4220139"/>
+            <a:ext cx="228234" cy="228234"/>
           </a:xfrm>
           <a:prstGeom prst="rect">
             <a:avLst/>
@@ -8045,8 +8195,8 @@
         </p:nvSpPr>
         <p:spPr>
           <a:xfrm>
-            <a:off x="1389888" y="4142232"/>
-            <a:ext cx="2509418" cy="384048"/>
+            <a:off x="7046824" y="4142232"/>
+            <a:ext cx="4440784" cy="365760"/>
           </a:xfrm>
           <a:prstGeom prst="rect">
             <a:avLst/>
@@ -8064,13 +8214,13 @@
             <a:r>
               <a:rPr lang="en-US" sz="1450" b="1" dirty="0">
                 <a:solidFill>
-                  <a:srgbClr val="1E2761"/>
-                </a:solidFill>
-                <a:latin typeface="Calibri" pitchFamily="34" charset="0"/>
-                <a:ea typeface="Calibri" pitchFamily="34" charset="-122"/>
-                <a:cs typeface="Calibri" pitchFamily="34" charset="-120"/>
-              </a:rPr>
-              <a:t>Pack coverage</a:t>
+                  <a:srgbClr val="2E7D5B"/>
+                </a:solidFill>
+                <a:latin typeface="Calibri" pitchFamily="34" charset="0"/>
+                <a:ea typeface="Calibri" pitchFamily="34" charset="-122"/>
+                <a:cs typeface="Calibri" pitchFamily="34" charset="-120"/>
+              </a:rPr>
+              <a:t>Desensitizer as a product</a:t>
             </a:r>
             <a:endParaRPr lang="en-US" sz="1450" dirty="0"/>
           </a:p>
@@ -8084,8 +8234,8 @@
         </p:nvSpPr>
         <p:spPr>
           <a:xfrm>
-            <a:off x="777240" y="4663440"/>
-            <a:ext cx="3058058" cy="1051560"/>
+            <a:off x="6470752" y="4599432"/>
+            <a:ext cx="4943704" cy="1252728"/>
           </a:xfrm>
           <a:prstGeom prst="rect">
             <a:avLst/>
@@ -8101,7 +8251,7 @@
               <a:buNone/>
             </a:pPr>
             <a:r>
-              <a:rPr lang="en-US" sz="1100" dirty="0">
+              <a:rPr lang="en-US" sz="1060" dirty="0">
                 <a:solidFill>
                   <a:srgbClr val="1B2440"/>
                 </a:solidFill>
@@ -8109,324 +8259,22 @@
                 <a:ea typeface="Calibri" pitchFamily="34" charset="-122"/>
                 <a:cs typeface="Calibri" pitchFamily="34" charset="-120"/>
               </a:rPr>
-              <a:t>% of business rules expressed as logic-pack data vs. escape-hatch code. Higher = less inside-only work = Phase 3 readiness.</a:t>
-            </a:r>
-            <a:endParaRPr lang="en-US" sz="1100" dirty="0"/>
-          </a:p>
-        </p:txBody>
-      </p:sp>
-      <p:sp>
-        <p:nvSpPr>
-          <p:cNvPr id="26" name="Shape 20"/>
-          <p:cNvSpPr/>
-          <p:nvPr/>
-        </p:nvSpPr>
-        <p:spPr>
-          <a:xfrm>
-            <a:off x="4338218" y="3886200"/>
-            <a:ext cx="3515258" cy="2011680"/>
-          </a:xfrm>
-          <a:prstGeom prst="roundRect">
-            <a:avLst>
-              <a:gd name="adj" fmla="val 3636"/>
-            </a:avLst>
-          </a:prstGeom>
-          <a:solidFill>
-            <a:srgbClr val="EDF3FC"/>
-          </a:solidFill>
-          <a:ln/>
-          <a:effectLst>
-            <a:outerShdw sx="100000" sy="100000" kx="0" ky="0" algn="bl" rotWithShape="0" blurRad="76200" dist="12700" dir="5400000">
-              <a:srgbClr val="9AA7C4">
-                <a:alpha val="25000"/>
-              </a:srgbClr>
-            </a:outerShdw>
-          </a:effectLst>
-        </p:spPr>
-      </p:sp>
-      <p:sp>
-        <p:nvSpPr>
-          <p:cNvPr id="27" name="Shape 21"/>
-          <p:cNvSpPr/>
-          <p:nvPr/>
-        </p:nvSpPr>
-        <p:spPr>
-          <a:xfrm>
-            <a:off x="4539386" y="4087368"/>
-            <a:ext cx="502920" cy="502920"/>
-          </a:xfrm>
-          <a:prstGeom prst="ellipse">
-            <a:avLst/>
-          </a:prstGeom>
-          <a:solidFill>
-            <a:srgbClr val="1E2761"/>
-          </a:solidFill>
-          <a:ln/>
-        </p:spPr>
-      </p:sp>
-      <p:pic>
-        <p:nvPicPr>
-          <p:cNvPr id="28" name="Image 4" descr="preencoded.png">    </p:cNvPr>
-          <p:cNvPicPr>
-            <a:picLocks noChangeAspect="1"/>
-          </p:cNvPicPr>
-          <p:nvPr/>
-        </p:nvPicPr>
-        <p:blipFill>
-          <a:blip r:embed="rId5"/>
-          <a:stretch>
-            <a:fillRect/>
-          </a:stretch>
-        </p:blipFill>
-        <p:spPr>
-          <a:xfrm>
-            <a:off x="4670146" y="4218127"/>
-            <a:ext cx="241402" cy="241402"/>
-          </a:xfrm>
-          <a:prstGeom prst="rect">
-            <a:avLst/>
-          </a:prstGeom>
-        </p:spPr>
-      </p:pic>
-      <p:sp>
-        <p:nvSpPr>
-          <p:cNvPr id="29" name="Text 22"/>
-          <p:cNvSpPr/>
-          <p:nvPr/>
-        </p:nvSpPr>
-        <p:spPr>
-          <a:xfrm>
-            <a:off x="5179466" y="4142232"/>
-            <a:ext cx="2509418" cy="384048"/>
-          </a:xfrm>
-          <a:prstGeom prst="rect">
-            <a:avLst/>
-          </a:prstGeom>
-          <a:noFill/>
-          <a:ln/>
-        </p:spPr>
-        <p:txBody>
-          <a:bodyPr wrap="square" lIns="0" tIns="0" rIns="0" bIns="0" rtlCol="0" anchor="ctr"/>
-          <a:lstStyle/>
-          <a:p>
-            <a:pPr indent="0" marL="0">
-              <a:buNone/>
-            </a:pPr>
-            <a:r>
-              <a:rPr lang="en-US" sz="1450" b="1" dirty="0">
-                <a:solidFill>
-                  <a:srgbClr val="1E2761"/>
-                </a:solidFill>
-                <a:latin typeface="Calibri" pitchFamily="34" charset="0"/>
-                <a:ea typeface="Calibri" pitchFamily="34" charset="-122"/>
-                <a:cs typeface="Calibri" pitchFamily="34" charset="-120"/>
-              </a:rPr>
-              <a:t>Security incidents</a:t>
-            </a:r>
-            <a:endParaRPr lang="en-US" sz="1450" dirty="0"/>
-          </a:p>
-        </p:txBody>
-      </p:sp>
-      <p:sp>
-        <p:nvSpPr>
-          <p:cNvPr id="30" name="Text 23"/>
-          <p:cNvSpPr/>
-          <p:nvPr/>
-        </p:nvSpPr>
-        <p:spPr>
-          <a:xfrm>
-            <a:off x="4566818" y="4663440"/>
-            <a:ext cx="3058058" cy="1051560"/>
-          </a:xfrm>
-          <a:prstGeom prst="rect">
-            <a:avLst/>
-          </a:prstGeom>
-          <a:noFill/>
-          <a:ln/>
-        </p:spPr>
-        <p:txBody>
-          <a:bodyPr wrap="square" lIns="0" tIns="0" rIns="0" bIns="0" rtlCol="0" anchor="ctr"/>
-          <a:lstStyle/>
-          <a:p>
-            <a:pPr indent="0" marL="0">
-              <a:buNone/>
-            </a:pPr>
-            <a:r>
-              <a:rPr lang="en-US" sz="1100" dirty="0">
-                <a:solidFill>
-                  <a:srgbClr val="1B2440"/>
-                </a:solidFill>
-                <a:latin typeface="Calibri" pitchFamily="34" charset="0"/>
-                <a:ea typeface="Calibri" pitchFamily="34" charset="-122"/>
-                <a:cs typeface="Calibri" pitchFamily="34" charset="-120"/>
-              </a:rPr>
-              <a:t>Confirmed leakage events past Gate 3. The only acceptable number is zero; one incident likely ends the program.</a:t>
-            </a:r>
-            <a:endParaRPr lang="en-US" sz="1100" dirty="0"/>
-          </a:p>
-        </p:txBody>
-      </p:sp>
-      <p:sp>
-        <p:nvSpPr>
-          <p:cNvPr id="31" name="Shape 24"/>
-          <p:cNvSpPr/>
-          <p:nvPr/>
-        </p:nvSpPr>
-        <p:spPr>
-          <a:xfrm>
-            <a:off x="8127797" y="3886200"/>
-            <a:ext cx="3515258" cy="2011680"/>
-          </a:xfrm>
-          <a:prstGeom prst="roundRect">
-            <a:avLst>
-              <a:gd name="adj" fmla="val 3636"/>
-            </a:avLst>
-          </a:prstGeom>
-          <a:solidFill>
-            <a:srgbClr val="EDF3FC"/>
-          </a:solidFill>
-          <a:ln/>
-          <a:effectLst>
-            <a:outerShdw sx="100000" sy="100000" kx="0" ky="0" algn="bl" rotWithShape="0" blurRad="76200" dist="12700" dir="5400000">
-              <a:srgbClr val="9AA7C4">
-                <a:alpha val="25000"/>
-              </a:srgbClr>
-            </a:outerShdw>
-          </a:effectLst>
-        </p:spPr>
-      </p:sp>
-      <p:sp>
-        <p:nvSpPr>
-          <p:cNvPr id="32" name="Shape 25"/>
-          <p:cNvSpPr/>
-          <p:nvPr/>
-        </p:nvSpPr>
-        <p:spPr>
-          <a:xfrm>
-            <a:off x="8328965" y="4087368"/>
-            <a:ext cx="502920" cy="502920"/>
-          </a:xfrm>
-          <a:prstGeom prst="ellipse">
-            <a:avLst/>
-          </a:prstGeom>
-          <a:solidFill>
-            <a:srgbClr val="1E2761"/>
-          </a:solidFill>
-          <a:ln/>
-        </p:spPr>
-      </p:sp>
-      <p:pic>
-        <p:nvPicPr>
-          <p:cNvPr id="33" name="Image 5" descr="preencoded.png">    </p:cNvPr>
-          <p:cNvPicPr>
-            <a:picLocks noChangeAspect="1"/>
-          </p:cNvPicPr>
-          <p:nvPr/>
-        </p:nvPicPr>
-        <p:blipFill>
-          <a:blip r:embed="rId6"/>
-          <a:stretch>
-            <a:fillRect/>
-          </a:stretch>
-        </p:blipFill>
-        <p:spPr>
-          <a:xfrm>
-            <a:off x="8459724" y="4218127"/>
-            <a:ext cx="241402" cy="241402"/>
-          </a:xfrm>
-          <a:prstGeom prst="rect">
-            <a:avLst/>
-          </a:prstGeom>
-        </p:spPr>
-      </p:pic>
-      <p:sp>
-        <p:nvSpPr>
-          <p:cNvPr id="34" name="Text 26"/>
-          <p:cNvSpPr/>
-          <p:nvPr/>
-        </p:nvSpPr>
-        <p:spPr>
-          <a:xfrm>
-            <a:off x="8969045" y="4142232"/>
-            <a:ext cx="2509418" cy="384048"/>
-          </a:xfrm>
-          <a:prstGeom prst="rect">
-            <a:avLst/>
-          </a:prstGeom>
-          <a:noFill/>
-          <a:ln/>
-        </p:spPr>
-        <p:txBody>
-          <a:bodyPr wrap="square" lIns="0" tIns="0" rIns="0" bIns="0" rtlCol="0" anchor="ctr"/>
-          <a:lstStyle/>
-          <a:p>
-            <a:pPr indent="0" marL="0">
-              <a:buNone/>
-            </a:pPr>
-            <a:r>
-              <a:rPr lang="en-US" sz="1450" b="1" dirty="0">
-                <a:solidFill>
-                  <a:srgbClr val="1E2761"/>
-                </a:solidFill>
-                <a:latin typeface="Calibri" pitchFamily="34" charset="0"/>
-                <a:ea typeface="Calibri" pitchFamily="34" charset="-122"/>
-                <a:cs typeface="Calibri" pitchFamily="34" charset="-120"/>
-              </a:rPr>
-              <a:t>Bus-factor spread</a:t>
-            </a:r>
-            <a:endParaRPr lang="en-US" sz="1450" dirty="0"/>
-          </a:p>
-        </p:txBody>
-      </p:sp>
-      <p:sp>
-        <p:nvSpPr>
-          <p:cNvPr id="35" name="Text 27"/>
-          <p:cNvSpPr/>
-          <p:nvPr/>
-        </p:nvSpPr>
-        <p:spPr>
-          <a:xfrm>
-            <a:off x="8356397" y="4663440"/>
-            <a:ext cx="3058058" cy="1051560"/>
-          </a:xfrm>
-          <a:prstGeom prst="rect">
-            <a:avLst/>
-          </a:prstGeom>
-          <a:noFill/>
-          <a:ln/>
-        </p:spPr>
-        <p:txBody>
-          <a:bodyPr wrap="square" lIns="0" tIns="0" rIns="0" bIns="0" rtlCol="0" anchor="ctr"/>
-          <a:lstStyle/>
-          <a:p>
-            <a:pPr indent="0" marL="0">
-              <a:buNone/>
-            </a:pPr>
-            <a:r>
-              <a:rPr lang="en-US" sz="1100" dirty="0">
-                <a:solidFill>
-                  <a:srgbClr val="1B2440"/>
-                </a:solidFill>
-                <a:latin typeface="Calibri" pitchFamily="34" charset="0"/>
-                <a:ea typeface="Calibri" pitchFamily="34" charset="-122"/>
-                <a:cs typeface="Calibri" pitchFamily="34" charset="-120"/>
-              </a:rPr>
-              <a:t>Per contractor duty: runbook exists + a core-team member has executed it this quarter. 100% = Phase 3 can trigger any day.</a:t>
-            </a:r>
-            <a:endParaRPr lang="en-US" sz="1100" dirty="0"/>
-          </a:p>
-        </p:txBody>
-      </p:sp>
-      <p:sp>
-        <p:nvSpPr>
-          <p:cNvPr id="36" name="Text 28"/>
-          <p:cNvSpPr/>
-          <p:nvPr/>
-        </p:nvSpPr>
-        <p:spPr>
-          <a:xfrm>
-            <a:off x="548640" y="5989320"/>
-            <a:ext cx="11094415" cy="365760"/>
+              <a:t>Other teams face the same “on-prem models are weak, code can't leave” problem. A sanctioned internal platform earns budget, allies, and makes security a CO-OWNER of the workflow instead of its auditor — co-owned controls get improved; audited workarounds get shut down. It reframes us from rule-benders to the team that built the org's answer.</a:t>
+            </a:r>
+            <a:endParaRPr lang="en-US" sz="1060" dirty="0"/>
+          </a:p>
+        </p:txBody>
+      </p:sp>
+      <p:sp>
+        <p:nvSpPr>
+          <p:cNvPr id="26" name="Text 20"/>
+          <p:cNvSpPr/>
+          <p:nvPr/>
+        </p:nvSpPr>
+        <p:spPr>
+          <a:xfrm>
+            <a:off x="548640" y="6263640"/>
+            <a:ext cx="11094415" cy="320040"/>
           </a:xfrm>
           <a:prstGeom prst="rect">
             <a:avLst/>
@@ -8442,7 +8290,7 @@
               <a:buNone/>
             </a:pPr>
             <a:r>
-              <a:rPr lang="en-US" sz="1250" i="1" dirty="0">
+              <a:rPr lang="en-US" sz="1200" i="1" dirty="0">
                 <a:solidFill>
                   <a:srgbClr val="5A6B8C"/>
                 </a:solidFill>
@@ -8450,9 +8298,9 @@
                 <a:ea typeface="Calibri" pitchFamily="34" charset="-122"/>
                 <a:cs typeface="Calibri" pitchFamily="34" charset="-120"/>
               </a:rPr>
-              <a:t>Publish the scoreboard monthly — to stakeholders, not just the team. Transparency is the counter-narrative.</a:t>
-            </a:r>
-            <a:endParaRPr lang="en-US" sz="1250" dirty="0"/>
+              <a:t>Each converts a defensive posture into an offensive one — governance as the product, not the tax.</a:t>
+            </a:r>
+            <a:endParaRPr lang="en-US" sz="1200" dirty="0"/>
           </a:p>
         </p:txBody>
       </p:sp>
@@ -8467,6 +8315,2300 @@
 <file path=ppt/slides/slide16.xml><?xml version="1.0" encoding="utf-8"?>
 <p:sld xmlns:a="http://schemas.openxmlformats.org/drawingml/2006/main" xmlns:r="http://schemas.openxmlformats.org/officeDocument/2006/relationships" xmlns:p="http://schemas.openxmlformats.org/presentationml/2006/main">
   <p:cSld name="Slide 16">
+    <p:bg>
+      <p:bgPr>
+        <a:solidFill>
+          <a:srgbClr val="FFFFFF"/>
+        </a:solidFill>
+      </p:bgPr>
+    </p:bg>
+    <p:spTree>
+      <p:nvGrpSpPr>
+        <p:cNvPr id="1" name=""/>
+        <p:cNvGrpSpPr/>
+        <p:nvPr/>
+      </p:nvGrpSpPr>
+      <p:grpSpPr>
+        <a:xfrm>
+          <a:off x="0" y="0"/>
+          <a:ext cx="0" cy="0"/>
+          <a:chOff x="0" y="0"/>
+          <a:chExt cx="0" cy="0"/>
+        </a:xfrm>
+      </p:grpSpPr>
+      <p:sp>
+        <p:nvSpPr>
+          <p:cNvPr id="2" name="Text 0"/>
+          <p:cNvSpPr/>
+          <p:nvPr/>
+        </p:nvSpPr>
+        <p:spPr>
+          <a:xfrm>
+            <a:off x="548640" y="6473952"/>
+            <a:ext cx="3657600" cy="274320"/>
+          </a:xfrm>
+          <a:prstGeom prst="rect">
+            <a:avLst/>
+          </a:prstGeom>
+          <a:noFill/>
+          <a:ln/>
+        </p:spPr>
+        <p:txBody>
+          <a:bodyPr wrap="square" lIns="0" tIns="0" rIns="0" bIns="0" rtlCol="0" anchor="ctr"/>
+          <a:lstStyle/>
+          <a:p>
+            <a:pPr algn="l" indent="0" marL="0">
+              <a:buNone/>
+            </a:pPr>
+            <a:r>
+              <a:rPr lang="en-US" sz="900" dirty="0">
+                <a:solidFill>
+                  <a:srgbClr val="5A6B8C"/>
+                </a:solidFill>
+                <a:latin typeface="Calibri" pitchFamily="34" charset="0"/>
+                <a:ea typeface="Calibri" pitchFamily="34" charset="-122"/>
+                <a:cs typeface="Calibri" pitchFamily="34" charset="-120"/>
+              </a:rPr>
+              <a:t>Internet-First, Airgap-Final</a:t>
+            </a:r>
+            <a:endParaRPr lang="en-US" sz="900" dirty="0"/>
+          </a:p>
+        </p:txBody>
+      </p:sp>
+      <p:sp>
+        <p:nvSpPr>
+          <p:cNvPr id="3" name="Text 1"/>
+          <p:cNvSpPr/>
+          <p:nvPr/>
+        </p:nvSpPr>
+        <p:spPr>
+          <a:xfrm>
+            <a:off x="11094415" y="6473952"/>
+            <a:ext cx="548640" cy="274320"/>
+          </a:xfrm>
+          <a:prstGeom prst="rect">
+            <a:avLst/>
+          </a:prstGeom>
+          <a:noFill/>
+          <a:ln/>
+        </p:spPr>
+        <p:txBody>
+          <a:bodyPr wrap="square" lIns="0" tIns="0" rIns="0" bIns="0" rtlCol="0" anchor="ctr"/>
+          <a:lstStyle/>
+          <a:p>
+            <a:pPr algn="r" indent="0" marL="0">
+              <a:buNone/>
+            </a:pPr>
+            <a:r>
+              <a:rPr lang="en-US" sz="900" dirty="0">
+                <a:solidFill>
+                  <a:srgbClr val="5A6B8C"/>
+                </a:solidFill>
+                <a:latin typeface="Calibri" pitchFamily="34" charset="0"/>
+                <a:ea typeface="Calibri" pitchFamily="34" charset="-122"/>
+                <a:cs typeface="Calibri" pitchFamily="34" charset="-120"/>
+              </a:rPr>
+              <a:t>16</a:t>
+            </a:r>
+            <a:endParaRPr lang="en-US" sz="900" dirty="0"/>
+          </a:p>
+        </p:txBody>
+      </p:sp>
+      <p:sp>
+        <p:nvSpPr>
+          <p:cNvPr id="4" name="Text 2"/>
+          <p:cNvSpPr/>
+          <p:nvPr/>
+        </p:nvSpPr>
+        <p:spPr>
+          <a:xfrm>
+            <a:off x="548640" y="384048"/>
+            <a:ext cx="11094415" cy="274320"/>
+          </a:xfrm>
+          <a:prstGeom prst="rect">
+            <a:avLst/>
+          </a:prstGeom>
+          <a:noFill/>
+          <a:ln/>
+        </p:spPr>
+        <p:txBody>
+          <a:bodyPr wrap="square" lIns="0" tIns="0" rIns="0" bIns="0" rtlCol="0" anchor="ctr"/>
+          <a:lstStyle/>
+          <a:p>
+            <a:pPr indent="0" marL="0">
+              <a:buNone/>
+            </a:pPr>
+            <a:r>
+              <a:rPr lang="en-US" sz="1200" b="1" spc="300" kern="0" dirty="0">
+                <a:solidFill>
+                  <a:srgbClr val="5A6B8C"/>
+                </a:solidFill>
+                <a:latin typeface="Calibri" pitchFamily="34" charset="0"/>
+                <a:ea typeface="Calibri" pitchFamily="34" charset="-122"/>
+                <a:cs typeface="Calibri" pitchFamily="34" charset="-120"/>
+              </a:rPr>
+              <a:t>EXECUTION · A PRAGMATIC TRANSITION TIMELINE</a:t>
+            </a:r>
+            <a:endParaRPr lang="en-US" sz="1200" dirty="0"/>
+          </a:p>
+        </p:txBody>
+      </p:sp>
+      <p:sp>
+        <p:nvSpPr>
+          <p:cNvPr id="5" name="Text 3"/>
+          <p:cNvSpPr/>
+          <p:nvPr/>
+        </p:nvSpPr>
+        <p:spPr>
+          <a:xfrm>
+            <a:off x="548640" y="658368"/>
+            <a:ext cx="11094415" cy="621792"/>
+          </a:xfrm>
+          <a:prstGeom prst="rect">
+            <a:avLst/>
+          </a:prstGeom>
+          <a:noFill/>
+          <a:ln/>
+        </p:spPr>
+        <p:txBody>
+          <a:bodyPr wrap="square" lIns="0" tIns="0" rIns="0" bIns="0" rtlCol="0" anchor="t"/>
+          <a:lstStyle/>
+          <a:p>
+            <a:pPr indent="0" marL="0">
+              <a:buNone/>
+            </a:pPr>
+            <a:r>
+              <a:rPr lang="en-US" sz="3000" b="1" dirty="0">
+                <a:solidFill>
+                  <a:srgbClr val="1E2761"/>
+                </a:solidFill>
+                <a:latin typeface="Cambria" pitchFamily="34" charset="0"/>
+                <a:ea typeface="Cambria" pitchFamily="34" charset="-122"/>
+                <a:cs typeface="Cambria" pitchFamily="34" charset="-120"/>
+              </a:rPr>
+              <a:t>Phase exits are criteria, not dates</a:t>
+            </a:r>
+            <a:endParaRPr lang="en-US" sz="3000" dirty="0"/>
+          </a:p>
+        </p:txBody>
+      </p:sp>
+      <p:sp>
+        <p:nvSpPr>
+          <p:cNvPr id="6" name="Shape 4"/>
+          <p:cNvSpPr/>
+          <p:nvPr/>
+        </p:nvSpPr>
+        <p:spPr>
+          <a:xfrm>
+            <a:off x="548640" y="1691640"/>
+            <a:ext cx="2602154" cy="4206240"/>
+          </a:xfrm>
+          <a:prstGeom prst="roundRect">
+            <a:avLst>
+              <a:gd name="adj" fmla="val 2811"/>
+            </a:avLst>
+          </a:prstGeom>
+          <a:solidFill>
+            <a:srgbClr val="EDF3FC"/>
+          </a:solidFill>
+          <a:ln/>
+          <a:effectLst>
+            <a:outerShdw sx="100000" sy="100000" kx="0" ky="0" algn="bl" rotWithShape="0" blurRad="76200" dist="12700" dir="5400000">
+              <a:srgbClr val="9AA7C4">
+                <a:alpha val="25000"/>
+              </a:srgbClr>
+            </a:outerShdw>
+          </a:effectLst>
+        </p:spPr>
+      </p:sp>
+      <p:sp>
+        <p:nvSpPr>
+          <p:cNvPr id="7" name="Text 5"/>
+          <p:cNvSpPr/>
+          <p:nvPr/>
+        </p:nvSpPr>
+        <p:spPr>
+          <a:xfrm>
+            <a:off x="731520" y="1828800"/>
+            <a:ext cx="2236394" cy="274320"/>
+          </a:xfrm>
+          <a:prstGeom prst="rect">
+            <a:avLst/>
+          </a:prstGeom>
+          <a:noFill/>
+          <a:ln/>
+        </p:spPr>
+        <p:txBody>
+          <a:bodyPr wrap="square" lIns="0" tIns="0" rIns="0" bIns="0" rtlCol="0" anchor="ctr"/>
+          <a:lstStyle/>
+          <a:p>
+            <a:pPr indent="0" marL="0">
+              <a:buNone/>
+            </a:pPr>
+            <a:r>
+              <a:rPr lang="en-US" sz="1100" b="1" spc="200" kern="0" dirty="0">
+                <a:solidFill>
+                  <a:srgbClr val="5A6B8C"/>
+                </a:solidFill>
+                <a:latin typeface="Calibri" pitchFamily="34" charset="0"/>
+                <a:ea typeface="Calibri" pitchFamily="34" charset="-122"/>
+                <a:cs typeface="Calibri" pitchFamily="34" charset="-120"/>
+              </a:rPr>
+              <a:t>PHASE 0</a:t>
+            </a:r>
+            <a:endParaRPr lang="en-US" sz="1100" dirty="0"/>
+          </a:p>
+        </p:txBody>
+      </p:sp>
+      <p:sp>
+        <p:nvSpPr>
+          <p:cNvPr id="8" name="Text 6"/>
+          <p:cNvSpPr/>
+          <p:nvPr/>
+        </p:nvSpPr>
+        <p:spPr>
+          <a:xfrm>
+            <a:off x="731520" y="2103120"/>
+            <a:ext cx="2236394" cy="685800"/>
+          </a:xfrm>
+          <a:prstGeom prst="rect">
+            <a:avLst/>
+          </a:prstGeom>
+          <a:noFill/>
+          <a:ln/>
+        </p:spPr>
+        <p:txBody>
+          <a:bodyPr wrap="square" lIns="0" tIns="0" rIns="0" bIns="0" rtlCol="0" anchor="ctr"/>
+          <a:lstStyle/>
+          <a:p>
+            <a:pPr indent="0" marL="0">
+              <a:buNone/>
+            </a:pPr>
+            <a:r>
+              <a:rPr lang="en-US" sz="1350" b="1" dirty="0">
+                <a:solidFill>
+                  <a:srgbClr val="1E2761"/>
+                </a:solidFill>
+                <a:latin typeface="Calibri" pitchFamily="34" charset="0"/>
+                <a:ea typeface="Calibri" pitchFamily="34" charset="-122"/>
+                <a:cs typeface="Calibri" pitchFamily="34" charset="-120"/>
+              </a:rPr>
+              <a:t>Legitimize &amp; pilot</a:t>
+            </a:r>
+            <a:endParaRPr lang="en-US" sz="1350" dirty="0"/>
+          </a:p>
+          <a:p>
+            <a:pPr indent="0" marL="0">
+              <a:buNone/>
+            </a:pPr>
+            <a:r>
+              <a:rPr lang="en-US" sz="1350" b="1" dirty="0">
+                <a:solidFill>
+                  <a:srgbClr val="1E2761"/>
+                </a:solidFill>
+                <a:latin typeface="Calibri" pitchFamily="34" charset="0"/>
+                <a:ea typeface="Calibri" pitchFamily="34" charset="-122"/>
+                <a:cs typeface="Calibri" pitchFamily="34" charset="-120"/>
+              </a:rPr>
+              <a:t>(mo 0–2)</a:t>
+            </a:r>
+            <a:endParaRPr lang="en-US" sz="1350" dirty="0"/>
+          </a:p>
+        </p:txBody>
+      </p:sp>
+      <p:sp>
+        <p:nvSpPr>
+          <p:cNvPr id="9" name="Text 7"/>
+          <p:cNvSpPr/>
+          <p:nvPr/>
+        </p:nvSpPr>
+        <p:spPr>
+          <a:xfrm>
+            <a:off x="731520" y="2880360"/>
+            <a:ext cx="2236394" cy="2834640"/>
+          </a:xfrm>
+          <a:prstGeom prst="rect">
+            <a:avLst/>
+          </a:prstGeom>
+          <a:noFill/>
+          <a:ln/>
+        </p:spPr>
+        <p:txBody>
+          <a:bodyPr wrap="square" lIns="0" tIns="0" rIns="0" bIns="0" rtlCol="0" anchor="ctr"/>
+          <a:lstStyle/>
+          <a:p>
+            <a:pPr marL="342900" indent="-342900">
+              <a:spcAft>
+                <a:spcPts val="600"/>
+              </a:spcAft>
+              <a:buSzPct val="100000"/>
+              <a:buChar char="•"/>
+            </a:pPr>
+            <a:r>
+              <a:rPr lang="en-US" sz="980" dirty="0">
+                <a:solidFill>
+                  <a:srgbClr val="1B2440"/>
+                </a:solidFill>
+                <a:latin typeface="Calibri" pitchFamily="34" charset="0"/>
+                <a:ea typeface="Calibri" pitchFamily="34" charset="-122"/>
+                <a:cs typeface="Calibri" pitchFamily="34" charset="-120"/>
+              </a:rPr>
+              <a:t>Written authorization: scope, egress channel, named approvers</a:t>
+            </a:r>
+            <a:endParaRPr lang="en-US" sz="980" dirty="0"/>
+          </a:p>
+          <a:p>
+            <a:pPr marL="342900" indent="-342900">
+              <a:spcAft>
+                <a:spcPts val="600"/>
+              </a:spcAft>
+              <a:buSzPct val="100000"/>
+              <a:buChar char="•"/>
+            </a:pPr>
+            <a:r>
+              <a:rPr lang="en-US" sz="980" dirty="0">
+                <a:solidFill>
+                  <a:srgbClr val="1B2440"/>
+                </a:solidFill>
+                <a:latin typeface="Calibri" pitchFamily="34" charset="0"/>
+                <a:ea typeface="Calibri" pitchFamily="34" charset="-122"/>
+                <a:cs typeface="Calibri" pitchFamily="34" charset="-120"/>
+              </a:rPr>
+              <a:t>Gates 0–3 stood up; denylist co-authored with cyber</a:t>
+            </a:r>
+            <a:endParaRPr lang="en-US" sz="980" dirty="0"/>
+          </a:p>
+          <a:p>
+            <a:pPr marL="342900" indent="-342900">
+              <a:spcAft>
+                <a:spcPts val="600"/>
+              </a:spcAft>
+              <a:buSzPct val="100000"/>
+              <a:buChar char="•"/>
+            </a:pPr>
+            <a:r>
+              <a:rPr lang="en-US" sz="980" dirty="0">
+                <a:solidFill>
+                  <a:srgbClr val="1B2440"/>
+                </a:solidFill>
+                <a:latin typeface="Calibri" pitchFamily="34" charset="0"/>
+                <a:ea typeface="Calibri" pitchFamily="34" charset="-122"/>
+                <a:cs typeface="Calibri" pitchFamily="34" charset="-120"/>
+              </a:rPr>
+              <a:t>World bible v1 + internet org &amp; repos with CI parity</a:t>
+            </a:r>
+            <a:endParaRPr lang="en-US" sz="980" dirty="0"/>
+          </a:p>
+          <a:p>
+            <a:pPr marL="342900" indent="-342900">
+              <a:spcAft>
+                <a:spcPts val="600"/>
+              </a:spcAft>
+              <a:buSzPct val="100000"/>
+              <a:buChar char="•"/>
+            </a:pPr>
+            <a:r>
+              <a:rPr lang="en-US" sz="980" dirty="0">
+                <a:solidFill>
+                  <a:srgbClr val="1B2440"/>
+                </a:solidFill>
+                <a:latin typeface="Calibri" pitchFamily="34" charset="0"/>
+                <a:ea typeface="Calibri" pitchFamily="34" charset="-122"/>
+                <a:cs typeface="Calibri" pitchFamily="34" charset="-120"/>
+              </a:rPr>
+              <a:t>Pilot feature specced and egressed</a:t>
+            </a:r>
+            <a:endParaRPr lang="en-US" sz="980" dirty="0"/>
+          </a:p>
+        </p:txBody>
+      </p:sp>
+      <p:sp>
+        <p:nvSpPr>
+          <p:cNvPr id="10" name="Shape 8"/>
+          <p:cNvSpPr/>
+          <p:nvPr/>
+        </p:nvSpPr>
+        <p:spPr>
+          <a:xfrm>
+            <a:off x="3379394" y="1691640"/>
+            <a:ext cx="2602154" cy="4206240"/>
+          </a:xfrm>
+          <a:prstGeom prst="roundRect">
+            <a:avLst>
+              <a:gd name="adj" fmla="val 2811"/>
+            </a:avLst>
+          </a:prstGeom>
+          <a:solidFill>
+            <a:srgbClr val="EDF3FC"/>
+          </a:solidFill>
+          <a:ln/>
+          <a:effectLst>
+            <a:outerShdw sx="100000" sy="100000" kx="0" ky="0" algn="bl" rotWithShape="0" blurRad="76200" dist="12700" dir="5400000">
+              <a:srgbClr val="9AA7C4">
+                <a:alpha val="25000"/>
+              </a:srgbClr>
+            </a:outerShdw>
+          </a:effectLst>
+        </p:spPr>
+      </p:sp>
+      <p:sp>
+        <p:nvSpPr>
+          <p:cNvPr id="11" name="Text 9"/>
+          <p:cNvSpPr/>
+          <p:nvPr/>
+        </p:nvSpPr>
+        <p:spPr>
+          <a:xfrm>
+            <a:off x="3562274" y="1828800"/>
+            <a:ext cx="2236394" cy="274320"/>
+          </a:xfrm>
+          <a:prstGeom prst="rect">
+            <a:avLst/>
+          </a:prstGeom>
+          <a:noFill/>
+          <a:ln/>
+        </p:spPr>
+        <p:txBody>
+          <a:bodyPr wrap="square" lIns="0" tIns="0" rIns="0" bIns="0" rtlCol="0" anchor="ctr"/>
+          <a:lstStyle/>
+          <a:p>
+            <a:pPr indent="0" marL="0">
+              <a:buNone/>
+            </a:pPr>
+            <a:r>
+              <a:rPr lang="en-US" sz="1100" b="1" spc="200" kern="0" dirty="0">
+                <a:solidFill>
+                  <a:srgbClr val="5A6B8C"/>
+                </a:solidFill>
+                <a:latin typeface="Calibri" pitchFamily="34" charset="0"/>
+                <a:ea typeface="Calibri" pitchFamily="34" charset="-122"/>
+                <a:cs typeface="Calibri" pitchFamily="34" charset="-120"/>
+              </a:rPr>
+              <a:t>PHASE 1</a:t>
+            </a:r>
+            <a:endParaRPr lang="en-US" sz="1100" dirty="0"/>
+          </a:p>
+        </p:txBody>
+      </p:sp>
+      <p:sp>
+        <p:nvSpPr>
+          <p:cNvPr id="12" name="Text 10"/>
+          <p:cNvSpPr/>
+          <p:nvPr/>
+        </p:nvSpPr>
+        <p:spPr>
+          <a:xfrm>
+            <a:off x="3562274" y="2103120"/>
+            <a:ext cx="2236394" cy="685800"/>
+          </a:xfrm>
+          <a:prstGeom prst="rect">
+            <a:avLst/>
+          </a:prstGeom>
+          <a:noFill/>
+          <a:ln/>
+        </p:spPr>
+        <p:txBody>
+          <a:bodyPr wrap="square" lIns="0" tIns="0" rIns="0" bIns="0" rtlCol="0" anchor="ctr"/>
+          <a:lstStyle/>
+          <a:p>
+            <a:pPr indent="0" marL="0">
+              <a:buNone/>
+            </a:pPr>
+            <a:r>
+              <a:rPr lang="en-US" sz="1350" b="1" dirty="0">
+                <a:solidFill>
+                  <a:srgbClr val="1E2761"/>
+                </a:solidFill>
+                <a:latin typeface="Calibri" pitchFamily="34" charset="0"/>
+                <a:ea typeface="Calibri" pitchFamily="34" charset="-122"/>
+                <a:cs typeface="Calibri" pitchFamily="34" charset="-120"/>
+              </a:rPr>
+              <a:t>Internet-first core team</a:t>
+            </a:r>
+            <a:endParaRPr lang="en-US" sz="1350" dirty="0"/>
+          </a:p>
+          <a:p>
+            <a:pPr indent="0" marL="0">
+              <a:buNone/>
+            </a:pPr>
+            <a:r>
+              <a:rPr lang="en-US" sz="1350" b="1" dirty="0">
+                <a:solidFill>
+                  <a:srgbClr val="1E2761"/>
+                </a:solidFill>
+                <a:latin typeface="Calibri" pitchFamily="34" charset="0"/>
+                <a:ea typeface="Calibri" pitchFamily="34" charset="-122"/>
+                <a:cs typeface="Calibri" pitchFamily="34" charset="-120"/>
+              </a:rPr>
+              <a:t>(mo 2–8)</a:t>
+            </a:r>
+            <a:endParaRPr lang="en-US" sz="1350" dirty="0"/>
+          </a:p>
+        </p:txBody>
+      </p:sp>
+      <p:sp>
+        <p:nvSpPr>
+          <p:cNvPr id="13" name="Text 11"/>
+          <p:cNvSpPr/>
+          <p:nvPr/>
+        </p:nvSpPr>
+        <p:spPr>
+          <a:xfrm>
+            <a:off x="3562274" y="2880360"/>
+            <a:ext cx="2236394" cy="2834640"/>
+          </a:xfrm>
+          <a:prstGeom prst="rect">
+            <a:avLst/>
+          </a:prstGeom>
+          <a:noFill/>
+          <a:ln/>
+        </p:spPr>
+        <p:txBody>
+          <a:bodyPr wrap="square" lIns="0" tIns="0" rIns="0" bIns="0" rtlCol="0" anchor="ctr"/>
+          <a:lstStyle/>
+          <a:p>
+            <a:pPr marL="342900" indent="-342900">
+              <a:spcAft>
+                <a:spcPts val="600"/>
+              </a:spcAft>
+              <a:buSzPct val="100000"/>
+              <a:buChar char="•"/>
+            </a:pPr>
+            <a:r>
+              <a:rPr lang="en-US" sz="980" dirty="0">
+                <a:solidFill>
+                  <a:srgbClr val="1B2440"/>
+                </a:solidFill>
+                <a:latin typeface="Calibri" pitchFamily="34" charset="0"/>
+                <a:ea typeface="Calibri" pitchFamily="34" charset="-122"/>
+                <a:cs typeface="Calibri" pitchFamily="34" charset="-120"/>
+              </a:rPr>
+              <a:t>Core team builds pilot + 2–3 MFEs outside; logic-pack engine v1</a:t>
+            </a:r>
+            <a:endParaRPr lang="en-US" sz="980" dirty="0"/>
+          </a:p>
+          <a:p>
+            <a:pPr marL="342900" indent="-342900">
+              <a:spcAft>
+                <a:spcPts val="600"/>
+              </a:spcAft>
+              <a:buSzPct val="100000"/>
+              <a:buChar char="•"/>
+            </a:pPr>
+            <a:r>
+              <a:rPr lang="en-US" sz="980" dirty="0">
+                <a:solidFill>
+                  <a:srgbClr val="1B2440"/>
+                </a:solidFill>
+                <a:latin typeface="Calibri" pitchFamily="34" charset="0"/>
+                <a:ea typeface="Calibri" pitchFamily="34" charset="-122"/>
+                <a:cs typeface="Calibri" pitchFamily="34" charset="-120"/>
+              </a:rPr>
+              <a:t>Contractors own integration, mappings, env testing, config mgmt; some move to BA/spec roles</a:t>
+            </a:r>
+            <a:endParaRPr lang="en-US" sz="980" dirty="0"/>
+          </a:p>
+          <a:p>
+            <a:pPr marL="342900" indent="-342900">
+              <a:spcAft>
+                <a:spcPts val="600"/>
+              </a:spcAft>
+              <a:buSzPct val="100000"/>
+              <a:buChar char="•"/>
+            </a:pPr>
+            <a:r>
+              <a:rPr lang="en-US" sz="980" dirty="0">
+                <a:solidFill>
+                  <a:srgbClr val="1B2440"/>
+                </a:solidFill>
+                <a:latin typeface="Calibri" pitchFamily="34" charset="0"/>
+                <a:ea typeface="Calibri" pitchFamily="34" charset="-122"/>
+                <a:cs typeface="Calibri" pitchFamily="34" charset="-120"/>
+              </a:rPr>
+              <a:t>Dependency-delta job feeding Confi registry requests</a:t>
+            </a:r>
+            <a:endParaRPr lang="en-US" sz="980" dirty="0"/>
+          </a:p>
+          <a:p>
+            <a:pPr marL="342900" indent="-342900">
+              <a:spcAft>
+                <a:spcPts val="600"/>
+              </a:spcAft>
+              <a:buSzPct val="100000"/>
+              <a:buChar char="•"/>
+            </a:pPr>
+            <a:r>
+              <a:rPr lang="en-US" sz="980" dirty="0">
+                <a:solidFill>
+                  <a:srgbClr val="1B2440"/>
+                </a:solidFill>
+                <a:latin typeface="Calibri" pitchFamily="34" charset="0"/>
+                <a:ea typeface="Calibri" pitchFamily="34" charset="-122"/>
+                <a:cs typeface="Calibri" pitchFamily="34" charset="-120"/>
+              </a:rPr>
+              <a:t>Exit: 2 MFEs shipped through the full loop; integration ≤ 15% of feature effort</a:t>
+            </a:r>
+            <a:endParaRPr lang="en-US" sz="980" dirty="0"/>
+          </a:p>
+        </p:txBody>
+      </p:sp>
+      <p:sp>
+        <p:nvSpPr>
+          <p:cNvPr id="14" name="Shape 12"/>
+          <p:cNvSpPr/>
+          <p:nvPr/>
+        </p:nvSpPr>
+        <p:spPr>
+          <a:xfrm>
+            <a:off x="6210148" y="1691640"/>
+            <a:ext cx="2602154" cy="4206240"/>
+          </a:xfrm>
+          <a:prstGeom prst="roundRect">
+            <a:avLst>
+              <a:gd name="adj" fmla="val 2811"/>
+            </a:avLst>
+          </a:prstGeom>
+          <a:solidFill>
+            <a:srgbClr val="EDF3FC"/>
+          </a:solidFill>
+          <a:ln/>
+          <a:effectLst>
+            <a:outerShdw sx="100000" sy="100000" kx="0" ky="0" algn="bl" rotWithShape="0" blurRad="76200" dist="12700" dir="5400000">
+              <a:srgbClr val="9AA7C4">
+                <a:alpha val="25000"/>
+              </a:srgbClr>
+            </a:outerShdw>
+          </a:effectLst>
+        </p:spPr>
+      </p:sp>
+      <p:sp>
+        <p:nvSpPr>
+          <p:cNvPr id="15" name="Text 13"/>
+          <p:cNvSpPr/>
+          <p:nvPr/>
+        </p:nvSpPr>
+        <p:spPr>
+          <a:xfrm>
+            <a:off x="6393028" y="1828800"/>
+            <a:ext cx="2236394" cy="274320"/>
+          </a:xfrm>
+          <a:prstGeom prst="rect">
+            <a:avLst/>
+          </a:prstGeom>
+          <a:noFill/>
+          <a:ln/>
+        </p:spPr>
+        <p:txBody>
+          <a:bodyPr wrap="square" lIns="0" tIns="0" rIns="0" bIns="0" rtlCol="0" anchor="ctr"/>
+          <a:lstStyle/>
+          <a:p>
+            <a:pPr indent="0" marL="0">
+              <a:buNone/>
+            </a:pPr>
+            <a:r>
+              <a:rPr lang="en-US" sz="1100" b="1" spc="200" kern="0" dirty="0">
+                <a:solidFill>
+                  <a:srgbClr val="5A6B8C"/>
+                </a:solidFill>
+                <a:latin typeface="Calibri" pitchFamily="34" charset="0"/>
+                <a:ea typeface="Calibri" pitchFamily="34" charset="-122"/>
+                <a:cs typeface="Calibri" pitchFamily="34" charset="-120"/>
+              </a:rPr>
+              <a:t>PHASE 2</a:t>
+            </a:r>
+            <a:endParaRPr lang="en-US" sz="1100" dirty="0"/>
+          </a:p>
+        </p:txBody>
+      </p:sp>
+      <p:sp>
+        <p:nvSpPr>
+          <p:cNvPr id="16" name="Text 14"/>
+          <p:cNvSpPr/>
+          <p:nvPr/>
+        </p:nvSpPr>
+        <p:spPr>
+          <a:xfrm>
+            <a:off x="6393028" y="2103120"/>
+            <a:ext cx="2236394" cy="685800"/>
+          </a:xfrm>
+          <a:prstGeom prst="rect">
+            <a:avLst/>
+          </a:prstGeom>
+          <a:noFill/>
+          <a:ln/>
+        </p:spPr>
+        <p:txBody>
+          <a:bodyPr wrap="square" lIns="0" tIns="0" rIns="0" bIns="0" rtlCol="0" anchor="ctr"/>
+          <a:lstStyle/>
+          <a:p>
+            <a:pPr indent="0" marL="0">
+              <a:buNone/>
+            </a:pPr>
+            <a:r>
+              <a:rPr lang="en-US" sz="1350" b="1" dirty="0">
+                <a:solidFill>
+                  <a:srgbClr val="1E2761"/>
+                </a:solidFill>
+                <a:latin typeface="Calibri" pitchFamily="34" charset="0"/>
+                <a:ea typeface="Calibri" pitchFamily="34" charset="-122"/>
+                <a:cs typeface="Calibri" pitchFamily="34" charset="-120"/>
+              </a:rPr>
+              <a:t>Outbound spec pipeline at scale</a:t>
+            </a:r>
+            <a:endParaRPr lang="en-US" sz="1350" dirty="0"/>
+          </a:p>
+          <a:p>
+            <a:pPr indent="0" marL="0">
+              <a:buNone/>
+            </a:pPr>
+            <a:r>
+              <a:rPr lang="en-US" sz="1350" b="1" dirty="0">
+                <a:solidFill>
+                  <a:srgbClr val="1E2761"/>
+                </a:solidFill>
+                <a:latin typeface="Calibri" pitchFamily="34" charset="0"/>
+                <a:ea typeface="Calibri" pitchFamily="34" charset="-122"/>
+                <a:cs typeface="Calibri" pitchFamily="34" charset="-120"/>
+              </a:rPr>
+              <a:t>(mo 6–14, overlaps)</a:t>
+            </a:r>
+            <a:endParaRPr lang="en-US" sz="1350" dirty="0"/>
+          </a:p>
+        </p:txBody>
+      </p:sp>
+      <p:sp>
+        <p:nvSpPr>
+          <p:cNvPr id="17" name="Text 15"/>
+          <p:cNvSpPr/>
+          <p:nvPr/>
+        </p:nvSpPr>
+        <p:spPr>
+          <a:xfrm>
+            <a:off x="6393028" y="2880360"/>
+            <a:ext cx="2236394" cy="2834640"/>
+          </a:xfrm>
+          <a:prstGeom prst="rect">
+            <a:avLst/>
+          </a:prstGeom>
+          <a:noFill/>
+          <a:ln/>
+        </p:spPr>
+        <p:txBody>
+          <a:bodyPr wrap="square" lIns="0" tIns="0" rIns="0" bIns="0" rtlCol="0" anchor="ctr"/>
+          <a:lstStyle/>
+          <a:p>
+            <a:pPr marL="342900" indent="-342900">
+              <a:spcAft>
+                <a:spcPts val="600"/>
+              </a:spcAft>
+              <a:buSzPct val="100000"/>
+              <a:buChar char="•"/>
+            </a:pPr>
+            <a:r>
+              <a:rPr lang="en-US" sz="980" dirty="0">
+                <a:solidFill>
+                  <a:srgbClr val="1B2440"/>
+                </a:solidFill>
+                <a:latin typeface="Calibri" pitchFamily="34" charset="0"/>
+                <a:ea typeface="Calibri" pitchFamily="34" charset="-122"/>
+                <a:cs typeface="Calibri" pitchFamily="34" charset="-120"/>
+              </a:rPr>
+              <a:t>Spec-package tooling hardened; Tier-0 standing approvals in force</a:t>
+            </a:r>
+            <a:endParaRPr lang="en-US" sz="980" dirty="0"/>
+          </a:p>
+          <a:p>
+            <a:pPr marL="342900" indent="-342900">
+              <a:spcAft>
+                <a:spcPts val="600"/>
+              </a:spcAft>
+              <a:buSzPct val="100000"/>
+              <a:buChar char="•"/>
+            </a:pPr>
+            <a:r>
+              <a:rPr lang="en-US" sz="980" dirty="0">
+                <a:solidFill>
+                  <a:srgbClr val="1B2440"/>
+                </a:solidFill>
+                <a:latin typeface="Calibri" pitchFamily="34" charset="0"/>
+                <a:ea typeface="Calibri" pitchFamily="34" charset="-122"/>
+                <a:cs typeface="Calibri" pitchFamily="34" charset="-120"/>
+              </a:rPr>
+              <a:t>Angular inventory complete; migration factory running per-feature</a:t>
+            </a:r>
+            <a:endParaRPr lang="en-US" sz="980" dirty="0"/>
+          </a:p>
+          <a:p>
+            <a:pPr marL="342900" indent="-342900">
+              <a:spcAft>
+                <a:spcPts val="600"/>
+              </a:spcAft>
+              <a:buSzPct val="100000"/>
+              <a:buChar char="•"/>
+            </a:pPr>
+            <a:r>
+              <a:rPr lang="en-US" sz="980" dirty="0">
+                <a:solidFill>
+                  <a:srgbClr val="1B2440"/>
+                </a:solidFill>
+                <a:latin typeface="Calibri" pitchFamily="34" charset="0"/>
+                <a:ea typeface="Calibri" pitchFamily="34" charset="-122"/>
+                <a:cs typeface="Calibri" pitchFamily="34" charset="-120"/>
+              </a:rPr>
+              <a:t>Sensitizer = logic-pack compiler + validators, fully inside</a:t>
+            </a:r>
+            <a:endParaRPr lang="en-US" sz="980" dirty="0"/>
+          </a:p>
+          <a:p>
+            <a:pPr marL="342900" indent="-342900">
+              <a:spcAft>
+                <a:spcPts val="600"/>
+              </a:spcAft>
+              <a:buSzPct val="100000"/>
+              <a:buChar char="•"/>
+            </a:pPr>
+            <a:r>
+              <a:rPr lang="en-US" sz="980" dirty="0">
+                <a:solidFill>
+                  <a:srgbClr val="1B2440"/>
+                </a:solidFill>
+                <a:latin typeface="Calibri" pitchFamily="34" charset="0"/>
+                <a:ea typeface="Calibri" pitchFamily="34" charset="-122"/>
+                <a:cs typeface="Calibri" pitchFamily="34" charset="-120"/>
+              </a:rPr>
+              <a:t>Exit: egress SLA met 90%+; zero security incidents; parity scoreboard trending to done</a:t>
+            </a:r>
+            <a:endParaRPr lang="en-US" sz="980" dirty="0"/>
+          </a:p>
+        </p:txBody>
+      </p:sp>
+      <p:sp>
+        <p:nvSpPr>
+          <p:cNvPr id="18" name="Shape 16"/>
+          <p:cNvSpPr/>
+          <p:nvPr/>
+        </p:nvSpPr>
+        <p:spPr>
+          <a:xfrm>
+            <a:off x="9040901" y="1691640"/>
+            <a:ext cx="2602154" cy="4206240"/>
+          </a:xfrm>
+          <a:prstGeom prst="roundRect">
+            <a:avLst>
+              <a:gd name="adj" fmla="val 2811"/>
+            </a:avLst>
+          </a:prstGeom>
+          <a:solidFill>
+            <a:srgbClr val="EAF4EF"/>
+          </a:solidFill>
+          <a:ln/>
+          <a:effectLst>
+            <a:outerShdw sx="100000" sy="100000" kx="0" ky="0" algn="bl" rotWithShape="0" blurRad="76200" dist="12700" dir="5400000">
+              <a:srgbClr val="9AA7C4">
+                <a:alpha val="25000"/>
+              </a:srgbClr>
+            </a:outerShdw>
+          </a:effectLst>
+        </p:spPr>
+      </p:sp>
+      <p:sp>
+        <p:nvSpPr>
+          <p:cNvPr id="19" name="Text 17"/>
+          <p:cNvSpPr/>
+          <p:nvPr/>
+        </p:nvSpPr>
+        <p:spPr>
+          <a:xfrm>
+            <a:off x="9223781" y="1828800"/>
+            <a:ext cx="2236394" cy="274320"/>
+          </a:xfrm>
+          <a:prstGeom prst="rect">
+            <a:avLst/>
+          </a:prstGeom>
+          <a:noFill/>
+          <a:ln/>
+        </p:spPr>
+        <p:txBody>
+          <a:bodyPr wrap="square" lIns="0" tIns="0" rIns="0" bIns="0" rtlCol="0" anchor="ctr"/>
+          <a:lstStyle/>
+          <a:p>
+            <a:pPr indent="0" marL="0">
+              <a:buNone/>
+            </a:pPr>
+            <a:r>
+              <a:rPr lang="en-US" sz="1100" b="1" spc="200" kern="0" dirty="0">
+                <a:solidFill>
+                  <a:srgbClr val="2E7D5B"/>
+                </a:solidFill>
+                <a:latin typeface="Calibri" pitchFamily="34" charset="0"/>
+                <a:ea typeface="Calibri" pitchFamily="34" charset="-122"/>
+                <a:cs typeface="Calibri" pitchFamily="34" charset="-120"/>
+              </a:rPr>
+              <a:t>PHASE 3</a:t>
+            </a:r>
+            <a:endParaRPr lang="en-US" sz="1100" dirty="0"/>
+          </a:p>
+        </p:txBody>
+      </p:sp>
+      <p:sp>
+        <p:nvSpPr>
+          <p:cNvPr id="20" name="Text 18"/>
+          <p:cNvSpPr/>
+          <p:nvPr/>
+        </p:nvSpPr>
+        <p:spPr>
+          <a:xfrm>
+            <a:off x="9223781" y="2103120"/>
+            <a:ext cx="2236394" cy="685800"/>
+          </a:xfrm>
+          <a:prstGeom prst="rect">
+            <a:avLst/>
+          </a:prstGeom>
+          <a:noFill/>
+          <a:ln/>
+        </p:spPr>
+        <p:txBody>
+          <a:bodyPr wrap="square" lIns="0" tIns="0" rIns="0" bIns="0" rtlCol="0" anchor="ctr"/>
+          <a:lstStyle/>
+          <a:p>
+            <a:pPr indent="0" marL="0">
+              <a:buNone/>
+            </a:pPr>
+            <a:r>
+              <a:rPr lang="en-US" sz="1350" b="1" dirty="0">
+                <a:solidFill>
+                  <a:srgbClr val="1E2761"/>
+                </a:solidFill>
+                <a:latin typeface="Calibri" pitchFamily="34" charset="0"/>
+                <a:ea typeface="Calibri" pitchFamily="34" charset="-122"/>
+                <a:cs typeface="Calibri" pitchFamily="34" charset="-120"/>
+              </a:rPr>
+              <a:t>Core-team absorption</a:t>
+            </a:r>
+            <a:endParaRPr lang="en-US" sz="1350" dirty="0"/>
+          </a:p>
+          <a:p>
+            <a:pPr indent="0" marL="0">
+              <a:buNone/>
+            </a:pPr>
+            <a:r>
+              <a:rPr lang="en-US" sz="1350" b="1" dirty="0">
+                <a:solidFill>
+                  <a:srgbClr val="1E2761"/>
+                </a:solidFill>
+                <a:latin typeface="Calibri" pitchFamily="34" charset="0"/>
+                <a:ea typeface="Calibri" pitchFamily="34" charset="-122"/>
+                <a:cs typeface="Calibri" pitchFamily="34" charset="-120"/>
+              </a:rPr>
+              <a:t>(trigger-based)</a:t>
+            </a:r>
+            <a:endParaRPr lang="en-US" sz="1350" dirty="0"/>
+          </a:p>
+        </p:txBody>
+      </p:sp>
+      <p:sp>
+        <p:nvSpPr>
+          <p:cNvPr id="21" name="Text 19"/>
+          <p:cNvSpPr/>
+          <p:nvPr/>
+        </p:nvSpPr>
+        <p:spPr>
+          <a:xfrm>
+            <a:off x="9223781" y="2880360"/>
+            <a:ext cx="2236394" cy="2834640"/>
+          </a:xfrm>
+          <a:prstGeom prst="rect">
+            <a:avLst/>
+          </a:prstGeom>
+          <a:noFill/>
+          <a:ln/>
+        </p:spPr>
+        <p:txBody>
+          <a:bodyPr wrap="square" lIns="0" tIns="0" rIns="0" bIns="0" rtlCol="0" anchor="ctr"/>
+          <a:lstStyle/>
+          <a:p>
+            <a:pPr marL="342900" indent="-342900">
+              <a:spcAft>
+                <a:spcPts val="600"/>
+              </a:spcAft>
+              <a:buSzPct val="100000"/>
+              <a:buChar char="•"/>
+            </a:pPr>
+            <a:r>
+              <a:rPr lang="en-US" sz="980" dirty="0">
+                <a:solidFill>
+                  <a:srgbClr val="1B2440"/>
+                </a:solidFill>
+                <a:latin typeface="Calibri" pitchFamily="34" charset="0"/>
+                <a:ea typeface="Calibri" pitchFamily="34" charset="-122"/>
+                <a:cs typeface="Calibri" pitchFamily="34" charset="-120"/>
+              </a:rPr>
+              <a:t>Trigger: contractor reduction mandate — readiness is built in Phases 1–2, not when the memo lands</a:t>
+            </a:r>
+            <a:endParaRPr lang="en-US" sz="980" dirty="0"/>
+          </a:p>
+          <a:p>
+            <a:pPr marL="342900" indent="-342900">
+              <a:spcAft>
+                <a:spcPts val="600"/>
+              </a:spcAft>
+              <a:buSzPct val="100000"/>
+              <a:buChar char="•"/>
+            </a:pPr>
+            <a:r>
+              <a:rPr lang="en-US" sz="980" dirty="0">
+                <a:solidFill>
+                  <a:srgbClr val="1B2440"/>
+                </a:solidFill>
+                <a:latin typeface="Calibri" pitchFamily="34" charset="0"/>
+                <a:ea typeface="Calibri" pitchFamily="34" charset="-122"/>
+                <a:cs typeface="Calibri" pitchFamily="34" charset="-120"/>
+              </a:rPr>
+              <a:t>Every contractor duty has a documented runbook + a core-team owner who has already done it (rotation in Phase 2)</a:t>
+            </a:r>
+            <a:endParaRPr lang="en-US" sz="980" dirty="0"/>
+          </a:p>
+          <a:p>
+            <a:pPr marL="342900" indent="-342900">
+              <a:spcAft>
+                <a:spcPts val="600"/>
+              </a:spcAft>
+              <a:buSzPct val="100000"/>
+              <a:buChar char="•"/>
+            </a:pPr>
+            <a:r>
+              <a:rPr lang="en-US" sz="980" dirty="0">
+                <a:solidFill>
+                  <a:srgbClr val="1B2440"/>
+                </a:solidFill>
+                <a:latin typeface="Calibri" pitchFamily="34" charset="0"/>
+                <a:ea typeface="Calibri" pitchFamily="34" charset="-122"/>
+                <a:cs typeface="Calibri" pitchFamily="34" charset="-120"/>
+              </a:rPr>
+              <a:t>Automate the residue: integration scripts, mapping validators, config lint</a:t>
+            </a:r>
+            <a:endParaRPr lang="en-US" sz="980" dirty="0"/>
+          </a:p>
+          <a:p>
+            <a:pPr marL="342900" indent="-342900">
+              <a:spcAft>
+                <a:spcPts val="600"/>
+              </a:spcAft>
+              <a:buSzPct val="100000"/>
+              <a:buChar char="•"/>
+            </a:pPr>
+            <a:r>
+              <a:rPr lang="en-US" sz="980" dirty="0">
+                <a:solidFill>
+                  <a:srgbClr val="1B2440"/>
+                </a:solidFill>
+                <a:latin typeface="Calibri" pitchFamily="34" charset="0"/>
+                <a:ea typeface="Calibri" pitchFamily="34" charset="-122"/>
+                <a:cs typeface="Calibri" pitchFamily="34" charset="-120"/>
+              </a:rPr>
+              <a:t>Exit: full loop runs with core team only, one release proven</a:t>
+            </a:r>
+            <a:endParaRPr lang="en-US" sz="980" dirty="0"/>
+          </a:p>
+        </p:txBody>
+      </p:sp>
+      <p:sp>
+        <p:nvSpPr>
+          <p:cNvPr id="22" name="Text 20"/>
+          <p:cNvSpPr/>
+          <p:nvPr/>
+        </p:nvSpPr>
+        <p:spPr>
+          <a:xfrm>
+            <a:off x="548640" y="6035040"/>
+            <a:ext cx="11094415" cy="411480"/>
+          </a:xfrm>
+          <a:prstGeom prst="rect">
+            <a:avLst/>
+          </a:prstGeom>
+          <a:noFill/>
+          <a:ln/>
+        </p:spPr>
+        <p:txBody>
+          <a:bodyPr wrap="square" lIns="0" tIns="0" rIns="0" bIns="0" rtlCol="0" anchor="ctr"/>
+          <a:lstStyle/>
+          <a:p>
+            <a:pPr algn="ctr" indent="0" marL="0">
+              <a:buNone/>
+            </a:pPr>
+            <a:r>
+              <a:rPr lang="en-US" sz="1250" b="1" dirty="0">
+                <a:solidFill>
+                  <a:srgbClr val="1E2761"/>
+                </a:solidFill>
+                <a:latin typeface="Calibri" pitchFamily="34" charset="0"/>
+                <a:ea typeface="Calibri" pitchFamily="34" charset="-122"/>
+                <a:cs typeface="Calibri" pitchFamily="34" charset="-120"/>
+              </a:rPr>
+              <a:t>Honest expectation: </a:t>
+            </a:r>
+            <a:pPr algn="ctr" indent="0" marL="0">
+              <a:buNone/>
+            </a:pPr>
+            <a:r>
+              <a:rPr lang="en-US" sz="1250" dirty="0">
+                <a:solidFill>
+                  <a:srgbClr val="1B2440"/>
+                </a:solidFill>
+                <a:latin typeface="Calibri" pitchFamily="34" charset="0"/>
+                <a:ea typeface="Calibri" pitchFamily="34" charset="-122"/>
+                <a:cs typeface="Calibri" pitchFamily="34" charset="-120"/>
+              </a:rPr>
+              <a:t>the first loop will be slower than today — you are building the factory while running it. Speed compounds from MFE #3 onward. Say this out loud on day one, or month 3 will be read as failure.</a:t>
+            </a:r>
+            <a:endParaRPr lang="en-US" sz="1250" dirty="0"/>
+          </a:p>
+        </p:txBody>
+      </p:sp>
+    </p:spTree>
+  </p:cSld>
+  <p:clrMapOvr>
+    <a:masterClrMapping/>
+  </p:clrMapOvr>
+</p:sld>
+</file>
+
+<file path=ppt/slides/slide17.xml><?xml version="1.0" encoding="utf-8"?>
+<p:sld xmlns:a="http://schemas.openxmlformats.org/drawingml/2006/main" xmlns:r="http://schemas.openxmlformats.org/officeDocument/2006/relationships" xmlns:p="http://schemas.openxmlformats.org/presentationml/2006/main">
+  <p:cSld name="Slide 17">
+    <p:bg>
+      <p:bgPr>
+        <a:solidFill>
+          <a:srgbClr val="FFFFFF"/>
+        </a:solidFill>
+      </p:bgPr>
+    </p:bg>
+    <p:spTree>
+      <p:nvGrpSpPr>
+        <p:cNvPr id="1" name=""/>
+        <p:cNvGrpSpPr/>
+        <p:nvPr/>
+      </p:nvGrpSpPr>
+      <p:grpSpPr>
+        <a:xfrm>
+          <a:off x="0" y="0"/>
+          <a:ext cx="0" cy="0"/>
+          <a:chOff x="0" y="0"/>
+          <a:chExt cx="0" cy="0"/>
+        </a:xfrm>
+      </p:grpSpPr>
+      <p:sp>
+        <p:nvSpPr>
+          <p:cNvPr id="2" name="Text 0"/>
+          <p:cNvSpPr/>
+          <p:nvPr/>
+        </p:nvSpPr>
+        <p:spPr>
+          <a:xfrm>
+            <a:off x="548640" y="6473952"/>
+            <a:ext cx="3657600" cy="274320"/>
+          </a:xfrm>
+          <a:prstGeom prst="rect">
+            <a:avLst/>
+          </a:prstGeom>
+          <a:noFill/>
+          <a:ln/>
+        </p:spPr>
+        <p:txBody>
+          <a:bodyPr wrap="square" lIns="0" tIns="0" rIns="0" bIns="0" rtlCol="0" anchor="ctr"/>
+          <a:lstStyle/>
+          <a:p>
+            <a:pPr algn="l" indent="0" marL="0">
+              <a:buNone/>
+            </a:pPr>
+            <a:r>
+              <a:rPr lang="en-US" sz="900" dirty="0">
+                <a:solidFill>
+                  <a:srgbClr val="5A6B8C"/>
+                </a:solidFill>
+                <a:latin typeface="Calibri" pitchFamily="34" charset="0"/>
+                <a:ea typeface="Calibri" pitchFamily="34" charset="-122"/>
+                <a:cs typeface="Calibri" pitchFamily="34" charset="-120"/>
+              </a:rPr>
+              <a:t>Internet-First, Airgap-Final</a:t>
+            </a:r>
+            <a:endParaRPr lang="en-US" sz="900" dirty="0"/>
+          </a:p>
+        </p:txBody>
+      </p:sp>
+      <p:sp>
+        <p:nvSpPr>
+          <p:cNvPr id="3" name="Text 1"/>
+          <p:cNvSpPr/>
+          <p:nvPr/>
+        </p:nvSpPr>
+        <p:spPr>
+          <a:xfrm>
+            <a:off x="11094415" y="6473952"/>
+            <a:ext cx="548640" cy="274320"/>
+          </a:xfrm>
+          <a:prstGeom prst="rect">
+            <a:avLst/>
+          </a:prstGeom>
+          <a:noFill/>
+          <a:ln/>
+        </p:spPr>
+        <p:txBody>
+          <a:bodyPr wrap="square" lIns="0" tIns="0" rIns="0" bIns="0" rtlCol="0" anchor="ctr"/>
+          <a:lstStyle/>
+          <a:p>
+            <a:pPr algn="r" indent="0" marL="0">
+              <a:buNone/>
+            </a:pPr>
+            <a:r>
+              <a:rPr lang="en-US" sz="900" dirty="0">
+                <a:solidFill>
+                  <a:srgbClr val="5A6B8C"/>
+                </a:solidFill>
+                <a:latin typeface="Calibri" pitchFamily="34" charset="0"/>
+                <a:ea typeface="Calibri" pitchFamily="34" charset="-122"/>
+                <a:cs typeface="Calibri" pitchFamily="34" charset="-120"/>
+              </a:rPr>
+              <a:t>17</a:t>
+            </a:r>
+            <a:endParaRPr lang="en-US" sz="900" dirty="0"/>
+          </a:p>
+        </p:txBody>
+      </p:sp>
+      <p:sp>
+        <p:nvSpPr>
+          <p:cNvPr id="4" name="Text 2"/>
+          <p:cNvSpPr/>
+          <p:nvPr/>
+        </p:nvSpPr>
+        <p:spPr>
+          <a:xfrm>
+            <a:off x="548640" y="384048"/>
+            <a:ext cx="11094415" cy="274320"/>
+          </a:xfrm>
+          <a:prstGeom prst="rect">
+            <a:avLst/>
+          </a:prstGeom>
+          <a:noFill/>
+          <a:ln/>
+        </p:spPr>
+        <p:txBody>
+          <a:bodyPr wrap="square" lIns="0" tIns="0" rIns="0" bIns="0" rtlCol="0" anchor="ctr"/>
+          <a:lstStyle/>
+          <a:p>
+            <a:pPr indent="0" marL="0">
+              <a:buNone/>
+            </a:pPr>
+            <a:r>
+              <a:rPr lang="en-US" sz="1200" b="1" spc="300" kern="0" dirty="0">
+                <a:solidFill>
+                  <a:srgbClr val="5A6B8C"/>
+                </a:solidFill>
+                <a:latin typeface="Calibri" pitchFamily="34" charset="0"/>
+                <a:ea typeface="Calibri" pitchFamily="34" charset="-122"/>
+                <a:cs typeface="Calibri" pitchFamily="34" charset="-120"/>
+              </a:rPr>
+              <a:t>MEASURING IT · THE COUNTER-NARRATIVE</a:t>
+            </a:r>
+            <a:endParaRPr lang="en-US" sz="1200" dirty="0"/>
+          </a:p>
+        </p:txBody>
+      </p:sp>
+      <p:sp>
+        <p:nvSpPr>
+          <p:cNvPr id="5" name="Text 3"/>
+          <p:cNvSpPr/>
+          <p:nvPr/>
+        </p:nvSpPr>
+        <p:spPr>
+          <a:xfrm>
+            <a:off x="548640" y="658368"/>
+            <a:ext cx="11094415" cy="621792"/>
+          </a:xfrm>
+          <a:prstGeom prst="rect">
+            <a:avLst/>
+          </a:prstGeom>
+          <a:noFill/>
+          <a:ln/>
+        </p:spPr>
+        <p:txBody>
+          <a:bodyPr wrap="square" lIns="0" tIns="0" rIns="0" bIns="0" rtlCol="0" anchor="t"/>
+          <a:lstStyle/>
+          <a:p>
+            <a:pPr indent="0" marL="0">
+              <a:buNone/>
+            </a:pPr>
+            <a:r>
+              <a:rPr lang="en-US" sz="3000" b="1" dirty="0">
+                <a:solidFill>
+                  <a:srgbClr val="1E2761"/>
+                </a:solidFill>
+                <a:latin typeface="Cambria" pitchFamily="34" charset="0"/>
+                <a:ea typeface="Cambria" pitchFamily="34" charset="-122"/>
+                <a:cs typeface="Cambria" pitchFamily="34" charset="-120"/>
+              </a:rPr>
+              <a:t>The scoreboard that wins the argument</a:t>
+            </a:r>
+            <a:endParaRPr lang="en-US" sz="3000" dirty="0"/>
+          </a:p>
+        </p:txBody>
+      </p:sp>
+      <p:sp>
+        <p:nvSpPr>
+          <p:cNvPr id="6" name="Shape 4"/>
+          <p:cNvSpPr/>
+          <p:nvPr/>
+        </p:nvSpPr>
+        <p:spPr>
+          <a:xfrm>
+            <a:off x="548640" y="1691640"/>
+            <a:ext cx="3515258" cy="2011680"/>
+          </a:xfrm>
+          <a:prstGeom prst="roundRect">
+            <a:avLst>
+              <a:gd name="adj" fmla="val 3636"/>
+            </a:avLst>
+          </a:prstGeom>
+          <a:solidFill>
+            <a:srgbClr val="EDF3FC"/>
+          </a:solidFill>
+          <a:ln/>
+          <a:effectLst>
+            <a:outerShdw sx="100000" sy="100000" kx="0" ky="0" algn="bl" rotWithShape="0" blurRad="76200" dist="12700" dir="5400000">
+              <a:srgbClr val="9AA7C4">
+                <a:alpha val="25000"/>
+              </a:srgbClr>
+            </a:outerShdw>
+          </a:effectLst>
+        </p:spPr>
+      </p:sp>
+      <p:sp>
+        <p:nvSpPr>
+          <p:cNvPr id="7" name="Shape 5"/>
+          <p:cNvSpPr/>
+          <p:nvPr/>
+        </p:nvSpPr>
+        <p:spPr>
+          <a:xfrm>
+            <a:off x="749808" y="1892808"/>
+            <a:ext cx="502920" cy="502920"/>
+          </a:xfrm>
+          <a:prstGeom prst="ellipse">
+            <a:avLst/>
+          </a:prstGeom>
+          <a:solidFill>
+            <a:srgbClr val="1E2761"/>
+          </a:solidFill>
+          <a:ln/>
+        </p:spPr>
+      </p:sp>
+      <p:pic>
+        <p:nvPicPr>
+          <p:cNvPr id="8" name="Image 0" descr="preencoded.png">    </p:cNvPr>
+          <p:cNvPicPr>
+            <a:picLocks noChangeAspect="1"/>
+          </p:cNvPicPr>
+          <p:nvPr/>
+        </p:nvPicPr>
+        <p:blipFill>
+          <a:blip r:embed="rId1"/>
+          <a:stretch>
+            <a:fillRect/>
+          </a:stretch>
+        </p:blipFill>
+        <p:spPr>
+          <a:xfrm>
+            <a:off x="880567" y="2023567"/>
+            <a:ext cx="241402" cy="241402"/>
+          </a:xfrm>
+          <a:prstGeom prst="rect">
+            <a:avLst/>
+          </a:prstGeom>
+        </p:spPr>
+      </p:pic>
+      <p:sp>
+        <p:nvSpPr>
+          <p:cNvPr id="9" name="Text 6"/>
+          <p:cNvSpPr/>
+          <p:nvPr/>
+        </p:nvSpPr>
+        <p:spPr>
+          <a:xfrm>
+            <a:off x="1389888" y="1947672"/>
+            <a:ext cx="2509418" cy="384048"/>
+          </a:xfrm>
+          <a:prstGeom prst="rect">
+            <a:avLst/>
+          </a:prstGeom>
+          <a:noFill/>
+          <a:ln/>
+        </p:spPr>
+        <p:txBody>
+          <a:bodyPr wrap="square" lIns="0" tIns="0" rIns="0" bIns="0" rtlCol="0" anchor="ctr"/>
+          <a:lstStyle/>
+          <a:p>
+            <a:pPr indent="0" marL="0">
+              <a:buNone/>
+            </a:pPr>
+            <a:r>
+              <a:rPr lang="en-US" sz="1450" b="1" dirty="0">
+                <a:solidFill>
+                  <a:srgbClr val="1E2761"/>
+                </a:solidFill>
+                <a:latin typeface="Calibri" pitchFamily="34" charset="0"/>
+                <a:ea typeface="Calibri" pitchFamily="34" charset="-122"/>
+                <a:cs typeface="Calibri" pitchFamily="34" charset="-120"/>
+              </a:rPr>
+              <a:t>Lead time</a:t>
+            </a:r>
+            <a:endParaRPr lang="en-US" sz="1450" dirty="0"/>
+          </a:p>
+        </p:txBody>
+      </p:sp>
+      <p:sp>
+        <p:nvSpPr>
+          <p:cNvPr id="10" name="Text 7"/>
+          <p:cNvSpPr/>
+          <p:nvPr/>
+        </p:nvSpPr>
+        <p:spPr>
+          <a:xfrm>
+            <a:off x="777240" y="2468880"/>
+            <a:ext cx="3058058" cy="1051560"/>
+          </a:xfrm>
+          <a:prstGeom prst="rect">
+            <a:avLst/>
+          </a:prstGeom>
+          <a:noFill/>
+          <a:ln/>
+        </p:spPr>
+        <p:txBody>
+          <a:bodyPr wrap="square" lIns="0" tIns="0" rIns="0" bIns="0" rtlCol="0" anchor="ctr"/>
+          <a:lstStyle/>
+          <a:p>
+            <a:pPr indent="0" marL="0">
+              <a:buNone/>
+            </a:pPr>
+            <a:r>
+              <a:rPr lang="en-US" sz="1100" dirty="0">
+                <a:solidFill>
+                  <a:srgbClr val="1B2440"/>
+                </a:solidFill>
+                <a:latin typeface="Calibri" pitchFamily="34" charset="0"/>
+                <a:ea typeface="Calibri" pitchFamily="34" charset="-122"/>
+                <a:cs typeface="Calibri" pitchFamily="34" charset="-120"/>
+              </a:rPr>
+              <a:t>Spec-frozen → running in Confi, per feature. The headline number stakeholders compare against “days”. Target: weeks, trending down every quarter.</a:t>
+            </a:r>
+            <a:endParaRPr lang="en-US" sz="1100" dirty="0"/>
+          </a:p>
+        </p:txBody>
+      </p:sp>
+      <p:sp>
+        <p:nvSpPr>
+          <p:cNvPr id="11" name="Shape 8"/>
+          <p:cNvSpPr/>
+          <p:nvPr/>
+        </p:nvSpPr>
+        <p:spPr>
+          <a:xfrm>
+            <a:off x="4338218" y="1691640"/>
+            <a:ext cx="3515258" cy="2011680"/>
+          </a:xfrm>
+          <a:prstGeom prst="roundRect">
+            <a:avLst>
+              <a:gd name="adj" fmla="val 3636"/>
+            </a:avLst>
+          </a:prstGeom>
+          <a:solidFill>
+            <a:srgbClr val="EDF3FC"/>
+          </a:solidFill>
+          <a:ln/>
+          <a:effectLst>
+            <a:outerShdw sx="100000" sy="100000" kx="0" ky="0" algn="bl" rotWithShape="0" blurRad="76200" dist="12700" dir="5400000">
+              <a:srgbClr val="9AA7C4">
+                <a:alpha val="25000"/>
+              </a:srgbClr>
+            </a:outerShdw>
+          </a:effectLst>
+        </p:spPr>
+      </p:sp>
+      <p:sp>
+        <p:nvSpPr>
+          <p:cNvPr id="12" name="Shape 9"/>
+          <p:cNvSpPr/>
+          <p:nvPr/>
+        </p:nvSpPr>
+        <p:spPr>
+          <a:xfrm>
+            <a:off x="4539386" y="1892808"/>
+            <a:ext cx="502920" cy="502920"/>
+          </a:xfrm>
+          <a:prstGeom prst="ellipse">
+            <a:avLst/>
+          </a:prstGeom>
+          <a:solidFill>
+            <a:srgbClr val="1E2761"/>
+          </a:solidFill>
+          <a:ln/>
+        </p:spPr>
+      </p:sp>
+      <p:pic>
+        <p:nvPicPr>
+          <p:cNvPr id="13" name="Image 1" descr="preencoded.png">    </p:cNvPr>
+          <p:cNvPicPr>
+            <a:picLocks noChangeAspect="1"/>
+          </p:cNvPicPr>
+          <p:nvPr/>
+        </p:nvPicPr>
+        <p:blipFill>
+          <a:blip r:embed="rId2"/>
+          <a:stretch>
+            <a:fillRect/>
+          </a:stretch>
+        </p:blipFill>
+        <p:spPr>
+          <a:xfrm>
+            <a:off x="4670146" y="2023567"/>
+            <a:ext cx="241402" cy="241402"/>
+          </a:xfrm>
+          <a:prstGeom prst="rect">
+            <a:avLst/>
+          </a:prstGeom>
+        </p:spPr>
+      </p:pic>
+      <p:sp>
+        <p:nvSpPr>
+          <p:cNvPr id="14" name="Text 10"/>
+          <p:cNvSpPr/>
+          <p:nvPr/>
+        </p:nvSpPr>
+        <p:spPr>
+          <a:xfrm>
+            <a:off x="5179466" y="1947672"/>
+            <a:ext cx="2509418" cy="384048"/>
+          </a:xfrm>
+          <a:prstGeom prst="rect">
+            <a:avLst/>
+          </a:prstGeom>
+          <a:noFill/>
+          <a:ln/>
+        </p:spPr>
+        <p:txBody>
+          <a:bodyPr wrap="square" lIns="0" tIns="0" rIns="0" bIns="0" rtlCol="0" anchor="ctr"/>
+          <a:lstStyle/>
+          <a:p>
+            <a:pPr indent="0" marL="0">
+              <a:buNone/>
+            </a:pPr>
+            <a:r>
+              <a:rPr lang="en-US" sz="1450" b="1" dirty="0">
+                <a:solidFill>
+                  <a:srgbClr val="1E2761"/>
+                </a:solidFill>
+                <a:latin typeface="Calibri" pitchFamily="34" charset="0"/>
+                <a:ea typeface="Calibri" pitchFamily="34" charset="-122"/>
+                <a:cs typeface="Calibri" pitchFamily="34" charset="-120"/>
+              </a:rPr>
+              <a:t>Integration tax</a:t>
+            </a:r>
+            <a:endParaRPr lang="en-US" sz="1450" dirty="0"/>
+          </a:p>
+        </p:txBody>
+      </p:sp>
+      <p:sp>
+        <p:nvSpPr>
+          <p:cNvPr id="15" name="Text 11"/>
+          <p:cNvSpPr/>
+          <p:nvPr/>
+        </p:nvSpPr>
+        <p:spPr>
+          <a:xfrm>
+            <a:off x="4566818" y="2468880"/>
+            <a:ext cx="3058058" cy="1051560"/>
+          </a:xfrm>
+          <a:prstGeom prst="rect">
+            <a:avLst/>
+          </a:prstGeom>
+          <a:noFill/>
+          <a:ln/>
+        </p:spPr>
+        <p:txBody>
+          <a:bodyPr wrap="square" lIns="0" tIns="0" rIns="0" bIns="0" rtlCol="0" anchor="ctr"/>
+          <a:lstStyle/>
+          <a:p>
+            <a:pPr indent="0" marL="0">
+              <a:buNone/>
+            </a:pPr>
+            <a:r>
+              <a:rPr lang="en-US" sz="1100" dirty="0">
+                <a:solidFill>
+                  <a:srgbClr val="1B2440"/>
+                </a:solidFill>
+                <a:latin typeface="Calibri" pitchFamily="34" charset="0"/>
+                <a:ea typeface="Calibri" pitchFamily="34" charset="-122"/>
+                <a:cs typeface="Calibri" pitchFamily="34" charset="-120"/>
+              </a:rPr>
+              <a:t>% of feature effort spent inside after the tag lands. The paradigm's core health metric. Target ≤ 15%; rising = spec/mock/pack drift.</a:t>
+            </a:r>
+            <a:endParaRPr lang="en-US" sz="1100" dirty="0"/>
+          </a:p>
+        </p:txBody>
+      </p:sp>
+      <p:sp>
+        <p:nvSpPr>
+          <p:cNvPr id="16" name="Shape 12"/>
+          <p:cNvSpPr/>
+          <p:nvPr/>
+        </p:nvSpPr>
+        <p:spPr>
+          <a:xfrm>
+            <a:off x="8127797" y="1691640"/>
+            <a:ext cx="3515258" cy="2011680"/>
+          </a:xfrm>
+          <a:prstGeom prst="roundRect">
+            <a:avLst>
+              <a:gd name="adj" fmla="val 3636"/>
+            </a:avLst>
+          </a:prstGeom>
+          <a:solidFill>
+            <a:srgbClr val="EDF3FC"/>
+          </a:solidFill>
+          <a:ln/>
+          <a:effectLst>
+            <a:outerShdw sx="100000" sy="100000" kx="0" ky="0" algn="bl" rotWithShape="0" blurRad="76200" dist="12700" dir="5400000">
+              <a:srgbClr val="9AA7C4">
+                <a:alpha val="25000"/>
+              </a:srgbClr>
+            </a:outerShdw>
+          </a:effectLst>
+        </p:spPr>
+      </p:sp>
+      <p:sp>
+        <p:nvSpPr>
+          <p:cNvPr id="17" name="Shape 13"/>
+          <p:cNvSpPr/>
+          <p:nvPr/>
+        </p:nvSpPr>
+        <p:spPr>
+          <a:xfrm>
+            <a:off x="8328965" y="1892808"/>
+            <a:ext cx="502920" cy="502920"/>
+          </a:xfrm>
+          <a:prstGeom prst="ellipse">
+            <a:avLst/>
+          </a:prstGeom>
+          <a:solidFill>
+            <a:srgbClr val="1E2761"/>
+          </a:solidFill>
+          <a:ln/>
+        </p:spPr>
+      </p:sp>
+      <p:pic>
+        <p:nvPicPr>
+          <p:cNvPr id="18" name="Image 2" descr="preencoded.png">    </p:cNvPr>
+          <p:cNvPicPr>
+            <a:picLocks noChangeAspect="1"/>
+          </p:cNvPicPr>
+          <p:nvPr/>
+        </p:nvPicPr>
+        <p:blipFill>
+          <a:blip r:embed="rId3"/>
+          <a:stretch>
+            <a:fillRect/>
+          </a:stretch>
+        </p:blipFill>
+        <p:spPr>
+          <a:xfrm>
+            <a:off x="8459724" y="2023567"/>
+            <a:ext cx="241402" cy="241402"/>
+          </a:xfrm>
+          <a:prstGeom prst="rect">
+            <a:avLst/>
+          </a:prstGeom>
+        </p:spPr>
+      </p:pic>
+      <p:sp>
+        <p:nvSpPr>
+          <p:cNvPr id="19" name="Text 14"/>
+          <p:cNvSpPr/>
+          <p:nvPr/>
+        </p:nvSpPr>
+        <p:spPr>
+          <a:xfrm>
+            <a:off x="8969045" y="1947672"/>
+            <a:ext cx="2509418" cy="384048"/>
+          </a:xfrm>
+          <a:prstGeom prst="rect">
+            <a:avLst/>
+          </a:prstGeom>
+          <a:noFill/>
+          <a:ln/>
+        </p:spPr>
+        <p:txBody>
+          <a:bodyPr wrap="square" lIns="0" tIns="0" rIns="0" bIns="0" rtlCol="0" anchor="ctr"/>
+          <a:lstStyle/>
+          <a:p>
+            <a:pPr indent="0" marL="0">
+              <a:buNone/>
+            </a:pPr>
+            <a:r>
+              <a:rPr lang="en-US" sz="1450" b="1" dirty="0">
+                <a:solidFill>
+                  <a:srgbClr val="1E2761"/>
+                </a:solidFill>
+                <a:latin typeface="Calibri" pitchFamily="34" charset="0"/>
+                <a:ea typeface="Calibri" pitchFamily="34" charset="-122"/>
+                <a:cs typeface="Calibri" pitchFamily="34" charset="-120"/>
+              </a:rPr>
+              <a:t>Egress SLA &amp; yield</a:t>
+            </a:r>
+            <a:endParaRPr lang="en-US" sz="1450" dirty="0"/>
+          </a:p>
+        </p:txBody>
+      </p:sp>
+      <p:sp>
+        <p:nvSpPr>
+          <p:cNvPr id="20" name="Text 15"/>
+          <p:cNvSpPr/>
+          <p:nvPr/>
+        </p:nvSpPr>
+        <p:spPr>
+          <a:xfrm>
+            <a:off x="8356397" y="2468880"/>
+            <a:ext cx="3058058" cy="1051560"/>
+          </a:xfrm>
+          <a:prstGeom prst="rect">
+            <a:avLst/>
+          </a:prstGeom>
+          <a:noFill/>
+          <a:ln/>
+        </p:spPr>
+        <p:txBody>
+          <a:bodyPr wrap="square" lIns="0" tIns="0" rIns="0" bIns="0" rtlCol="0" anchor="ctr"/>
+          <a:lstStyle/>
+          <a:p>
+            <a:pPr indent="0" marL="0">
+              <a:buNone/>
+            </a:pPr>
+            <a:r>
+              <a:rPr lang="en-US" sz="1100" dirty="0">
+                <a:solidFill>
+                  <a:srgbClr val="1B2440"/>
+                </a:solidFill>
+                <a:latin typeface="Calibri" pitchFamily="34" charset="0"/>
+                <a:ea typeface="Calibri" pitchFamily="34" charset="-122"/>
+                <a:cs typeface="Calibri" pitchFamily="34" charset="-120"/>
+              </a:rPr>
+              <a:t>Gate turnaround vs. matrix targets, and % of packages passing Gate 0 clean first try. Falling yield = checklist or tooling gap.</a:t>
+            </a:r>
+            <a:endParaRPr lang="en-US" sz="1100" dirty="0"/>
+          </a:p>
+        </p:txBody>
+      </p:sp>
+      <p:sp>
+        <p:nvSpPr>
+          <p:cNvPr id="21" name="Shape 16"/>
+          <p:cNvSpPr/>
+          <p:nvPr/>
+        </p:nvSpPr>
+        <p:spPr>
+          <a:xfrm>
+            <a:off x="548640" y="3886200"/>
+            <a:ext cx="3515258" cy="2011680"/>
+          </a:xfrm>
+          <a:prstGeom prst="roundRect">
+            <a:avLst>
+              <a:gd name="adj" fmla="val 3636"/>
+            </a:avLst>
+          </a:prstGeom>
+          <a:solidFill>
+            <a:srgbClr val="EDF3FC"/>
+          </a:solidFill>
+          <a:ln/>
+          <a:effectLst>
+            <a:outerShdw sx="100000" sy="100000" kx="0" ky="0" algn="bl" rotWithShape="0" blurRad="76200" dist="12700" dir="5400000">
+              <a:srgbClr val="9AA7C4">
+                <a:alpha val="25000"/>
+              </a:srgbClr>
+            </a:outerShdw>
+          </a:effectLst>
+        </p:spPr>
+      </p:sp>
+      <p:sp>
+        <p:nvSpPr>
+          <p:cNvPr id="22" name="Shape 17"/>
+          <p:cNvSpPr/>
+          <p:nvPr/>
+        </p:nvSpPr>
+        <p:spPr>
+          <a:xfrm>
+            <a:off x="749808" y="4087368"/>
+            <a:ext cx="502920" cy="502920"/>
+          </a:xfrm>
+          <a:prstGeom prst="ellipse">
+            <a:avLst/>
+          </a:prstGeom>
+          <a:solidFill>
+            <a:srgbClr val="1E2761"/>
+          </a:solidFill>
+          <a:ln/>
+        </p:spPr>
+      </p:sp>
+      <p:pic>
+        <p:nvPicPr>
+          <p:cNvPr id="23" name="Image 3" descr="preencoded.png">    </p:cNvPr>
+          <p:cNvPicPr>
+            <a:picLocks noChangeAspect="1"/>
+          </p:cNvPicPr>
+          <p:nvPr/>
+        </p:nvPicPr>
+        <p:blipFill>
+          <a:blip r:embed="rId4"/>
+          <a:stretch>
+            <a:fillRect/>
+          </a:stretch>
+        </p:blipFill>
+        <p:spPr>
+          <a:xfrm>
+            <a:off x="880567" y="4218127"/>
+            <a:ext cx="241402" cy="241402"/>
+          </a:xfrm>
+          <a:prstGeom prst="rect">
+            <a:avLst/>
+          </a:prstGeom>
+        </p:spPr>
+      </p:pic>
+      <p:sp>
+        <p:nvSpPr>
+          <p:cNvPr id="24" name="Text 18"/>
+          <p:cNvSpPr/>
+          <p:nvPr/>
+        </p:nvSpPr>
+        <p:spPr>
+          <a:xfrm>
+            <a:off x="1389888" y="4142232"/>
+            <a:ext cx="2509418" cy="384048"/>
+          </a:xfrm>
+          <a:prstGeom prst="rect">
+            <a:avLst/>
+          </a:prstGeom>
+          <a:noFill/>
+          <a:ln/>
+        </p:spPr>
+        <p:txBody>
+          <a:bodyPr wrap="square" lIns="0" tIns="0" rIns="0" bIns="0" rtlCol="0" anchor="ctr"/>
+          <a:lstStyle/>
+          <a:p>
+            <a:pPr indent="0" marL="0">
+              <a:buNone/>
+            </a:pPr>
+            <a:r>
+              <a:rPr lang="en-US" sz="1450" b="1" dirty="0">
+                <a:solidFill>
+                  <a:srgbClr val="1E2761"/>
+                </a:solidFill>
+                <a:latin typeface="Calibri" pitchFamily="34" charset="0"/>
+                <a:ea typeface="Calibri" pitchFamily="34" charset="-122"/>
+                <a:cs typeface="Calibri" pitchFamily="34" charset="-120"/>
+              </a:rPr>
+              <a:t>Pack coverage</a:t>
+            </a:r>
+            <a:endParaRPr lang="en-US" sz="1450" dirty="0"/>
+          </a:p>
+        </p:txBody>
+      </p:sp>
+      <p:sp>
+        <p:nvSpPr>
+          <p:cNvPr id="25" name="Text 19"/>
+          <p:cNvSpPr/>
+          <p:nvPr/>
+        </p:nvSpPr>
+        <p:spPr>
+          <a:xfrm>
+            <a:off x="777240" y="4663440"/>
+            <a:ext cx="3058058" cy="1051560"/>
+          </a:xfrm>
+          <a:prstGeom prst="rect">
+            <a:avLst/>
+          </a:prstGeom>
+          <a:noFill/>
+          <a:ln/>
+        </p:spPr>
+        <p:txBody>
+          <a:bodyPr wrap="square" lIns="0" tIns="0" rIns="0" bIns="0" rtlCol="0" anchor="ctr"/>
+          <a:lstStyle/>
+          <a:p>
+            <a:pPr indent="0" marL="0">
+              <a:buNone/>
+            </a:pPr>
+            <a:r>
+              <a:rPr lang="en-US" sz="1100" dirty="0">
+                <a:solidFill>
+                  <a:srgbClr val="1B2440"/>
+                </a:solidFill>
+                <a:latin typeface="Calibri" pitchFamily="34" charset="0"/>
+                <a:ea typeface="Calibri" pitchFamily="34" charset="-122"/>
+                <a:cs typeface="Calibri" pitchFamily="34" charset="-120"/>
+              </a:rPr>
+              <a:t>% of business rules expressed as logic-pack data vs. escape-hatch code. Higher = less inside-only work = Phase 3 readiness.</a:t>
+            </a:r>
+            <a:endParaRPr lang="en-US" sz="1100" dirty="0"/>
+          </a:p>
+        </p:txBody>
+      </p:sp>
+      <p:sp>
+        <p:nvSpPr>
+          <p:cNvPr id="26" name="Shape 20"/>
+          <p:cNvSpPr/>
+          <p:nvPr/>
+        </p:nvSpPr>
+        <p:spPr>
+          <a:xfrm>
+            <a:off x="4338218" y="3886200"/>
+            <a:ext cx="3515258" cy="2011680"/>
+          </a:xfrm>
+          <a:prstGeom prst="roundRect">
+            <a:avLst>
+              <a:gd name="adj" fmla="val 3636"/>
+            </a:avLst>
+          </a:prstGeom>
+          <a:solidFill>
+            <a:srgbClr val="EDF3FC"/>
+          </a:solidFill>
+          <a:ln/>
+          <a:effectLst>
+            <a:outerShdw sx="100000" sy="100000" kx="0" ky="0" algn="bl" rotWithShape="0" blurRad="76200" dist="12700" dir="5400000">
+              <a:srgbClr val="9AA7C4">
+                <a:alpha val="25000"/>
+              </a:srgbClr>
+            </a:outerShdw>
+          </a:effectLst>
+        </p:spPr>
+      </p:sp>
+      <p:sp>
+        <p:nvSpPr>
+          <p:cNvPr id="27" name="Shape 21"/>
+          <p:cNvSpPr/>
+          <p:nvPr/>
+        </p:nvSpPr>
+        <p:spPr>
+          <a:xfrm>
+            <a:off x="4539386" y="4087368"/>
+            <a:ext cx="502920" cy="502920"/>
+          </a:xfrm>
+          <a:prstGeom prst="ellipse">
+            <a:avLst/>
+          </a:prstGeom>
+          <a:solidFill>
+            <a:srgbClr val="1E2761"/>
+          </a:solidFill>
+          <a:ln/>
+        </p:spPr>
+      </p:sp>
+      <p:pic>
+        <p:nvPicPr>
+          <p:cNvPr id="28" name="Image 4" descr="preencoded.png">    </p:cNvPr>
+          <p:cNvPicPr>
+            <a:picLocks noChangeAspect="1"/>
+          </p:cNvPicPr>
+          <p:nvPr/>
+        </p:nvPicPr>
+        <p:blipFill>
+          <a:blip r:embed="rId5"/>
+          <a:stretch>
+            <a:fillRect/>
+          </a:stretch>
+        </p:blipFill>
+        <p:spPr>
+          <a:xfrm>
+            <a:off x="4670146" y="4218127"/>
+            <a:ext cx="241402" cy="241402"/>
+          </a:xfrm>
+          <a:prstGeom prst="rect">
+            <a:avLst/>
+          </a:prstGeom>
+        </p:spPr>
+      </p:pic>
+      <p:sp>
+        <p:nvSpPr>
+          <p:cNvPr id="29" name="Text 22"/>
+          <p:cNvSpPr/>
+          <p:nvPr/>
+        </p:nvSpPr>
+        <p:spPr>
+          <a:xfrm>
+            <a:off x="5179466" y="4142232"/>
+            <a:ext cx="2509418" cy="384048"/>
+          </a:xfrm>
+          <a:prstGeom prst="rect">
+            <a:avLst/>
+          </a:prstGeom>
+          <a:noFill/>
+          <a:ln/>
+        </p:spPr>
+        <p:txBody>
+          <a:bodyPr wrap="square" lIns="0" tIns="0" rIns="0" bIns="0" rtlCol="0" anchor="ctr"/>
+          <a:lstStyle/>
+          <a:p>
+            <a:pPr indent="0" marL="0">
+              <a:buNone/>
+            </a:pPr>
+            <a:r>
+              <a:rPr lang="en-US" sz="1450" b="1" dirty="0">
+                <a:solidFill>
+                  <a:srgbClr val="1E2761"/>
+                </a:solidFill>
+                <a:latin typeface="Calibri" pitchFamily="34" charset="0"/>
+                <a:ea typeface="Calibri" pitchFamily="34" charset="-122"/>
+                <a:cs typeface="Calibri" pitchFamily="34" charset="-120"/>
+              </a:rPr>
+              <a:t>Security incidents</a:t>
+            </a:r>
+            <a:endParaRPr lang="en-US" sz="1450" dirty="0"/>
+          </a:p>
+        </p:txBody>
+      </p:sp>
+      <p:sp>
+        <p:nvSpPr>
+          <p:cNvPr id="30" name="Text 23"/>
+          <p:cNvSpPr/>
+          <p:nvPr/>
+        </p:nvSpPr>
+        <p:spPr>
+          <a:xfrm>
+            <a:off x="4566818" y="4663440"/>
+            <a:ext cx="3058058" cy="1051560"/>
+          </a:xfrm>
+          <a:prstGeom prst="rect">
+            <a:avLst/>
+          </a:prstGeom>
+          <a:noFill/>
+          <a:ln/>
+        </p:spPr>
+        <p:txBody>
+          <a:bodyPr wrap="square" lIns="0" tIns="0" rIns="0" bIns="0" rtlCol="0" anchor="ctr"/>
+          <a:lstStyle/>
+          <a:p>
+            <a:pPr indent="0" marL="0">
+              <a:buNone/>
+            </a:pPr>
+            <a:r>
+              <a:rPr lang="en-US" sz="1100" dirty="0">
+                <a:solidFill>
+                  <a:srgbClr val="1B2440"/>
+                </a:solidFill>
+                <a:latin typeface="Calibri" pitchFamily="34" charset="0"/>
+                <a:ea typeface="Calibri" pitchFamily="34" charset="-122"/>
+                <a:cs typeface="Calibri" pitchFamily="34" charset="-120"/>
+              </a:rPr>
+              <a:t>Confirmed leakage events past Gate 3. The only acceptable number is zero; one incident likely ends the program.</a:t>
+            </a:r>
+            <a:endParaRPr lang="en-US" sz="1100" dirty="0"/>
+          </a:p>
+        </p:txBody>
+      </p:sp>
+      <p:sp>
+        <p:nvSpPr>
+          <p:cNvPr id="31" name="Shape 24"/>
+          <p:cNvSpPr/>
+          <p:nvPr/>
+        </p:nvSpPr>
+        <p:spPr>
+          <a:xfrm>
+            <a:off x="8127797" y="3886200"/>
+            <a:ext cx="3515258" cy="2011680"/>
+          </a:xfrm>
+          <a:prstGeom prst="roundRect">
+            <a:avLst>
+              <a:gd name="adj" fmla="val 3636"/>
+            </a:avLst>
+          </a:prstGeom>
+          <a:solidFill>
+            <a:srgbClr val="EDF3FC"/>
+          </a:solidFill>
+          <a:ln/>
+          <a:effectLst>
+            <a:outerShdw sx="100000" sy="100000" kx="0" ky="0" algn="bl" rotWithShape="0" blurRad="76200" dist="12700" dir="5400000">
+              <a:srgbClr val="9AA7C4">
+                <a:alpha val="25000"/>
+              </a:srgbClr>
+            </a:outerShdw>
+          </a:effectLst>
+        </p:spPr>
+      </p:sp>
+      <p:sp>
+        <p:nvSpPr>
+          <p:cNvPr id="32" name="Shape 25"/>
+          <p:cNvSpPr/>
+          <p:nvPr/>
+        </p:nvSpPr>
+        <p:spPr>
+          <a:xfrm>
+            <a:off x="8328965" y="4087368"/>
+            <a:ext cx="502920" cy="502920"/>
+          </a:xfrm>
+          <a:prstGeom prst="ellipse">
+            <a:avLst/>
+          </a:prstGeom>
+          <a:solidFill>
+            <a:srgbClr val="1E2761"/>
+          </a:solidFill>
+          <a:ln/>
+        </p:spPr>
+      </p:sp>
+      <p:pic>
+        <p:nvPicPr>
+          <p:cNvPr id="33" name="Image 5" descr="preencoded.png">    </p:cNvPr>
+          <p:cNvPicPr>
+            <a:picLocks noChangeAspect="1"/>
+          </p:cNvPicPr>
+          <p:nvPr/>
+        </p:nvPicPr>
+        <p:blipFill>
+          <a:blip r:embed="rId6"/>
+          <a:stretch>
+            <a:fillRect/>
+          </a:stretch>
+        </p:blipFill>
+        <p:spPr>
+          <a:xfrm>
+            <a:off x="8459724" y="4218127"/>
+            <a:ext cx="241402" cy="241402"/>
+          </a:xfrm>
+          <a:prstGeom prst="rect">
+            <a:avLst/>
+          </a:prstGeom>
+        </p:spPr>
+      </p:pic>
+      <p:sp>
+        <p:nvSpPr>
+          <p:cNvPr id="34" name="Text 26"/>
+          <p:cNvSpPr/>
+          <p:nvPr/>
+        </p:nvSpPr>
+        <p:spPr>
+          <a:xfrm>
+            <a:off x="8969045" y="4142232"/>
+            <a:ext cx="2509418" cy="384048"/>
+          </a:xfrm>
+          <a:prstGeom prst="rect">
+            <a:avLst/>
+          </a:prstGeom>
+          <a:noFill/>
+          <a:ln/>
+        </p:spPr>
+        <p:txBody>
+          <a:bodyPr wrap="square" lIns="0" tIns="0" rIns="0" bIns="0" rtlCol="0" anchor="ctr"/>
+          <a:lstStyle/>
+          <a:p>
+            <a:pPr indent="0" marL="0">
+              <a:buNone/>
+            </a:pPr>
+            <a:r>
+              <a:rPr lang="en-US" sz="1450" b="1" dirty="0">
+                <a:solidFill>
+                  <a:srgbClr val="1E2761"/>
+                </a:solidFill>
+                <a:latin typeface="Calibri" pitchFamily="34" charset="0"/>
+                <a:ea typeface="Calibri" pitchFamily="34" charset="-122"/>
+                <a:cs typeface="Calibri" pitchFamily="34" charset="-120"/>
+              </a:rPr>
+              <a:t>Bus-factor spread</a:t>
+            </a:r>
+            <a:endParaRPr lang="en-US" sz="1450" dirty="0"/>
+          </a:p>
+        </p:txBody>
+      </p:sp>
+      <p:sp>
+        <p:nvSpPr>
+          <p:cNvPr id="35" name="Text 27"/>
+          <p:cNvSpPr/>
+          <p:nvPr/>
+        </p:nvSpPr>
+        <p:spPr>
+          <a:xfrm>
+            <a:off x="8356397" y="4663440"/>
+            <a:ext cx="3058058" cy="1051560"/>
+          </a:xfrm>
+          <a:prstGeom prst="rect">
+            <a:avLst/>
+          </a:prstGeom>
+          <a:noFill/>
+          <a:ln/>
+        </p:spPr>
+        <p:txBody>
+          <a:bodyPr wrap="square" lIns="0" tIns="0" rIns="0" bIns="0" rtlCol="0" anchor="ctr"/>
+          <a:lstStyle/>
+          <a:p>
+            <a:pPr indent="0" marL="0">
+              <a:buNone/>
+            </a:pPr>
+            <a:r>
+              <a:rPr lang="en-US" sz="1100" dirty="0">
+                <a:solidFill>
+                  <a:srgbClr val="1B2440"/>
+                </a:solidFill>
+                <a:latin typeface="Calibri" pitchFamily="34" charset="0"/>
+                <a:ea typeface="Calibri" pitchFamily="34" charset="-122"/>
+                <a:cs typeface="Calibri" pitchFamily="34" charset="-120"/>
+              </a:rPr>
+              <a:t>Per contractor duty: runbook exists + a core-team member has executed it this quarter. 100% = Phase 3 can trigger any day.</a:t>
+            </a:r>
+            <a:endParaRPr lang="en-US" sz="1100" dirty="0"/>
+          </a:p>
+        </p:txBody>
+      </p:sp>
+      <p:sp>
+        <p:nvSpPr>
+          <p:cNvPr id="36" name="Text 28"/>
+          <p:cNvSpPr/>
+          <p:nvPr/>
+        </p:nvSpPr>
+        <p:spPr>
+          <a:xfrm>
+            <a:off x="548640" y="5989320"/>
+            <a:ext cx="11094415" cy="365760"/>
+          </a:xfrm>
+          <a:prstGeom prst="rect">
+            <a:avLst/>
+          </a:prstGeom>
+          <a:noFill/>
+          <a:ln/>
+        </p:spPr>
+        <p:txBody>
+          <a:bodyPr wrap="square" lIns="0" tIns="0" rIns="0" bIns="0" rtlCol="0" anchor="ctr"/>
+          <a:lstStyle/>
+          <a:p>
+            <a:pPr algn="ctr" indent="0" marL="0">
+              <a:buNone/>
+            </a:pPr>
+            <a:r>
+              <a:rPr lang="en-US" sz="1250" i="1" dirty="0">
+                <a:solidFill>
+                  <a:srgbClr val="5A6B8C"/>
+                </a:solidFill>
+                <a:latin typeface="Calibri" pitchFamily="34" charset="0"/>
+                <a:ea typeface="Calibri" pitchFamily="34" charset="-122"/>
+                <a:cs typeface="Calibri" pitchFamily="34" charset="-120"/>
+              </a:rPr>
+              <a:t>Publish the scoreboard monthly — to stakeholders, not just the team. Transparency is the counter-narrative.</a:t>
+            </a:r>
+            <a:endParaRPr lang="en-US" sz="1250" dirty="0"/>
+          </a:p>
+        </p:txBody>
+      </p:sp>
+    </p:spTree>
+  </p:cSld>
+  <p:clrMapOvr>
+    <a:masterClrMapping/>
+  </p:clrMapOvr>
+</p:sld>
+</file>
+
+<file path=ppt/slides/slide18.xml><?xml version="1.0" encoding="utf-8"?>
+<p:sld xmlns:a="http://schemas.openxmlformats.org/drawingml/2006/main" xmlns:r="http://schemas.openxmlformats.org/officeDocument/2006/relationships" xmlns:p="http://schemas.openxmlformats.org/presentationml/2006/main">
+  <p:cSld name="Slide 18">
     <p:bg>
       <p:bgPr>
         <a:solidFill>
@@ -8560,7 +10702,7 @@
                 <a:ea typeface="Calibri" pitchFamily="34" charset="-122"/>
                 <a:cs typeface="Calibri" pitchFamily="34" charset="-120"/>
               </a:rPr>
-              <a:t>16</a:t>
+              <a:t>18</a:t>
             </a:r>
             <a:endParaRPr lang="en-US" sz="900" dirty="0"/>
           </a:p>

</xml_diff>

<commit_message>
Revise competitive strategy and add department federation section
- Replace 'absorb the vibe-coders' with 'win at the production gate':
  user teams are fearless-only by design and direct competitors, so
  the play is a neutral platform onboarding standard plus the
  two-clocks metric (time-to-demo vs time-to-production)
- Reframe demo-space as the one lane where head-to-head speed is
  winnable (mocks carry no security tax)
- New incident-response gap (5.7): pre-agreed IR playbook driven by
  the egress ledger; mapping.json leaks cannot be rotated
- New Section 7 and deck slide: department federation — shared fate
  on incidents, fiction hygiene across teams, writing the gate
  standard first, cross-team reviewer/tooling/KPI leverage
- Fifth ask: charter a department working group

Co-Authored-By: Claude Fable 5 <noreply@anthropic.com>
Claude-Session: https://claude.ai/code/session_01NCQ4pPu4jZQ7AgDqWePsQe
</commit_message>
<xml_diff>
--- a/docs/internet-first-airgap-final.pptx
+++ b/docs/internet-first-airgap-final.pptx
@@ -23,9 +23,10 @@
     <p:sldId id="271" r:id="rId17"/>
     <p:sldId id="272" r:id="rId18"/>
     <p:sldId id="273" r:id="rId19"/>
+    <p:sldId id="274" r:id="rId20"/>
   </p:sldIdLst>
   <p:notesMasterIdLst>
-    <p:notesMasterId r:id="rId20"/>
+    <p:notesMasterId r:id="rId21"/>
   </p:notesMasterIdLst>
   <p:sldSz cx="12192000" cy="6858000"/>
   <p:notesSz cx="6858000" cy="12192000"/>
@@ -1335,6 +1336,94 @@
             <a:fld id="{F7021451-1387-4CA6-816F-3879F97B5CBC}" type="slidenum">
               <a:rPr lang="en-US"/>
               <a:t>18</a:t>
+            </a:fld>
+            <a:endParaRPr lang="en-US"/>
+          </a:p>
+        </p:txBody>
+      </p:sp>
+    </p:spTree>
+    <p:extLst>
+      <p:ext uri="{BB962C8B-B14F-4D97-AF65-F5344CB8AC3E}">
+        <p14:creationId xmlns:p14="http://schemas.microsoft.com/office/powerpoint/2010/main" val="1024086991"/>
+      </p:ext>
+    </p:extLst>
+  </p:cSld>
+  <p:clrMapOvr>
+    <a:masterClrMapping/>
+  </p:clrMapOvr>
+</p:notes>
+</file>
+
+<file path=ppt/notesSlides/notesSlide19.xml><?xml version="1.0" encoding="utf-8"?>
+<p:notes xmlns:a="http://schemas.openxmlformats.org/drawingml/2006/main" xmlns:r="http://schemas.openxmlformats.org/officeDocument/2006/relationships" xmlns:p="http://schemas.openxmlformats.org/presentationml/2006/main">
+  <p:cSld>
+    <p:spTree>
+      <p:nvGrpSpPr>
+        <p:cNvPr id="1" name=""/>
+        <p:cNvGrpSpPr/>
+        <p:nvPr/>
+      </p:nvGrpSpPr>
+      <p:grpSpPr>
+        <a:xfrm>
+          <a:off x="0" y="0"/>
+          <a:ext cx="0" cy="0"/>
+          <a:chOff x="0" y="0"/>
+          <a:chExt cx="0" cy="0"/>
+        </a:xfrm>
+      </p:grpSpPr>
+      <p:sp>
+        <p:nvSpPr>
+          <p:cNvPr id="2" name="Slide Image Placeholder 1"/>
+          <p:cNvSpPr>
+            <a:spLocks noGrp="1" noRot="1" noChangeAspect="1"/>
+          </p:cNvSpPr>
+          <p:nvPr>
+            <p:ph type="sldImg"/>
+          </p:nvPr>
+        </p:nvSpPr>
+        <p:spPr/>
+      </p:sp>
+      <p:sp>
+        <p:nvSpPr>
+          <p:cNvPr id="3" name="Notes Placeholder 2"/>
+          <p:cNvSpPr>
+            <a:spLocks noGrp="1"/>
+          </p:cNvSpPr>
+          <p:nvPr>
+            <p:ph type="body" idx="1"/>
+          </p:nvPr>
+        </p:nvSpPr>
+        <p:spPr/>
+        <p:txBody>
+          <a:bodyPr/>
+          <a:lstStyle/>
+          <a:p>
+            <a:r>
+              <a:rPr lang="en-US" dirty="0"/>
+              <a:t/>
+            </a:r>
+            <a:endParaRPr lang="en-US" dirty="0"/>
+          </a:p>
+        </p:txBody>
+      </p:sp>
+      <p:sp>
+        <p:nvSpPr>
+          <p:cNvPr id="4" name="Slide Number Placeholder 3"/>
+          <p:cNvSpPr>
+            <a:spLocks noGrp="1"/>
+          </p:cNvSpPr>
+          <p:nvPr>
+            <p:ph type="sldNum" sz="quarter" idx="10"/>
+          </p:nvPr>
+        </p:nvSpPr>
+        <p:spPr/>
+        <p:txBody>
+          <a:bodyPr/>
+          <a:lstStyle/>
+          <a:p>
+            <a:fld id="{F7021451-1387-4CA6-816F-3879F97B5CBC}" type="slidenum">
+              <a:rPr lang="en-US"/>
+              <a:t>19</a:t>
             </a:fld>
             <a:endParaRPr lang="en-US"/>
           </a:p>
@@ -7767,7 +7856,7 @@
                 <a:ea typeface="Calibri" pitchFamily="34" charset="-122"/>
                 <a:cs typeface="Calibri" pitchFamily="34" charset="-120"/>
               </a:rPr>
-              <a:t>Absorb the vibe-coders</a:t>
+              <a:t>Win at the production gate</a:t>
             </a:r>
             <a:endParaRPr lang="en-US" sz="1450" dirty="0"/>
           </a:p>
@@ -7806,7 +7895,7 @@
                 <a:ea typeface="Calibri" pitchFamily="34" charset="-122"/>
                 <a:cs typeface="Calibri" pitchFamily="34" charset="-120"/>
               </a:rPr>
-              <a:t>Don't race the GenAI user teams — give them a lane inside the paradigm. Hand them the LTC sandbox, world bible, and mock scaffold; their prototypes become Tier-1 spec inputs flowing through our gate. The loudest political threat becomes the requirements pipeline, and stakeholders see one program, not a rivalry.</a:t>
+              <a:t>The user teams are fearless-only BY DESIGN — they carry none of our security burden, so we can't out-sprint them on their scoreboard, and as direct competitors we can't absorb them. Move the finish line instead: publish a neutral onboarding standard for ANY MFE entering the production platform we operate (contracts, tests, SAST — the bar we already meet ourselves). Either they meet it (they've adopted our paradigm on our terms) or they stall at the one gate their model can't pass. Let production do the arguing — never badmouth the demos.</a:t>
             </a:r>
             <a:endParaRPr lang="en-US" sz="1060" dirty="0"/>
           </a:p>
@@ -7918,7 +8007,7 @@
                 <a:ea typeface="Calibri" pitchFamily="34" charset="-122"/>
                 <a:cs typeface="Calibri" pitchFamily="34" charset="-120"/>
               </a:rPr>
-              <a:t>Fix requirements with mocks</a:t>
+              <a:t>Match them in demo-space</a:t>
             </a:r>
             <a:endParaRPr lang="en-US" sz="1450" dirty="0"/>
           </a:p>
@@ -7957,7 +8046,7 @@
                 <a:ea typeface="Calibri" pitchFamily="34" charset="-122"/>
                 <a:cs typeface="Calibri" pitchFamily="34" charset="-120"/>
               </a:rPr>
-              <a:t>“Heavy requirements gathering” was a named root cause, and the plan only speeds up what happens after it. A running MSW-backed UI is a requirements instrument: clickable, realistic-data prototypes in front of users in week one — react to behavior, not documents. The legitimate version of exactly what the vibe-coders do.</a:t>
+              <a:t>The MSW-backed passive shell carries NONE of our security tax — mocks touch nothing classified — so on demos we are exactly as fast as the vibe-coders. Put clickable, realistic-data prototypes in front of stakeholders in week one: fearless demos, disciplined delivery. This also fixes the named root cause the plan otherwise skips — requirements gathering — because users react to behavior, not documents.</a:t>
             </a:r>
             <a:endParaRPr lang="en-US" sz="1060" dirty="0"/>
           </a:p>
@@ -8447,7 +8536,7 @@
                 <a:ea typeface="Calibri" pitchFamily="34" charset="-122"/>
                 <a:cs typeface="Calibri" pitchFamily="34" charset="-120"/>
               </a:rPr>
-              <a:t>EXECUTION · A PRAGMATIC TRANSITION TIMELINE</a:t>
+              <a:t>THE DEPARTMENT DIMENSION · SIBLING CORE TEAMS ARE DOING THIS TOO</a:t>
             </a:r>
             <a:endParaRPr lang="en-US" sz="1200" dirty="0"/>
           </a:p>
@@ -8486,7 +8575,7 @@
                 <a:ea typeface="Cambria" pitchFamily="34" charset="-122"/>
                 <a:cs typeface="Cambria" pitchFamily="34" charset="-120"/>
               </a:rPr>
-              <a:t>Phase exits are criteria, not dates</a:t>
+              <a:t>One paradigm, many teams — federate or fragment</a:t>
             </a:r>
             <a:endParaRPr lang="en-US" sz="3000" dirty="0"/>
           </a:p>
@@ -8500,12 +8589,12 @@
         </p:nvSpPr>
         <p:spPr>
           <a:xfrm>
-            <a:off x="548640" y="1691640"/>
-            <a:ext cx="2602154" cy="4206240"/>
+            <a:off x="548640" y="1627632"/>
+            <a:ext cx="5400904" cy="2121408"/>
           </a:xfrm>
           <a:prstGeom prst="roundRect">
             <a:avLst>
-              <a:gd name="adj" fmla="val 2811"/>
+              <a:gd name="adj" fmla="val 3448"/>
             </a:avLst>
           </a:prstGeom>
           <a:solidFill>
@@ -8523,14 +8612,58 @@
       </p:sp>
       <p:sp>
         <p:nvSpPr>
-          <p:cNvPr id="7" name="Text 5"/>
-          <p:cNvSpPr/>
-          <p:nvPr/>
-        </p:nvSpPr>
-        <p:spPr>
-          <a:xfrm>
-            <a:off x="731520" y="1828800"/>
-            <a:ext cx="2236394" cy="274320"/>
+          <p:cNvPr id="7" name="Shape 5"/>
+          <p:cNvSpPr/>
+          <p:nvPr/>
+        </p:nvSpPr>
+        <p:spPr>
+          <a:xfrm>
+            <a:off x="749808" y="1810512"/>
+            <a:ext cx="475488" cy="475488"/>
+          </a:xfrm>
+          <a:prstGeom prst="ellipse">
+            <a:avLst/>
+          </a:prstGeom>
+          <a:solidFill>
+            <a:srgbClr val="1E2761"/>
+          </a:solidFill>
+          <a:ln/>
+        </p:spPr>
+      </p:sp>
+      <p:pic>
+        <p:nvPicPr>
+          <p:cNvPr id="8" name="Image 0" descr="preencoded.png">    </p:cNvPr>
+          <p:cNvPicPr>
+            <a:picLocks noChangeAspect="1"/>
+          </p:cNvPicPr>
+          <p:nvPr/>
+        </p:nvPicPr>
+        <p:blipFill>
+          <a:blip r:embed="rId1"/>
+          <a:stretch>
+            <a:fillRect/>
+          </a:stretch>
+        </p:blipFill>
+        <p:spPr>
+          <a:xfrm>
+            <a:off x="873435" y="1934139"/>
+            <a:ext cx="228234" cy="228234"/>
+          </a:xfrm>
+          <a:prstGeom prst="rect">
+            <a:avLst/>
+          </a:prstGeom>
+        </p:spPr>
+      </p:pic>
+      <p:sp>
+        <p:nvSpPr>
+          <p:cNvPr id="9" name="Text 6"/>
+          <p:cNvSpPr/>
+          <p:nvPr/>
+        </p:nvSpPr>
+        <p:spPr>
+          <a:xfrm>
+            <a:off x="1353312" y="1856232"/>
+            <a:ext cx="4440784" cy="365760"/>
           </a:xfrm>
           <a:prstGeom prst="rect">
             <a:avLst/>
@@ -8546,30 +8679,30 @@
               <a:buNone/>
             </a:pPr>
             <a:r>
-              <a:rPr lang="en-US" sz="1100" b="1" spc="200" kern="0" dirty="0">
-                <a:solidFill>
-                  <a:srgbClr val="5A6B8C"/>
-                </a:solidFill>
-                <a:latin typeface="Calibri" pitchFamily="34" charset="0"/>
-                <a:ea typeface="Calibri" pitchFamily="34" charset="-122"/>
-                <a:cs typeface="Calibri" pitchFamily="34" charset="-120"/>
-              </a:rPr>
-              <a:t>PHASE 0</a:t>
-            </a:r>
-            <a:endParaRPr lang="en-US" sz="1100" dirty="0"/>
-          </a:p>
-        </p:txBody>
-      </p:sp>
-      <p:sp>
-        <p:nvSpPr>
-          <p:cNvPr id="8" name="Text 6"/>
-          <p:cNvSpPr/>
-          <p:nvPr/>
-        </p:nvSpPr>
-        <p:spPr>
-          <a:xfrm>
-            <a:off x="731520" y="2103120"/>
-            <a:ext cx="2236394" cy="685800"/>
+              <a:rPr lang="en-US" sz="1400" b="1" dirty="0">
+                <a:solidFill>
+                  <a:srgbClr val="1E2761"/>
+                </a:solidFill>
+                <a:latin typeface="Calibri" pitchFamily="34" charset="0"/>
+                <a:ea typeface="Calibri" pitchFamily="34" charset="-122"/>
+                <a:cs typeface="Calibri" pitchFamily="34" charset="-120"/>
+              </a:rPr>
+              <a:t>Shared fate on incidents</a:t>
+            </a:r>
+            <a:endParaRPr lang="en-US" sz="1400" dirty="0"/>
+          </a:p>
+        </p:txBody>
+      </p:sp>
+      <p:sp>
+        <p:nvSpPr>
+          <p:cNvPr id="10" name="Text 7"/>
+          <p:cNvSpPr/>
+          <p:nvPr/>
+        </p:nvSpPr>
+        <p:spPr>
+          <a:xfrm>
+            <a:off x="777240" y="2286000"/>
+            <a:ext cx="4943704" cy="1280160"/>
           </a:xfrm>
           <a:prstGeom prst="rect">
             <a:avLst/>
@@ -8585,67 +8718,7 @@
               <a:buNone/>
             </a:pPr>
             <a:r>
-              <a:rPr lang="en-US" sz="1350" b="1" dirty="0">
-                <a:solidFill>
-                  <a:srgbClr val="1E2761"/>
-                </a:solidFill>
-                <a:latin typeface="Calibri" pitchFamily="34" charset="0"/>
-                <a:ea typeface="Calibri" pitchFamily="34" charset="-122"/>
-                <a:cs typeface="Calibri" pitchFamily="34" charset="-120"/>
-              </a:rPr>
-              <a:t>Legitimize &amp; pilot</a:t>
-            </a:r>
-            <a:endParaRPr lang="en-US" sz="1350" dirty="0"/>
-          </a:p>
-          <a:p>
-            <a:pPr indent="0" marL="0">
-              <a:buNone/>
-            </a:pPr>
-            <a:r>
-              <a:rPr lang="en-US" sz="1350" b="1" dirty="0">
-                <a:solidFill>
-                  <a:srgbClr val="1E2761"/>
-                </a:solidFill>
-                <a:latin typeface="Calibri" pitchFamily="34" charset="0"/>
-                <a:ea typeface="Calibri" pitchFamily="34" charset="-122"/>
-                <a:cs typeface="Calibri" pitchFamily="34" charset="-120"/>
-              </a:rPr>
-              <a:t>(mo 0–2)</a:t>
-            </a:r>
-            <a:endParaRPr lang="en-US" sz="1350" dirty="0"/>
-          </a:p>
-        </p:txBody>
-      </p:sp>
-      <p:sp>
-        <p:nvSpPr>
-          <p:cNvPr id="9" name="Text 7"/>
-          <p:cNvSpPr/>
-          <p:nvPr/>
-        </p:nvSpPr>
-        <p:spPr>
-          <a:xfrm>
-            <a:off x="731520" y="2880360"/>
-            <a:ext cx="2236394" cy="2834640"/>
-          </a:xfrm>
-          <a:prstGeom prst="rect">
-            <a:avLst/>
-          </a:prstGeom>
-          <a:noFill/>
-          <a:ln/>
-        </p:spPr>
-        <p:txBody>
-          <a:bodyPr wrap="square" lIns="0" tIns="0" rIns="0" bIns="0" rtlCol="0" anchor="ctr"/>
-          <a:lstStyle/>
-          <a:p>
-            <a:pPr marL="342900" indent="-342900">
-              <a:spcAft>
-                <a:spcPts val="600"/>
-              </a:spcAft>
-              <a:buSzPct val="100000"/>
-              <a:buChar char="•"/>
-            </a:pPr>
-            <a:r>
-              <a:rPr lang="en-US" sz="980" dirty="0">
+              <a:rPr lang="en-US" sz="960" dirty="0">
                 <a:solidFill>
                   <a:srgbClr val="1B2440"/>
                 </a:solidFill>
@@ -8653,89 +8726,26 @@
                 <a:ea typeface="Calibri" pitchFamily="34" charset="-122"/>
                 <a:cs typeface="Calibri" pitchFamily="34" charset="-120"/>
               </a:rPr>
-              <a:t>Written authorization: scope, egress channel, named approvers</a:t>
-            </a:r>
-            <a:endParaRPr lang="en-US" sz="980" dirty="0"/>
-          </a:p>
-          <a:p>
-            <a:pPr marL="342900" indent="-342900">
-              <a:spcAft>
-                <a:spcPts val="600"/>
-              </a:spcAft>
-              <a:buSzPct val="100000"/>
-              <a:buChar char="•"/>
-            </a:pPr>
-            <a:r>
-              <a:rPr lang="en-US" sz="980" dirty="0">
-                <a:solidFill>
-                  <a:srgbClr val="1B2440"/>
-                </a:solidFill>
-                <a:latin typeface="Calibri" pitchFamily="34" charset="0"/>
-                <a:ea typeface="Calibri" pitchFamily="34" charset="-122"/>
-                <a:cs typeface="Calibri" pitchFamily="34" charset="-120"/>
-              </a:rPr>
-              <a:t>Gates 0–3 stood up; denylist co-authored with cyber</a:t>
-            </a:r>
-            <a:endParaRPr lang="en-US" sz="980" dirty="0"/>
-          </a:p>
-          <a:p>
-            <a:pPr marL="342900" indent="-342900">
-              <a:spcAft>
-                <a:spcPts val="600"/>
-              </a:spcAft>
-              <a:buSzPct val="100000"/>
-              <a:buChar char="•"/>
-            </a:pPr>
-            <a:r>
-              <a:rPr lang="en-US" sz="980" dirty="0">
-                <a:solidFill>
-                  <a:srgbClr val="1B2440"/>
-                </a:solidFill>
-                <a:latin typeface="Calibri" pitchFamily="34" charset="0"/>
-                <a:ea typeface="Calibri" pitchFamily="34" charset="-122"/>
-                <a:cs typeface="Calibri" pitchFamily="34" charset="-120"/>
-              </a:rPr>
-              <a:t>World bible v1 + internet org &amp; repos with CI parity</a:t>
-            </a:r>
-            <a:endParaRPr lang="en-US" sz="980" dirty="0"/>
-          </a:p>
-          <a:p>
-            <a:pPr marL="342900" indent="-342900">
-              <a:spcAft>
-                <a:spcPts val="600"/>
-              </a:spcAft>
-              <a:buSzPct val="100000"/>
-              <a:buChar char="•"/>
-            </a:pPr>
-            <a:r>
-              <a:rPr lang="en-US" sz="980" dirty="0">
-                <a:solidFill>
-                  <a:srgbClr val="1B2440"/>
-                </a:solidFill>
-                <a:latin typeface="Calibri" pitchFamily="34" charset="0"/>
-                <a:ea typeface="Calibri" pitchFamily="34" charset="-122"/>
-                <a:cs typeface="Calibri" pitchFamily="34" charset="-120"/>
-              </a:rPr>
-              <a:t>Pilot feature specced and egressed</a:t>
-            </a:r>
-            <a:endParaRPr lang="en-US" sz="980" dirty="0"/>
-          </a:p>
-        </p:txBody>
-      </p:sp>
-      <p:sp>
-        <p:nvSpPr>
-          <p:cNvPr id="10" name="Shape 8"/>
-          <p:cNvSpPr/>
-          <p:nvPr/>
-        </p:nvSpPr>
-        <p:spPr>
-          <a:xfrm>
-            <a:off x="3379394" y="1691640"/>
-            <a:ext cx="2602154" cy="4206240"/>
+              <a:t>With N teams running parallel egress workflows, ONE team's leak ends the paradigm for ALL — leadership will not distinguish whose gate failed. The weakest gate in the department now defines our risk. Propose a common department gate standard (gates 0–3, tiers, ledgers), shared scanner + denylist infrastructure, and a JOINT incident-response playbook: who is notified, blast-radius assessment from the egress ledger, remediation (retire aliases, quarantine repos), reporting channel. No team should be inventing IR mid-incident.</a:t>
+            </a:r>
+            <a:endParaRPr lang="en-US" sz="960" dirty="0"/>
+          </a:p>
+        </p:txBody>
+      </p:sp>
+      <p:sp>
+        <p:nvSpPr>
+          <p:cNvPr id="11" name="Shape 8"/>
+          <p:cNvSpPr/>
+          <p:nvPr/>
+        </p:nvSpPr>
+        <p:spPr>
+          <a:xfrm>
+            <a:off x="6242152" y="1627632"/>
+            <a:ext cx="5400904" cy="2121408"/>
           </a:xfrm>
           <a:prstGeom prst="roundRect">
             <a:avLst>
-              <a:gd name="adj" fmla="val 2811"/>
+              <a:gd name="adj" fmla="val 3448"/>
             </a:avLst>
           </a:prstGeom>
           <a:solidFill>
@@ -8753,14 +8763,58 @@
       </p:sp>
       <p:sp>
         <p:nvSpPr>
-          <p:cNvPr id="11" name="Text 9"/>
-          <p:cNvSpPr/>
-          <p:nvPr/>
-        </p:nvSpPr>
-        <p:spPr>
-          <a:xfrm>
-            <a:off x="3562274" y="1828800"/>
-            <a:ext cx="2236394" cy="274320"/>
+          <p:cNvPr id="12" name="Shape 9"/>
+          <p:cNvSpPr/>
+          <p:nvPr/>
+        </p:nvSpPr>
+        <p:spPr>
+          <a:xfrm>
+            <a:off x="6443320" y="1810512"/>
+            <a:ext cx="475488" cy="475488"/>
+          </a:xfrm>
+          <a:prstGeom prst="ellipse">
+            <a:avLst/>
+          </a:prstGeom>
+          <a:solidFill>
+            <a:srgbClr val="1E2761"/>
+          </a:solidFill>
+          <a:ln/>
+        </p:spPr>
+      </p:sp>
+      <p:pic>
+        <p:nvPicPr>
+          <p:cNvPr id="13" name="Image 1" descr="preencoded.png">    </p:cNvPr>
+          <p:cNvPicPr>
+            <a:picLocks noChangeAspect="1"/>
+          </p:cNvPicPr>
+          <p:nvPr/>
+        </p:nvPicPr>
+        <p:blipFill>
+          <a:blip r:embed="rId2"/>
+          <a:stretch>
+            <a:fillRect/>
+          </a:stretch>
+        </p:blipFill>
+        <p:spPr>
+          <a:xfrm>
+            <a:off x="6566946" y="1934139"/>
+            <a:ext cx="228234" cy="228234"/>
+          </a:xfrm>
+          <a:prstGeom prst="rect">
+            <a:avLst/>
+          </a:prstGeom>
+        </p:spPr>
+      </p:pic>
+      <p:sp>
+        <p:nvSpPr>
+          <p:cNvPr id="14" name="Text 10"/>
+          <p:cNvSpPr/>
+          <p:nvPr/>
+        </p:nvSpPr>
+        <p:spPr>
+          <a:xfrm>
+            <a:off x="7046824" y="1856232"/>
+            <a:ext cx="4440784" cy="365760"/>
           </a:xfrm>
           <a:prstGeom prst="rect">
             <a:avLst/>
@@ -8776,30 +8830,30 @@
               <a:buNone/>
             </a:pPr>
             <a:r>
-              <a:rPr lang="en-US" sz="1100" b="1" spc="200" kern="0" dirty="0">
-                <a:solidFill>
-                  <a:srgbClr val="5A6B8C"/>
-                </a:solidFill>
-                <a:latin typeface="Calibri" pitchFamily="34" charset="0"/>
-                <a:ea typeface="Calibri" pitchFamily="34" charset="-122"/>
-                <a:cs typeface="Calibri" pitchFamily="34" charset="-120"/>
-              </a:rPr>
-              <a:t>PHASE 1</a:t>
-            </a:r>
-            <a:endParaRPr lang="en-US" sz="1100" dirty="0"/>
-          </a:p>
-        </p:txBody>
-      </p:sp>
-      <p:sp>
-        <p:nvSpPr>
-          <p:cNvPr id="12" name="Text 10"/>
-          <p:cNvSpPr/>
-          <p:nvPr/>
-        </p:nvSpPr>
-        <p:spPr>
-          <a:xfrm>
-            <a:off x="3562274" y="2103120"/>
-            <a:ext cx="2236394" cy="685800"/>
+              <a:rPr lang="en-US" sz="1400" b="1" dirty="0">
+                <a:solidFill>
+                  <a:srgbClr val="1E2761"/>
+                </a:solidFill>
+                <a:latin typeface="Calibri" pitchFamily="34" charset="0"/>
+                <a:ea typeface="Calibri" pitchFamily="34" charset="-122"/>
+                <a:cs typeface="Calibri" pitchFamily="34" charset="-120"/>
+              </a:rPr>
+              <a:t>Fiction hygiene across teams</a:t>
+            </a:r>
+            <a:endParaRPr lang="en-US" sz="1400" dirty="0"/>
+          </a:p>
+        </p:txBody>
+      </p:sp>
+      <p:sp>
+        <p:nvSpPr>
+          <p:cNvPr id="15" name="Text 11"/>
+          <p:cNvSpPr/>
+          <p:nvPr/>
+        </p:nvSpPr>
+        <p:spPr>
+          <a:xfrm>
+            <a:off x="6470752" y="2286000"/>
+            <a:ext cx="4943704" cy="1280160"/>
           </a:xfrm>
           <a:prstGeom prst="rect">
             <a:avLst/>
@@ -8815,67 +8869,7 @@
               <a:buNone/>
             </a:pPr>
             <a:r>
-              <a:rPr lang="en-US" sz="1350" b="1" dirty="0">
-                <a:solidFill>
-                  <a:srgbClr val="1E2761"/>
-                </a:solidFill>
-                <a:latin typeface="Calibri" pitchFamily="34" charset="0"/>
-                <a:ea typeface="Calibri" pitchFamily="34" charset="-122"/>
-                <a:cs typeface="Calibri" pitchFamily="34" charset="-120"/>
-              </a:rPr>
-              <a:t>Internet-first core team</a:t>
-            </a:r>
-            <a:endParaRPr lang="en-US" sz="1350" dirty="0"/>
-          </a:p>
-          <a:p>
-            <a:pPr indent="0" marL="0">
-              <a:buNone/>
-            </a:pPr>
-            <a:r>
-              <a:rPr lang="en-US" sz="1350" b="1" dirty="0">
-                <a:solidFill>
-                  <a:srgbClr val="1E2761"/>
-                </a:solidFill>
-                <a:latin typeface="Calibri" pitchFamily="34" charset="0"/>
-                <a:ea typeface="Calibri" pitchFamily="34" charset="-122"/>
-                <a:cs typeface="Calibri" pitchFamily="34" charset="-120"/>
-              </a:rPr>
-              <a:t>(mo 2–8)</a:t>
-            </a:r>
-            <a:endParaRPr lang="en-US" sz="1350" dirty="0"/>
-          </a:p>
-        </p:txBody>
-      </p:sp>
-      <p:sp>
-        <p:nvSpPr>
-          <p:cNvPr id="13" name="Text 11"/>
-          <p:cNvSpPr/>
-          <p:nvPr/>
-        </p:nvSpPr>
-        <p:spPr>
-          <a:xfrm>
-            <a:off x="3562274" y="2880360"/>
-            <a:ext cx="2236394" cy="2834640"/>
-          </a:xfrm>
-          <a:prstGeom prst="rect">
-            <a:avLst/>
-          </a:prstGeom>
-          <a:noFill/>
-          <a:ln/>
-        </p:spPr>
-        <p:txBody>
-          <a:bodyPr wrap="square" lIns="0" tIns="0" rIns="0" bIns="0" rtlCol="0" anchor="ctr"/>
-          <a:lstStyle/>
-          <a:p>
-            <a:pPr marL="342900" indent="-342900">
-              <a:spcAft>
-                <a:spcPts val="600"/>
-              </a:spcAft>
-              <a:buSzPct val="100000"/>
-              <a:buChar char="•"/>
-            </a:pPr>
-            <a:r>
-              <a:rPr lang="en-US" sz="980" dirty="0">
+              <a:rPr lang="en-US" sz="960" dirty="0">
                 <a:solidFill>
                   <a:srgbClr val="1B2440"/>
                 </a:solidFill>
@@ -8883,93 +8877,30 @@
                 <a:ea typeface="Calibri" pitchFamily="34" charset="-122"/>
                 <a:cs typeface="Calibri" pitchFamily="34" charset="-120"/>
               </a:rPr>
-              <a:t>Core team builds pilot + 2–3 MFEs outside; logic-pack engine v1</a:t>
-            </a:r>
-            <a:endParaRPr lang="en-US" sz="980" dirty="0"/>
-          </a:p>
-          <a:p>
-            <a:pPr marL="342900" indent="-342900">
-              <a:spcAft>
-                <a:spcPts val="600"/>
-              </a:spcAft>
-              <a:buSzPct val="100000"/>
-              <a:buChar char="•"/>
-            </a:pPr>
-            <a:r>
-              <a:rPr lang="en-US" sz="980" dirty="0">
-                <a:solidFill>
-                  <a:srgbClr val="1B2440"/>
-                </a:solidFill>
-                <a:latin typeface="Calibri" pitchFamily="34" charset="0"/>
-                <a:ea typeface="Calibri" pitchFamily="34" charset="-122"/>
-                <a:cs typeface="Calibri" pitchFamily="34" charset="-120"/>
-              </a:rPr>
-              <a:t>Contractors own integration, mappings, env testing, config mgmt; some move to BA/spec roles</a:t>
-            </a:r>
-            <a:endParaRPr lang="en-US" sz="980" dirty="0"/>
-          </a:p>
-          <a:p>
-            <a:pPr marL="342900" indent="-342900">
-              <a:spcAft>
-                <a:spcPts val="600"/>
-              </a:spcAft>
-              <a:buSzPct val="100000"/>
-              <a:buChar char="•"/>
-            </a:pPr>
-            <a:r>
-              <a:rPr lang="en-US" sz="980" dirty="0">
-                <a:solidFill>
-                  <a:srgbClr val="1B2440"/>
-                </a:solidFill>
-                <a:latin typeface="Calibri" pitchFamily="34" charset="0"/>
-                <a:ea typeface="Calibri" pitchFamily="34" charset="-122"/>
-                <a:cs typeface="Calibri" pitchFamily="34" charset="-120"/>
-              </a:rPr>
-              <a:t>Dependency-delta job feeding Confi registry requests</a:t>
-            </a:r>
-            <a:endParaRPr lang="en-US" sz="980" dirty="0"/>
-          </a:p>
-          <a:p>
-            <a:pPr marL="342900" indent="-342900">
-              <a:spcAft>
-                <a:spcPts val="600"/>
-              </a:spcAft>
-              <a:buSzPct val="100000"/>
-              <a:buChar char="•"/>
-            </a:pPr>
-            <a:r>
-              <a:rPr lang="en-US" sz="980" dirty="0">
-                <a:solidFill>
-                  <a:srgbClr val="1B2440"/>
-                </a:solidFill>
-                <a:latin typeface="Calibri" pitchFamily="34" charset="0"/>
-                <a:ea typeface="Calibri" pitchFamily="34" charset="-122"/>
-                <a:cs typeface="Calibri" pitchFamily="34" charset="-120"/>
-              </a:rPr>
-              <a:t>Exit: 2 MFEs shipped through the full loop; integration ≤ 15% of feature effort</a:t>
-            </a:r>
-            <a:endParaRPr lang="en-US" sz="980" dirty="0"/>
-          </a:p>
-        </p:txBody>
-      </p:sp>
-      <p:sp>
-        <p:nvSpPr>
-          <p:cNvPr id="14" name="Shape 12"/>
-          <p:cNvSpPr/>
-          <p:nvPr/>
-        </p:nvSpPr>
-        <p:spPr>
-          <a:xfrm>
-            <a:off x="6210148" y="1691640"/>
-            <a:ext cx="2602154" cy="4206240"/>
+              <a:t>Multiple fictional universes from the same population of people and orgs is a triangulation gift: shared contributors, shared CI templates, and structurally similar repos let an observer correlate universes and back out the real domain. Rules: one fiction per team, never shared; separate internet orgs; no cross-referencing between universes; share world-BUILDING lessons inside the airgap, never world content outside it.</a:t>
+            </a:r>
+            <a:endParaRPr lang="en-US" sz="960" dirty="0"/>
+          </a:p>
+        </p:txBody>
+      </p:sp>
+      <p:sp>
+        <p:nvSpPr>
+          <p:cNvPr id="16" name="Shape 12"/>
+          <p:cNvSpPr/>
+          <p:nvPr/>
+        </p:nvSpPr>
+        <p:spPr>
+          <a:xfrm>
+            <a:off x="548640" y="3913632"/>
+            <a:ext cx="5400904" cy="2121408"/>
           </a:xfrm>
           <a:prstGeom prst="roundRect">
             <a:avLst>
-              <a:gd name="adj" fmla="val 2811"/>
+              <a:gd name="adj" fmla="val 3448"/>
             </a:avLst>
           </a:prstGeom>
           <a:solidFill>
-            <a:srgbClr val="EDF3FC"/>
+            <a:srgbClr val="EAF4EF"/>
           </a:solidFill>
           <a:ln/>
           <a:effectLst>
@@ -8983,14 +8914,58 @@
       </p:sp>
       <p:sp>
         <p:nvSpPr>
-          <p:cNvPr id="15" name="Text 13"/>
-          <p:cNvSpPr/>
-          <p:nvPr/>
-        </p:nvSpPr>
-        <p:spPr>
-          <a:xfrm>
-            <a:off x="6393028" y="1828800"/>
-            <a:ext cx="2236394" cy="274320"/>
+          <p:cNvPr id="17" name="Shape 13"/>
+          <p:cNvSpPr/>
+          <p:nvPr/>
+        </p:nvSpPr>
+        <p:spPr>
+          <a:xfrm>
+            <a:off x="749808" y="4096512"/>
+            <a:ext cx="475488" cy="475488"/>
+          </a:xfrm>
+          <a:prstGeom prst="ellipse">
+            <a:avLst/>
+          </a:prstGeom>
+          <a:solidFill>
+            <a:srgbClr val="2E7D5B"/>
+          </a:solidFill>
+          <a:ln/>
+        </p:spPr>
+      </p:sp>
+      <p:pic>
+        <p:nvPicPr>
+          <p:cNvPr id="18" name="Image 2" descr="preencoded.png">    </p:cNvPr>
+          <p:cNvPicPr>
+            <a:picLocks noChangeAspect="1"/>
+          </p:cNvPicPr>
+          <p:nvPr/>
+        </p:nvPicPr>
+        <p:blipFill>
+          <a:blip r:embed="rId3"/>
+          <a:stretch>
+            <a:fillRect/>
+          </a:stretch>
+        </p:blipFill>
+        <p:spPr>
+          <a:xfrm>
+            <a:off x="873435" y="4220139"/>
+            <a:ext cx="228234" cy="228234"/>
+          </a:xfrm>
+          <a:prstGeom prst="rect">
+            <a:avLst/>
+          </a:prstGeom>
+        </p:spPr>
+      </p:pic>
+      <p:sp>
+        <p:nvSpPr>
+          <p:cNvPr id="19" name="Text 14"/>
+          <p:cNvSpPr/>
+          <p:nvPr/>
+        </p:nvSpPr>
+        <p:spPr>
+          <a:xfrm>
+            <a:off x="1353312" y="4142232"/>
+            <a:ext cx="4440784" cy="365760"/>
           </a:xfrm>
           <a:prstGeom prst="rect">
             <a:avLst/>
@@ -9006,30 +8981,30 @@
               <a:buNone/>
             </a:pPr>
             <a:r>
-              <a:rPr lang="en-US" sz="1100" b="1" spc="200" kern="0" dirty="0">
-                <a:solidFill>
-                  <a:srgbClr val="5A6B8C"/>
-                </a:solidFill>
-                <a:latin typeface="Calibri" pitchFamily="34" charset="0"/>
-                <a:ea typeface="Calibri" pitchFamily="34" charset="-122"/>
-                <a:cs typeface="Calibri" pitchFamily="34" charset="-120"/>
-              </a:rPr>
-              <a:t>PHASE 2</a:t>
-            </a:r>
-            <a:endParaRPr lang="en-US" sz="1100" dirty="0"/>
-          </a:p>
-        </p:txBody>
-      </p:sp>
-      <p:sp>
-        <p:nvSpPr>
-          <p:cNvPr id="16" name="Text 14"/>
-          <p:cNvSpPr/>
-          <p:nvPr/>
-        </p:nvSpPr>
-        <p:spPr>
-          <a:xfrm>
-            <a:off x="6393028" y="2103120"/>
-            <a:ext cx="2236394" cy="685800"/>
+              <a:rPr lang="en-US" sz="1400" b="1" dirty="0">
+                <a:solidFill>
+                  <a:srgbClr val="2E7D5B"/>
+                </a:solidFill>
+                <a:latin typeface="Calibri" pitchFamily="34" charset="0"/>
+                <a:ea typeface="Calibri" pitchFamily="34" charset="-122"/>
+                <a:cs typeface="Calibri" pitchFamily="34" charset="-120"/>
+              </a:rPr>
+              <a:t>Write the standard first</a:t>
+            </a:r>
+            <a:endParaRPr lang="en-US" sz="1400" dirty="0"/>
+          </a:p>
+        </p:txBody>
+      </p:sp>
+      <p:sp>
+        <p:nvSpPr>
+          <p:cNvPr id="20" name="Text 15"/>
+          <p:cNvSpPr/>
+          <p:nvPr/>
+        </p:nvSpPr>
+        <p:spPr>
+          <a:xfrm>
+            <a:off x="777240" y="4572000"/>
+            <a:ext cx="4943704" cy="1280160"/>
           </a:xfrm>
           <a:prstGeom prst="rect">
             <a:avLst/>
@@ -9045,67 +9020,7 @@
               <a:buNone/>
             </a:pPr>
             <a:r>
-              <a:rPr lang="en-US" sz="1350" b="1" dirty="0">
-                <a:solidFill>
-                  <a:srgbClr val="1E2761"/>
-                </a:solidFill>
-                <a:latin typeface="Calibri" pitchFamily="34" charset="0"/>
-                <a:ea typeface="Calibri" pitchFamily="34" charset="-122"/>
-                <a:cs typeface="Calibri" pitchFamily="34" charset="-120"/>
-              </a:rPr>
-              <a:t>Outbound spec pipeline at scale</a:t>
-            </a:r>
-            <a:endParaRPr lang="en-US" sz="1350" dirty="0"/>
-          </a:p>
-          <a:p>
-            <a:pPr indent="0" marL="0">
-              <a:buNone/>
-            </a:pPr>
-            <a:r>
-              <a:rPr lang="en-US" sz="1350" b="1" dirty="0">
-                <a:solidFill>
-                  <a:srgbClr val="1E2761"/>
-                </a:solidFill>
-                <a:latin typeface="Calibri" pitchFamily="34" charset="0"/>
-                <a:ea typeface="Calibri" pitchFamily="34" charset="-122"/>
-                <a:cs typeface="Calibri" pitchFamily="34" charset="-120"/>
-              </a:rPr>
-              <a:t>(mo 6–14, overlaps)</a:t>
-            </a:r>
-            <a:endParaRPr lang="en-US" sz="1350" dirty="0"/>
-          </a:p>
-        </p:txBody>
-      </p:sp>
-      <p:sp>
-        <p:nvSpPr>
-          <p:cNvPr id="17" name="Text 15"/>
-          <p:cNvSpPr/>
-          <p:nvPr/>
-        </p:nvSpPr>
-        <p:spPr>
-          <a:xfrm>
-            <a:off x="6393028" y="2880360"/>
-            <a:ext cx="2236394" cy="2834640"/>
-          </a:xfrm>
-          <a:prstGeom prst="rect">
-            <a:avLst/>
-          </a:prstGeom>
-          <a:noFill/>
-          <a:ln/>
-        </p:spPr>
-        <p:txBody>
-          <a:bodyPr wrap="square" lIns="0" tIns="0" rIns="0" bIns="0" rtlCol="0" anchor="ctr"/>
-          <a:lstStyle/>
-          <a:p>
-            <a:pPr marL="342900" indent="-342900">
-              <a:spcAft>
-                <a:spcPts val="600"/>
-              </a:spcAft>
-              <a:buSzPct val="100000"/>
-              <a:buChar char="•"/>
-            </a:pPr>
-            <a:r>
-              <a:rPr lang="en-US" sz="980" dirty="0">
+              <a:rPr lang="en-US" sz="960" dirty="0">
                 <a:solidFill>
                   <a:srgbClr val="1B2440"/>
                 </a:solidFill>
@@ -9113,89 +9028,26 @@
                 <a:ea typeface="Calibri" pitchFamily="34" charset="-122"/>
                 <a:cs typeface="Calibri" pitchFamily="34" charset="-120"/>
               </a:rPr>
-              <a:t>Spec-package tooling hardened; Tier-0 standing approvals in force</a:t>
-            </a:r>
-            <a:endParaRPr lang="en-US" sz="980" dirty="0"/>
-          </a:p>
-          <a:p>
-            <a:pPr marL="342900" indent="-342900">
-              <a:spcAft>
-                <a:spcPts val="600"/>
-              </a:spcAft>
-              <a:buSzPct val="100000"/>
-              <a:buChar char="•"/>
-            </a:pPr>
-            <a:r>
-              <a:rPr lang="en-US" sz="980" dirty="0">
-                <a:solidFill>
-                  <a:srgbClr val="1B2440"/>
-                </a:solidFill>
-                <a:latin typeface="Calibri" pitchFamily="34" charset="0"/>
-                <a:ea typeface="Calibri" pitchFamily="34" charset="-122"/>
-                <a:cs typeface="Calibri" pitchFamily="34" charset="-120"/>
-              </a:rPr>
-              <a:t>Angular inventory complete; migration factory running per-feature</a:t>
-            </a:r>
-            <a:endParaRPr lang="en-US" sz="980" dirty="0"/>
-          </a:p>
-          <a:p>
-            <a:pPr marL="342900" indent="-342900">
-              <a:spcAft>
-                <a:spcPts val="600"/>
-              </a:spcAft>
-              <a:buSzPct val="100000"/>
-              <a:buChar char="•"/>
-            </a:pPr>
-            <a:r>
-              <a:rPr lang="en-US" sz="980" dirty="0">
-                <a:solidFill>
-                  <a:srgbClr val="1B2440"/>
-                </a:solidFill>
-                <a:latin typeface="Calibri" pitchFamily="34" charset="0"/>
-                <a:ea typeface="Calibri" pitchFamily="34" charset="-122"/>
-                <a:cs typeface="Calibri" pitchFamily="34" charset="-120"/>
-              </a:rPr>
-              <a:t>Sensitizer = logic-pack compiler + validators, fully inside</a:t>
-            </a:r>
-            <a:endParaRPr lang="en-US" sz="980" dirty="0"/>
-          </a:p>
-          <a:p>
-            <a:pPr marL="342900" indent="-342900">
-              <a:spcAft>
-                <a:spcPts val="600"/>
-              </a:spcAft>
-              <a:buSzPct val="100000"/>
-              <a:buChar char="•"/>
-            </a:pPr>
-            <a:r>
-              <a:rPr lang="en-US" sz="980" dirty="0">
-                <a:solidFill>
-                  <a:srgbClr val="1B2440"/>
-                </a:solidFill>
-                <a:latin typeface="Calibri" pitchFamily="34" charset="0"/>
-                <a:ea typeface="Calibri" pitchFamily="34" charset="-122"/>
-                <a:cs typeface="Calibri" pitchFamily="34" charset="-120"/>
-              </a:rPr>
-              <a:t>Exit: egress SLA met 90%+; zero security incidents; parity scoreboard trending to done</a:t>
-            </a:r>
-            <a:endParaRPr lang="en-US" sz="980" dirty="0"/>
-          </a:p>
-        </p:txBody>
-      </p:sp>
-      <p:sp>
-        <p:nvSpPr>
-          <p:cNvPr id="18" name="Shape 16"/>
-          <p:cNvSpPr/>
-          <p:nvPr/>
-        </p:nvSpPr>
-        <p:spPr>
-          <a:xfrm>
-            <a:off x="9040901" y="1691640"/>
-            <a:ext cx="2602154" cy="4206240"/>
+              <a:t>Whoever formalizes their gate process first will effectively write the department SOP — everyone else gets audited against it later. We have the head start: the desensitizer exists, the gate design exists. Co-author the standard with cyber NOW and the “desensitizer as internal product” play gains real customers: sibling teams adopt our tooling, and we become the paradigm's platform team rather than one of N users of someone else's rules.</a:t>
+            </a:r>
+            <a:endParaRPr lang="en-US" sz="960" dirty="0"/>
+          </a:p>
+        </p:txBody>
+      </p:sp>
+      <p:sp>
+        <p:nvSpPr>
+          <p:cNvPr id="21" name="Shape 16"/>
+          <p:cNvSpPr/>
+          <p:nvPr/>
+        </p:nvSpPr>
+        <p:spPr>
+          <a:xfrm>
+            <a:off x="6242152" y="3913632"/>
+            <a:ext cx="5400904" cy="2121408"/>
           </a:xfrm>
           <a:prstGeom prst="roundRect">
             <a:avLst>
-              <a:gd name="adj" fmla="val 2811"/>
+              <a:gd name="adj" fmla="val 3448"/>
             </a:avLst>
           </a:prstGeom>
           <a:solidFill>
@@ -9213,14 +9065,58 @@
       </p:sp>
       <p:sp>
         <p:nvSpPr>
-          <p:cNvPr id="19" name="Text 17"/>
-          <p:cNvSpPr/>
-          <p:nvPr/>
-        </p:nvSpPr>
-        <p:spPr>
-          <a:xfrm>
-            <a:off x="9223781" y="1828800"/>
-            <a:ext cx="2236394" cy="274320"/>
+          <p:cNvPr id="22" name="Shape 17"/>
+          <p:cNvSpPr/>
+          <p:nvPr/>
+        </p:nvSpPr>
+        <p:spPr>
+          <a:xfrm>
+            <a:off x="6443320" y="4096512"/>
+            <a:ext cx="475488" cy="475488"/>
+          </a:xfrm>
+          <a:prstGeom prst="ellipse">
+            <a:avLst/>
+          </a:prstGeom>
+          <a:solidFill>
+            <a:srgbClr val="2E7D5B"/>
+          </a:solidFill>
+          <a:ln/>
+        </p:spPr>
+      </p:sp>
+      <p:pic>
+        <p:nvPicPr>
+          <p:cNvPr id="23" name="Image 3" descr="preencoded.png">    </p:cNvPr>
+          <p:cNvPicPr>
+            <a:picLocks noChangeAspect="1"/>
+          </p:cNvPicPr>
+          <p:nvPr/>
+        </p:nvPicPr>
+        <p:blipFill>
+          <a:blip r:embed="rId4"/>
+          <a:stretch>
+            <a:fillRect/>
+          </a:stretch>
+        </p:blipFill>
+        <p:spPr>
+          <a:xfrm>
+            <a:off x="6566946" y="4220139"/>
+            <a:ext cx="228234" cy="228234"/>
+          </a:xfrm>
+          <a:prstGeom prst="rect">
+            <a:avLst/>
+          </a:prstGeom>
+        </p:spPr>
+      </p:pic>
+      <p:sp>
+        <p:nvSpPr>
+          <p:cNvPr id="24" name="Text 18"/>
+          <p:cNvSpPr/>
+          <p:nvPr/>
+        </p:nvSpPr>
+        <p:spPr>
+          <a:xfrm>
+            <a:off x="7046824" y="4142232"/>
+            <a:ext cx="4440784" cy="365760"/>
           </a:xfrm>
           <a:prstGeom prst="rect">
             <a:avLst/>
@@ -9236,7 +9132,7 @@
               <a:buNone/>
             </a:pPr>
             <a:r>
-              <a:rPr lang="en-US" sz="1100" b="1" spc="200" kern="0" dirty="0">
+              <a:rPr lang="en-US" sz="1400" b="1" dirty="0">
                 <a:solidFill>
                   <a:srgbClr val="2E7D5B"/>
                 </a:solidFill>
@@ -9244,224 +9140,87 @@
                 <a:ea typeface="Calibri" pitchFamily="34" charset="-122"/>
                 <a:cs typeface="Calibri" pitchFamily="34" charset="-120"/>
               </a:rPr>
-              <a:t>PHASE 3</a:t>
+              <a:t>Cross-team leverage</a:t>
+            </a:r>
+            <a:endParaRPr lang="en-US" sz="1400" dirty="0"/>
+          </a:p>
+        </p:txBody>
+      </p:sp>
+      <p:sp>
+        <p:nvSpPr>
+          <p:cNvPr id="25" name="Text 19"/>
+          <p:cNvSpPr/>
+          <p:nvPr/>
+        </p:nvSpPr>
+        <p:spPr>
+          <a:xfrm>
+            <a:off x="6470752" y="4572000"/>
+            <a:ext cx="4943704" cy="1280160"/>
+          </a:xfrm>
+          <a:prstGeom prst="rect">
+            <a:avLst/>
+          </a:prstGeom>
+          <a:noFill/>
+          <a:ln/>
+        </p:spPr>
+        <p:txBody>
+          <a:bodyPr wrap="square" lIns="0" tIns="0" rIns="0" bIns="0" rtlCol="0" anchor="ctr"/>
+          <a:lstStyle/>
+          <a:p>
+            <a:pPr indent="0" marL="0">
+              <a:buNone/>
+            </a:pPr>
+            <a:r>
+              <a:rPr lang="en-US" sz="960" dirty="0">
+                <a:solidFill>
+                  <a:srgbClr val="1B2440"/>
+                </a:solidFill>
+                <a:latin typeface="Calibri" pitchFamily="34" charset="0"/>
+                <a:ea typeface="Calibri" pitchFamily="34" charset="-122"/>
+                <a:cs typeface="Calibri" pitchFamily="34" charset="-120"/>
+              </a:rPr>
+              <a:t>Sibling teams solve our hardest staffing problems: Gate-2 reviewers borrowed across teams are GENUINELY fresh eyes (they don't share our context, so residual meaning jumps out); shared inner-source tooling (passive-shell engine, MSW scaffolds, dependency-delta job, mapping registry) amortizes platform cost across the department; and KPI benchmarking across teams will happen anyway — co-defining the metrics beats being measured by someone else's.</a:t>
+            </a:r>
+            <a:endParaRPr lang="en-US" sz="960" dirty="0"/>
+          </a:p>
+        </p:txBody>
+      </p:sp>
+      <p:sp>
+        <p:nvSpPr>
+          <p:cNvPr id="26" name="Text 20"/>
+          <p:cNvSpPr/>
+          <p:nvPr/>
+        </p:nvSpPr>
+        <p:spPr>
+          <a:xfrm>
+            <a:off x="548640" y="6236208"/>
+            <a:ext cx="11094415" cy="320040"/>
+          </a:xfrm>
+          <a:prstGeom prst="rect">
+            <a:avLst/>
+          </a:prstGeom>
+          <a:noFill/>
+          <a:ln/>
+        </p:spPr>
+        <p:txBody>
+          <a:bodyPr wrap="square" lIns="0" tIns="0" rIns="0" bIns="0" rtlCol="0" anchor="ctr"/>
+          <a:lstStyle/>
+          <a:p>
+            <a:pPr algn="ctr" indent="0" marL="0">
+              <a:buNone/>
+            </a:pPr>
+            <a:r>
+              <a:rPr lang="en-US" sz="1100" i="1" dirty="0">
+                <a:solidFill>
+                  <a:srgbClr val="5A6B8C"/>
+                </a:solidFill>
+                <a:latin typeface="Calibri" pitchFamily="34" charset="0"/>
+                <a:ea typeface="Calibri" pitchFamily="34" charset="-122"/>
+                <a:cs typeface="Calibri" pitchFamily="34" charset="-120"/>
+              </a:rPr>
+              <a:t>Blue = risks to close jointly · Green = advantages of moving first. And scale the approvers: N teams need a cyber rota, not a named hero.</a:t>
             </a:r>
             <a:endParaRPr lang="en-US" sz="1100" dirty="0"/>
-          </a:p>
-        </p:txBody>
-      </p:sp>
-      <p:sp>
-        <p:nvSpPr>
-          <p:cNvPr id="20" name="Text 18"/>
-          <p:cNvSpPr/>
-          <p:nvPr/>
-        </p:nvSpPr>
-        <p:spPr>
-          <a:xfrm>
-            <a:off x="9223781" y="2103120"/>
-            <a:ext cx="2236394" cy="685800"/>
-          </a:xfrm>
-          <a:prstGeom prst="rect">
-            <a:avLst/>
-          </a:prstGeom>
-          <a:noFill/>
-          <a:ln/>
-        </p:spPr>
-        <p:txBody>
-          <a:bodyPr wrap="square" lIns="0" tIns="0" rIns="0" bIns="0" rtlCol="0" anchor="ctr"/>
-          <a:lstStyle/>
-          <a:p>
-            <a:pPr indent="0" marL="0">
-              <a:buNone/>
-            </a:pPr>
-            <a:r>
-              <a:rPr lang="en-US" sz="1350" b="1" dirty="0">
-                <a:solidFill>
-                  <a:srgbClr val="1E2761"/>
-                </a:solidFill>
-                <a:latin typeface="Calibri" pitchFamily="34" charset="0"/>
-                <a:ea typeface="Calibri" pitchFamily="34" charset="-122"/>
-                <a:cs typeface="Calibri" pitchFamily="34" charset="-120"/>
-              </a:rPr>
-              <a:t>Core-team absorption</a:t>
-            </a:r>
-            <a:endParaRPr lang="en-US" sz="1350" dirty="0"/>
-          </a:p>
-          <a:p>
-            <a:pPr indent="0" marL="0">
-              <a:buNone/>
-            </a:pPr>
-            <a:r>
-              <a:rPr lang="en-US" sz="1350" b="1" dirty="0">
-                <a:solidFill>
-                  <a:srgbClr val="1E2761"/>
-                </a:solidFill>
-                <a:latin typeface="Calibri" pitchFamily="34" charset="0"/>
-                <a:ea typeface="Calibri" pitchFamily="34" charset="-122"/>
-                <a:cs typeface="Calibri" pitchFamily="34" charset="-120"/>
-              </a:rPr>
-              <a:t>(trigger-based)</a:t>
-            </a:r>
-            <a:endParaRPr lang="en-US" sz="1350" dirty="0"/>
-          </a:p>
-        </p:txBody>
-      </p:sp>
-      <p:sp>
-        <p:nvSpPr>
-          <p:cNvPr id="21" name="Text 19"/>
-          <p:cNvSpPr/>
-          <p:nvPr/>
-        </p:nvSpPr>
-        <p:spPr>
-          <a:xfrm>
-            <a:off x="9223781" y="2880360"/>
-            <a:ext cx="2236394" cy="2834640"/>
-          </a:xfrm>
-          <a:prstGeom prst="rect">
-            <a:avLst/>
-          </a:prstGeom>
-          <a:noFill/>
-          <a:ln/>
-        </p:spPr>
-        <p:txBody>
-          <a:bodyPr wrap="square" lIns="0" tIns="0" rIns="0" bIns="0" rtlCol="0" anchor="ctr"/>
-          <a:lstStyle/>
-          <a:p>
-            <a:pPr marL="342900" indent="-342900">
-              <a:spcAft>
-                <a:spcPts val="600"/>
-              </a:spcAft>
-              <a:buSzPct val="100000"/>
-              <a:buChar char="•"/>
-            </a:pPr>
-            <a:r>
-              <a:rPr lang="en-US" sz="980" dirty="0">
-                <a:solidFill>
-                  <a:srgbClr val="1B2440"/>
-                </a:solidFill>
-                <a:latin typeface="Calibri" pitchFamily="34" charset="0"/>
-                <a:ea typeface="Calibri" pitchFamily="34" charset="-122"/>
-                <a:cs typeface="Calibri" pitchFamily="34" charset="-120"/>
-              </a:rPr>
-              <a:t>Trigger: contractor reduction mandate — readiness is built in Phases 1–2, not when the memo lands</a:t>
-            </a:r>
-            <a:endParaRPr lang="en-US" sz="980" dirty="0"/>
-          </a:p>
-          <a:p>
-            <a:pPr marL="342900" indent="-342900">
-              <a:spcAft>
-                <a:spcPts val="600"/>
-              </a:spcAft>
-              <a:buSzPct val="100000"/>
-              <a:buChar char="•"/>
-            </a:pPr>
-            <a:r>
-              <a:rPr lang="en-US" sz="980" dirty="0">
-                <a:solidFill>
-                  <a:srgbClr val="1B2440"/>
-                </a:solidFill>
-                <a:latin typeface="Calibri" pitchFamily="34" charset="0"/>
-                <a:ea typeface="Calibri" pitchFamily="34" charset="-122"/>
-                <a:cs typeface="Calibri" pitchFamily="34" charset="-120"/>
-              </a:rPr>
-              <a:t>Every contractor duty has a documented runbook + a core-team owner who has already done it (rotation in Phase 2)</a:t>
-            </a:r>
-            <a:endParaRPr lang="en-US" sz="980" dirty="0"/>
-          </a:p>
-          <a:p>
-            <a:pPr marL="342900" indent="-342900">
-              <a:spcAft>
-                <a:spcPts val="600"/>
-              </a:spcAft>
-              <a:buSzPct val="100000"/>
-              <a:buChar char="•"/>
-            </a:pPr>
-            <a:r>
-              <a:rPr lang="en-US" sz="980" dirty="0">
-                <a:solidFill>
-                  <a:srgbClr val="1B2440"/>
-                </a:solidFill>
-                <a:latin typeface="Calibri" pitchFamily="34" charset="0"/>
-                <a:ea typeface="Calibri" pitchFamily="34" charset="-122"/>
-                <a:cs typeface="Calibri" pitchFamily="34" charset="-120"/>
-              </a:rPr>
-              <a:t>Automate the residue: integration scripts, mapping validators, config lint</a:t>
-            </a:r>
-            <a:endParaRPr lang="en-US" sz="980" dirty="0"/>
-          </a:p>
-          <a:p>
-            <a:pPr marL="342900" indent="-342900">
-              <a:spcAft>
-                <a:spcPts val="600"/>
-              </a:spcAft>
-              <a:buSzPct val="100000"/>
-              <a:buChar char="•"/>
-            </a:pPr>
-            <a:r>
-              <a:rPr lang="en-US" sz="980" dirty="0">
-                <a:solidFill>
-                  <a:srgbClr val="1B2440"/>
-                </a:solidFill>
-                <a:latin typeface="Calibri" pitchFamily="34" charset="0"/>
-                <a:ea typeface="Calibri" pitchFamily="34" charset="-122"/>
-                <a:cs typeface="Calibri" pitchFamily="34" charset="-120"/>
-              </a:rPr>
-              <a:t>Exit: full loop runs with core team only, one release proven</a:t>
-            </a:r>
-            <a:endParaRPr lang="en-US" sz="980" dirty="0"/>
-          </a:p>
-        </p:txBody>
-      </p:sp>
-      <p:sp>
-        <p:nvSpPr>
-          <p:cNvPr id="22" name="Text 20"/>
-          <p:cNvSpPr/>
-          <p:nvPr/>
-        </p:nvSpPr>
-        <p:spPr>
-          <a:xfrm>
-            <a:off x="548640" y="6035040"/>
-            <a:ext cx="11094415" cy="411480"/>
-          </a:xfrm>
-          <a:prstGeom prst="rect">
-            <a:avLst/>
-          </a:prstGeom>
-          <a:noFill/>
-          <a:ln/>
-        </p:spPr>
-        <p:txBody>
-          <a:bodyPr wrap="square" lIns="0" tIns="0" rIns="0" bIns="0" rtlCol="0" anchor="ctr"/>
-          <a:lstStyle/>
-          <a:p>
-            <a:pPr algn="ctr" indent="0" marL="0">
-              <a:buNone/>
-            </a:pPr>
-            <a:r>
-              <a:rPr lang="en-US" sz="1250" b="1" dirty="0">
-                <a:solidFill>
-                  <a:srgbClr val="1E2761"/>
-                </a:solidFill>
-                <a:latin typeface="Calibri" pitchFamily="34" charset="0"/>
-                <a:ea typeface="Calibri" pitchFamily="34" charset="-122"/>
-                <a:cs typeface="Calibri" pitchFamily="34" charset="-120"/>
-              </a:rPr>
-              <a:t>Honest expectation: </a:t>
-            </a:r>
-            <a:pPr algn="ctr" indent="0" marL="0">
-              <a:buNone/>
-            </a:pPr>
-            <a:r>
-              <a:rPr lang="en-US" sz="1250" dirty="0">
-                <a:solidFill>
-                  <a:srgbClr val="1B2440"/>
-                </a:solidFill>
-                <a:latin typeface="Calibri" pitchFamily="34" charset="0"/>
-                <a:ea typeface="Calibri" pitchFamily="34" charset="-122"/>
-                <a:cs typeface="Calibri" pitchFamily="34" charset="-120"/>
-              </a:rPr>
-              <a:t>the first loop will be slower than today — you are building the factory while running it. Speed compounds from MFE #3 onward. Say this out loud on day one, or month 3 will be read as failure.</a:t>
-            </a:r>
-            <a:endParaRPr lang="en-US" sz="1250" dirty="0"/>
           </a:p>
         </p:txBody>
       </p:sp>
@@ -9608,7 +9367,7 @@
                 <a:ea typeface="Calibri" pitchFamily="34" charset="-122"/>
                 <a:cs typeface="Calibri" pitchFamily="34" charset="-120"/>
               </a:rPr>
-              <a:t>MEASURING IT · THE COUNTER-NARRATIVE</a:t>
+              <a:t>EXECUTION · A PRAGMATIC TRANSITION TIMELINE</a:t>
             </a:r>
             <a:endParaRPr lang="en-US" sz="1200" dirty="0"/>
           </a:p>
@@ -9647,7 +9406,7 @@
                 <a:ea typeface="Cambria" pitchFamily="34" charset="-122"/>
                 <a:cs typeface="Cambria" pitchFamily="34" charset="-120"/>
               </a:rPr>
-              <a:t>The scoreboard that wins the argument</a:t>
+              <a:t>Phase exits are criteria, not dates</a:t>
             </a:r>
             <a:endParaRPr lang="en-US" sz="3000" dirty="0"/>
           </a:p>
@@ -9662,11 +9421,11 @@
         <p:spPr>
           <a:xfrm>
             <a:off x="548640" y="1691640"/>
-            <a:ext cx="3515258" cy="2011680"/>
+            <a:ext cx="2602154" cy="4206240"/>
           </a:xfrm>
           <a:prstGeom prst="roundRect">
             <a:avLst>
-              <a:gd name="adj" fmla="val 3636"/>
+              <a:gd name="adj" fmla="val 2811"/>
             </a:avLst>
           </a:prstGeom>
           <a:solidFill>
@@ -9684,58 +9443,14 @@
       </p:sp>
       <p:sp>
         <p:nvSpPr>
-          <p:cNvPr id="7" name="Shape 5"/>
-          <p:cNvSpPr/>
-          <p:nvPr/>
-        </p:nvSpPr>
-        <p:spPr>
-          <a:xfrm>
-            <a:off x="749808" y="1892808"/>
-            <a:ext cx="502920" cy="502920"/>
-          </a:xfrm>
-          <a:prstGeom prst="ellipse">
-            <a:avLst/>
-          </a:prstGeom>
-          <a:solidFill>
-            <a:srgbClr val="1E2761"/>
-          </a:solidFill>
-          <a:ln/>
-        </p:spPr>
-      </p:sp>
-      <p:pic>
-        <p:nvPicPr>
-          <p:cNvPr id="8" name="Image 0" descr="preencoded.png">    </p:cNvPr>
-          <p:cNvPicPr>
-            <a:picLocks noChangeAspect="1"/>
-          </p:cNvPicPr>
-          <p:nvPr/>
-        </p:nvPicPr>
-        <p:blipFill>
-          <a:blip r:embed="rId1"/>
-          <a:stretch>
-            <a:fillRect/>
-          </a:stretch>
-        </p:blipFill>
-        <p:spPr>
-          <a:xfrm>
-            <a:off x="880567" y="2023567"/>
-            <a:ext cx="241402" cy="241402"/>
-          </a:xfrm>
-          <a:prstGeom prst="rect">
-            <a:avLst/>
-          </a:prstGeom>
-        </p:spPr>
-      </p:pic>
-      <p:sp>
-        <p:nvSpPr>
-          <p:cNvPr id="9" name="Text 6"/>
-          <p:cNvSpPr/>
-          <p:nvPr/>
-        </p:nvSpPr>
-        <p:spPr>
-          <a:xfrm>
-            <a:off x="1389888" y="1947672"/>
-            <a:ext cx="2509418" cy="384048"/>
+          <p:cNvPr id="7" name="Text 5"/>
+          <p:cNvSpPr/>
+          <p:nvPr/>
+        </p:nvSpPr>
+        <p:spPr>
+          <a:xfrm>
+            <a:off x="731520" y="1828800"/>
+            <a:ext cx="2236394" cy="274320"/>
           </a:xfrm>
           <a:prstGeom prst="rect">
             <a:avLst/>
@@ -9751,7 +9466,46 @@
               <a:buNone/>
             </a:pPr>
             <a:r>
-              <a:rPr lang="en-US" sz="1450" b="1" dirty="0">
+              <a:rPr lang="en-US" sz="1100" b="1" spc="200" kern="0" dirty="0">
+                <a:solidFill>
+                  <a:srgbClr val="5A6B8C"/>
+                </a:solidFill>
+                <a:latin typeface="Calibri" pitchFamily="34" charset="0"/>
+                <a:ea typeface="Calibri" pitchFamily="34" charset="-122"/>
+                <a:cs typeface="Calibri" pitchFamily="34" charset="-120"/>
+              </a:rPr>
+              <a:t>PHASE 0</a:t>
+            </a:r>
+            <a:endParaRPr lang="en-US" sz="1100" dirty="0"/>
+          </a:p>
+        </p:txBody>
+      </p:sp>
+      <p:sp>
+        <p:nvSpPr>
+          <p:cNvPr id="8" name="Text 6"/>
+          <p:cNvSpPr/>
+          <p:nvPr/>
+        </p:nvSpPr>
+        <p:spPr>
+          <a:xfrm>
+            <a:off x="731520" y="2103120"/>
+            <a:ext cx="2236394" cy="685800"/>
+          </a:xfrm>
+          <a:prstGeom prst="rect">
+            <a:avLst/>
+          </a:prstGeom>
+          <a:noFill/>
+          <a:ln/>
+        </p:spPr>
+        <p:txBody>
+          <a:bodyPr wrap="square" lIns="0" tIns="0" rIns="0" bIns="0" rtlCol="0" anchor="ctr"/>
+          <a:lstStyle/>
+          <a:p>
+            <a:pPr indent="0" marL="0">
+              <a:buNone/>
+            </a:pPr>
+            <a:r>
+              <a:rPr lang="en-US" sz="1350" b="1" dirty="0">
                 <a:solidFill>
                   <a:srgbClr val="1E2761"/>
                 </a:solidFill>
@@ -9759,38 +9513,59 @@
                 <a:ea typeface="Calibri" pitchFamily="34" charset="-122"/>
                 <a:cs typeface="Calibri" pitchFamily="34" charset="-120"/>
               </a:rPr>
-              <a:t>Lead time</a:t>
-            </a:r>
-            <a:endParaRPr lang="en-US" sz="1450" dirty="0"/>
-          </a:p>
-        </p:txBody>
-      </p:sp>
-      <p:sp>
-        <p:nvSpPr>
-          <p:cNvPr id="10" name="Text 7"/>
-          <p:cNvSpPr/>
-          <p:nvPr/>
-        </p:nvSpPr>
-        <p:spPr>
-          <a:xfrm>
-            <a:off x="777240" y="2468880"/>
-            <a:ext cx="3058058" cy="1051560"/>
-          </a:xfrm>
-          <a:prstGeom prst="rect">
-            <a:avLst/>
-          </a:prstGeom>
-          <a:noFill/>
-          <a:ln/>
-        </p:spPr>
-        <p:txBody>
-          <a:bodyPr wrap="square" lIns="0" tIns="0" rIns="0" bIns="0" rtlCol="0" anchor="ctr"/>
-          <a:lstStyle/>
+              <a:t>Legitimize &amp; pilot</a:t>
+            </a:r>
+            <a:endParaRPr lang="en-US" sz="1350" dirty="0"/>
+          </a:p>
           <a:p>
             <a:pPr indent="0" marL="0">
               <a:buNone/>
             </a:pPr>
             <a:r>
-              <a:rPr lang="en-US" sz="1100" dirty="0">
+              <a:rPr lang="en-US" sz="1350" b="1" dirty="0">
+                <a:solidFill>
+                  <a:srgbClr val="1E2761"/>
+                </a:solidFill>
+                <a:latin typeface="Calibri" pitchFamily="34" charset="0"/>
+                <a:ea typeface="Calibri" pitchFamily="34" charset="-122"/>
+                <a:cs typeface="Calibri" pitchFamily="34" charset="-120"/>
+              </a:rPr>
+              <a:t>(mo 0–2)</a:t>
+            </a:r>
+            <a:endParaRPr lang="en-US" sz="1350" dirty="0"/>
+          </a:p>
+        </p:txBody>
+      </p:sp>
+      <p:sp>
+        <p:nvSpPr>
+          <p:cNvPr id="9" name="Text 7"/>
+          <p:cNvSpPr/>
+          <p:nvPr/>
+        </p:nvSpPr>
+        <p:spPr>
+          <a:xfrm>
+            <a:off x="731520" y="2880360"/>
+            <a:ext cx="2236394" cy="2834640"/>
+          </a:xfrm>
+          <a:prstGeom prst="rect">
+            <a:avLst/>
+          </a:prstGeom>
+          <a:noFill/>
+          <a:ln/>
+        </p:spPr>
+        <p:txBody>
+          <a:bodyPr wrap="square" lIns="0" tIns="0" rIns="0" bIns="0" rtlCol="0" anchor="ctr"/>
+          <a:lstStyle/>
+          <a:p>
+            <a:pPr marL="342900" indent="-342900">
+              <a:spcAft>
+                <a:spcPts val="600"/>
+              </a:spcAft>
+              <a:buSzPct val="100000"/>
+              <a:buChar char="•"/>
+            </a:pPr>
+            <a:r>
+              <a:rPr lang="en-US" sz="980" dirty="0">
                 <a:solidFill>
                   <a:srgbClr val="1B2440"/>
                 </a:solidFill>
@@ -9798,26 +9573,89 @@
                 <a:ea typeface="Calibri" pitchFamily="34" charset="-122"/>
                 <a:cs typeface="Calibri" pitchFamily="34" charset="-120"/>
               </a:rPr>
-              <a:t>Spec-frozen → running in Confi, per feature. The headline number stakeholders compare against “days”. Target: weeks, trending down every quarter.</a:t>
-            </a:r>
-            <a:endParaRPr lang="en-US" sz="1100" dirty="0"/>
-          </a:p>
-        </p:txBody>
-      </p:sp>
-      <p:sp>
-        <p:nvSpPr>
-          <p:cNvPr id="11" name="Shape 8"/>
-          <p:cNvSpPr/>
-          <p:nvPr/>
-        </p:nvSpPr>
-        <p:spPr>
-          <a:xfrm>
-            <a:off x="4338218" y="1691640"/>
-            <a:ext cx="3515258" cy="2011680"/>
+              <a:t>Written authorization: scope, egress channel, named approvers</a:t>
+            </a:r>
+            <a:endParaRPr lang="en-US" sz="980" dirty="0"/>
+          </a:p>
+          <a:p>
+            <a:pPr marL="342900" indent="-342900">
+              <a:spcAft>
+                <a:spcPts val="600"/>
+              </a:spcAft>
+              <a:buSzPct val="100000"/>
+              <a:buChar char="•"/>
+            </a:pPr>
+            <a:r>
+              <a:rPr lang="en-US" sz="980" dirty="0">
+                <a:solidFill>
+                  <a:srgbClr val="1B2440"/>
+                </a:solidFill>
+                <a:latin typeface="Calibri" pitchFamily="34" charset="0"/>
+                <a:ea typeface="Calibri" pitchFamily="34" charset="-122"/>
+                <a:cs typeface="Calibri" pitchFamily="34" charset="-120"/>
+              </a:rPr>
+              <a:t>Gates 0–3 stood up; denylist co-authored with cyber</a:t>
+            </a:r>
+            <a:endParaRPr lang="en-US" sz="980" dirty="0"/>
+          </a:p>
+          <a:p>
+            <a:pPr marL="342900" indent="-342900">
+              <a:spcAft>
+                <a:spcPts val="600"/>
+              </a:spcAft>
+              <a:buSzPct val="100000"/>
+              <a:buChar char="•"/>
+            </a:pPr>
+            <a:r>
+              <a:rPr lang="en-US" sz="980" dirty="0">
+                <a:solidFill>
+                  <a:srgbClr val="1B2440"/>
+                </a:solidFill>
+                <a:latin typeface="Calibri" pitchFamily="34" charset="0"/>
+                <a:ea typeface="Calibri" pitchFamily="34" charset="-122"/>
+                <a:cs typeface="Calibri" pitchFamily="34" charset="-120"/>
+              </a:rPr>
+              <a:t>World bible v1 + internet org &amp; repos with CI parity</a:t>
+            </a:r>
+            <a:endParaRPr lang="en-US" sz="980" dirty="0"/>
+          </a:p>
+          <a:p>
+            <a:pPr marL="342900" indent="-342900">
+              <a:spcAft>
+                <a:spcPts val="600"/>
+              </a:spcAft>
+              <a:buSzPct val="100000"/>
+              <a:buChar char="•"/>
+            </a:pPr>
+            <a:r>
+              <a:rPr lang="en-US" sz="980" dirty="0">
+                <a:solidFill>
+                  <a:srgbClr val="1B2440"/>
+                </a:solidFill>
+                <a:latin typeface="Calibri" pitchFamily="34" charset="0"/>
+                <a:ea typeface="Calibri" pitchFamily="34" charset="-122"/>
+                <a:cs typeface="Calibri" pitchFamily="34" charset="-120"/>
+              </a:rPr>
+              <a:t>Pilot feature specced and egressed</a:t>
+            </a:r>
+            <a:endParaRPr lang="en-US" sz="980" dirty="0"/>
+          </a:p>
+        </p:txBody>
+      </p:sp>
+      <p:sp>
+        <p:nvSpPr>
+          <p:cNvPr id="10" name="Shape 8"/>
+          <p:cNvSpPr/>
+          <p:nvPr/>
+        </p:nvSpPr>
+        <p:spPr>
+          <a:xfrm>
+            <a:off x="3379394" y="1691640"/>
+            <a:ext cx="2602154" cy="4206240"/>
           </a:xfrm>
           <a:prstGeom prst="roundRect">
             <a:avLst>
-              <a:gd name="adj" fmla="val 3636"/>
+              <a:gd name="adj" fmla="val 2811"/>
             </a:avLst>
           </a:prstGeom>
           <a:solidFill>
@@ -9835,58 +9673,14 @@
       </p:sp>
       <p:sp>
         <p:nvSpPr>
-          <p:cNvPr id="12" name="Shape 9"/>
-          <p:cNvSpPr/>
-          <p:nvPr/>
-        </p:nvSpPr>
-        <p:spPr>
-          <a:xfrm>
-            <a:off x="4539386" y="1892808"/>
-            <a:ext cx="502920" cy="502920"/>
-          </a:xfrm>
-          <a:prstGeom prst="ellipse">
-            <a:avLst/>
-          </a:prstGeom>
-          <a:solidFill>
-            <a:srgbClr val="1E2761"/>
-          </a:solidFill>
-          <a:ln/>
-        </p:spPr>
-      </p:sp>
-      <p:pic>
-        <p:nvPicPr>
-          <p:cNvPr id="13" name="Image 1" descr="preencoded.png">    </p:cNvPr>
-          <p:cNvPicPr>
-            <a:picLocks noChangeAspect="1"/>
-          </p:cNvPicPr>
-          <p:nvPr/>
-        </p:nvPicPr>
-        <p:blipFill>
-          <a:blip r:embed="rId2"/>
-          <a:stretch>
-            <a:fillRect/>
-          </a:stretch>
-        </p:blipFill>
-        <p:spPr>
-          <a:xfrm>
-            <a:off x="4670146" y="2023567"/>
-            <a:ext cx="241402" cy="241402"/>
-          </a:xfrm>
-          <a:prstGeom prst="rect">
-            <a:avLst/>
-          </a:prstGeom>
-        </p:spPr>
-      </p:pic>
-      <p:sp>
-        <p:nvSpPr>
-          <p:cNvPr id="14" name="Text 10"/>
-          <p:cNvSpPr/>
-          <p:nvPr/>
-        </p:nvSpPr>
-        <p:spPr>
-          <a:xfrm>
-            <a:off x="5179466" y="1947672"/>
-            <a:ext cx="2509418" cy="384048"/>
+          <p:cNvPr id="11" name="Text 9"/>
+          <p:cNvSpPr/>
+          <p:nvPr/>
+        </p:nvSpPr>
+        <p:spPr>
+          <a:xfrm>
+            <a:off x="3562274" y="1828800"/>
+            <a:ext cx="2236394" cy="274320"/>
           </a:xfrm>
           <a:prstGeom prst="rect">
             <a:avLst/>
@@ -9902,7 +9696,46 @@
               <a:buNone/>
             </a:pPr>
             <a:r>
-              <a:rPr lang="en-US" sz="1450" b="1" dirty="0">
+              <a:rPr lang="en-US" sz="1100" b="1" spc="200" kern="0" dirty="0">
+                <a:solidFill>
+                  <a:srgbClr val="5A6B8C"/>
+                </a:solidFill>
+                <a:latin typeface="Calibri" pitchFamily="34" charset="0"/>
+                <a:ea typeface="Calibri" pitchFamily="34" charset="-122"/>
+                <a:cs typeface="Calibri" pitchFamily="34" charset="-120"/>
+              </a:rPr>
+              <a:t>PHASE 1</a:t>
+            </a:r>
+            <a:endParaRPr lang="en-US" sz="1100" dirty="0"/>
+          </a:p>
+        </p:txBody>
+      </p:sp>
+      <p:sp>
+        <p:nvSpPr>
+          <p:cNvPr id="12" name="Text 10"/>
+          <p:cNvSpPr/>
+          <p:nvPr/>
+        </p:nvSpPr>
+        <p:spPr>
+          <a:xfrm>
+            <a:off x="3562274" y="2103120"/>
+            <a:ext cx="2236394" cy="685800"/>
+          </a:xfrm>
+          <a:prstGeom prst="rect">
+            <a:avLst/>
+          </a:prstGeom>
+          <a:noFill/>
+          <a:ln/>
+        </p:spPr>
+        <p:txBody>
+          <a:bodyPr wrap="square" lIns="0" tIns="0" rIns="0" bIns="0" rtlCol="0" anchor="ctr"/>
+          <a:lstStyle/>
+          <a:p>
+            <a:pPr indent="0" marL="0">
+              <a:buNone/>
+            </a:pPr>
+            <a:r>
+              <a:rPr lang="en-US" sz="1350" b="1" dirty="0">
                 <a:solidFill>
                   <a:srgbClr val="1E2761"/>
                 </a:solidFill>
@@ -9910,38 +9743,59 @@
                 <a:ea typeface="Calibri" pitchFamily="34" charset="-122"/>
                 <a:cs typeface="Calibri" pitchFamily="34" charset="-120"/>
               </a:rPr>
-              <a:t>Integration tax</a:t>
-            </a:r>
-            <a:endParaRPr lang="en-US" sz="1450" dirty="0"/>
-          </a:p>
-        </p:txBody>
-      </p:sp>
-      <p:sp>
-        <p:nvSpPr>
-          <p:cNvPr id="15" name="Text 11"/>
-          <p:cNvSpPr/>
-          <p:nvPr/>
-        </p:nvSpPr>
-        <p:spPr>
-          <a:xfrm>
-            <a:off x="4566818" y="2468880"/>
-            <a:ext cx="3058058" cy="1051560"/>
-          </a:xfrm>
-          <a:prstGeom prst="rect">
-            <a:avLst/>
-          </a:prstGeom>
-          <a:noFill/>
-          <a:ln/>
-        </p:spPr>
-        <p:txBody>
-          <a:bodyPr wrap="square" lIns="0" tIns="0" rIns="0" bIns="0" rtlCol="0" anchor="ctr"/>
-          <a:lstStyle/>
+              <a:t>Internet-first core team</a:t>
+            </a:r>
+            <a:endParaRPr lang="en-US" sz="1350" dirty="0"/>
+          </a:p>
           <a:p>
             <a:pPr indent="0" marL="0">
               <a:buNone/>
             </a:pPr>
             <a:r>
-              <a:rPr lang="en-US" sz="1100" dirty="0">
+              <a:rPr lang="en-US" sz="1350" b="1" dirty="0">
+                <a:solidFill>
+                  <a:srgbClr val="1E2761"/>
+                </a:solidFill>
+                <a:latin typeface="Calibri" pitchFamily="34" charset="0"/>
+                <a:ea typeface="Calibri" pitchFamily="34" charset="-122"/>
+                <a:cs typeface="Calibri" pitchFamily="34" charset="-120"/>
+              </a:rPr>
+              <a:t>(mo 2–8)</a:t>
+            </a:r>
+            <a:endParaRPr lang="en-US" sz="1350" dirty="0"/>
+          </a:p>
+        </p:txBody>
+      </p:sp>
+      <p:sp>
+        <p:nvSpPr>
+          <p:cNvPr id="13" name="Text 11"/>
+          <p:cNvSpPr/>
+          <p:nvPr/>
+        </p:nvSpPr>
+        <p:spPr>
+          <a:xfrm>
+            <a:off x="3562274" y="2880360"/>
+            <a:ext cx="2236394" cy="2834640"/>
+          </a:xfrm>
+          <a:prstGeom prst="rect">
+            <a:avLst/>
+          </a:prstGeom>
+          <a:noFill/>
+          <a:ln/>
+        </p:spPr>
+        <p:txBody>
+          <a:bodyPr wrap="square" lIns="0" tIns="0" rIns="0" bIns="0" rtlCol="0" anchor="ctr"/>
+          <a:lstStyle/>
+          <a:p>
+            <a:pPr marL="342900" indent="-342900">
+              <a:spcAft>
+                <a:spcPts val="600"/>
+              </a:spcAft>
+              <a:buSzPct val="100000"/>
+              <a:buChar char="•"/>
+            </a:pPr>
+            <a:r>
+              <a:rPr lang="en-US" sz="980" dirty="0">
                 <a:solidFill>
                   <a:srgbClr val="1B2440"/>
                 </a:solidFill>
@@ -9949,26 +9803,89 @@
                 <a:ea typeface="Calibri" pitchFamily="34" charset="-122"/>
                 <a:cs typeface="Calibri" pitchFamily="34" charset="-120"/>
               </a:rPr>
-              <a:t>% of feature effort spent inside after the tag lands. The paradigm's core health metric. Target ≤ 15%; rising = spec/mock/pack drift.</a:t>
-            </a:r>
-            <a:endParaRPr lang="en-US" sz="1100" dirty="0"/>
-          </a:p>
-        </p:txBody>
-      </p:sp>
-      <p:sp>
-        <p:nvSpPr>
-          <p:cNvPr id="16" name="Shape 12"/>
-          <p:cNvSpPr/>
-          <p:nvPr/>
-        </p:nvSpPr>
-        <p:spPr>
-          <a:xfrm>
-            <a:off x="8127797" y="1691640"/>
-            <a:ext cx="3515258" cy="2011680"/>
+              <a:t>Core team builds pilot + 2–3 MFEs outside; logic-pack engine v1</a:t>
+            </a:r>
+            <a:endParaRPr lang="en-US" sz="980" dirty="0"/>
+          </a:p>
+          <a:p>
+            <a:pPr marL="342900" indent="-342900">
+              <a:spcAft>
+                <a:spcPts val="600"/>
+              </a:spcAft>
+              <a:buSzPct val="100000"/>
+              <a:buChar char="•"/>
+            </a:pPr>
+            <a:r>
+              <a:rPr lang="en-US" sz="980" dirty="0">
+                <a:solidFill>
+                  <a:srgbClr val="1B2440"/>
+                </a:solidFill>
+                <a:latin typeface="Calibri" pitchFamily="34" charset="0"/>
+                <a:ea typeface="Calibri" pitchFamily="34" charset="-122"/>
+                <a:cs typeface="Calibri" pitchFamily="34" charset="-120"/>
+              </a:rPr>
+              <a:t>Contractors own integration, mappings, env testing, config mgmt; some move to BA/spec roles</a:t>
+            </a:r>
+            <a:endParaRPr lang="en-US" sz="980" dirty="0"/>
+          </a:p>
+          <a:p>
+            <a:pPr marL="342900" indent="-342900">
+              <a:spcAft>
+                <a:spcPts val="600"/>
+              </a:spcAft>
+              <a:buSzPct val="100000"/>
+              <a:buChar char="•"/>
+            </a:pPr>
+            <a:r>
+              <a:rPr lang="en-US" sz="980" dirty="0">
+                <a:solidFill>
+                  <a:srgbClr val="1B2440"/>
+                </a:solidFill>
+                <a:latin typeface="Calibri" pitchFamily="34" charset="0"/>
+                <a:ea typeface="Calibri" pitchFamily="34" charset="-122"/>
+                <a:cs typeface="Calibri" pitchFamily="34" charset="-120"/>
+              </a:rPr>
+              <a:t>Dependency-delta job feeding Confi registry requests</a:t>
+            </a:r>
+            <a:endParaRPr lang="en-US" sz="980" dirty="0"/>
+          </a:p>
+          <a:p>
+            <a:pPr marL="342900" indent="-342900">
+              <a:spcAft>
+                <a:spcPts val="600"/>
+              </a:spcAft>
+              <a:buSzPct val="100000"/>
+              <a:buChar char="•"/>
+            </a:pPr>
+            <a:r>
+              <a:rPr lang="en-US" sz="980" dirty="0">
+                <a:solidFill>
+                  <a:srgbClr val="1B2440"/>
+                </a:solidFill>
+                <a:latin typeface="Calibri" pitchFamily="34" charset="0"/>
+                <a:ea typeface="Calibri" pitchFamily="34" charset="-122"/>
+                <a:cs typeface="Calibri" pitchFamily="34" charset="-120"/>
+              </a:rPr>
+              <a:t>Exit: 2 MFEs shipped through the full loop; integration ≤ 15% of feature effort</a:t>
+            </a:r>
+            <a:endParaRPr lang="en-US" sz="980" dirty="0"/>
+          </a:p>
+        </p:txBody>
+      </p:sp>
+      <p:sp>
+        <p:nvSpPr>
+          <p:cNvPr id="14" name="Shape 12"/>
+          <p:cNvSpPr/>
+          <p:nvPr/>
+        </p:nvSpPr>
+        <p:spPr>
+          <a:xfrm>
+            <a:off x="6210148" y="1691640"/>
+            <a:ext cx="2602154" cy="4206240"/>
           </a:xfrm>
           <a:prstGeom prst="roundRect">
             <a:avLst>
-              <a:gd name="adj" fmla="val 3636"/>
+              <a:gd name="adj" fmla="val 2811"/>
             </a:avLst>
           </a:prstGeom>
           <a:solidFill>
@@ -9986,58 +9903,14 @@
       </p:sp>
       <p:sp>
         <p:nvSpPr>
-          <p:cNvPr id="17" name="Shape 13"/>
-          <p:cNvSpPr/>
-          <p:nvPr/>
-        </p:nvSpPr>
-        <p:spPr>
-          <a:xfrm>
-            <a:off x="8328965" y="1892808"/>
-            <a:ext cx="502920" cy="502920"/>
-          </a:xfrm>
-          <a:prstGeom prst="ellipse">
-            <a:avLst/>
-          </a:prstGeom>
-          <a:solidFill>
-            <a:srgbClr val="1E2761"/>
-          </a:solidFill>
-          <a:ln/>
-        </p:spPr>
-      </p:sp>
-      <p:pic>
-        <p:nvPicPr>
-          <p:cNvPr id="18" name="Image 2" descr="preencoded.png">    </p:cNvPr>
-          <p:cNvPicPr>
-            <a:picLocks noChangeAspect="1"/>
-          </p:cNvPicPr>
-          <p:nvPr/>
-        </p:nvPicPr>
-        <p:blipFill>
-          <a:blip r:embed="rId3"/>
-          <a:stretch>
-            <a:fillRect/>
-          </a:stretch>
-        </p:blipFill>
-        <p:spPr>
-          <a:xfrm>
-            <a:off x="8459724" y="2023567"/>
-            <a:ext cx="241402" cy="241402"/>
-          </a:xfrm>
-          <a:prstGeom prst="rect">
-            <a:avLst/>
-          </a:prstGeom>
-        </p:spPr>
-      </p:pic>
-      <p:sp>
-        <p:nvSpPr>
-          <p:cNvPr id="19" name="Text 14"/>
-          <p:cNvSpPr/>
-          <p:nvPr/>
-        </p:nvSpPr>
-        <p:spPr>
-          <a:xfrm>
-            <a:off x="8969045" y="1947672"/>
-            <a:ext cx="2509418" cy="384048"/>
+          <p:cNvPr id="15" name="Text 13"/>
+          <p:cNvSpPr/>
+          <p:nvPr/>
+        </p:nvSpPr>
+        <p:spPr>
+          <a:xfrm>
+            <a:off x="6393028" y="1828800"/>
+            <a:ext cx="2236394" cy="274320"/>
           </a:xfrm>
           <a:prstGeom prst="rect">
             <a:avLst/>
@@ -10053,7 +9926,46 @@
               <a:buNone/>
             </a:pPr>
             <a:r>
-              <a:rPr lang="en-US" sz="1450" b="1" dirty="0">
+              <a:rPr lang="en-US" sz="1100" b="1" spc="200" kern="0" dirty="0">
+                <a:solidFill>
+                  <a:srgbClr val="5A6B8C"/>
+                </a:solidFill>
+                <a:latin typeface="Calibri" pitchFamily="34" charset="0"/>
+                <a:ea typeface="Calibri" pitchFamily="34" charset="-122"/>
+                <a:cs typeface="Calibri" pitchFamily="34" charset="-120"/>
+              </a:rPr>
+              <a:t>PHASE 2</a:t>
+            </a:r>
+            <a:endParaRPr lang="en-US" sz="1100" dirty="0"/>
+          </a:p>
+        </p:txBody>
+      </p:sp>
+      <p:sp>
+        <p:nvSpPr>
+          <p:cNvPr id="16" name="Text 14"/>
+          <p:cNvSpPr/>
+          <p:nvPr/>
+        </p:nvSpPr>
+        <p:spPr>
+          <a:xfrm>
+            <a:off x="6393028" y="2103120"/>
+            <a:ext cx="2236394" cy="685800"/>
+          </a:xfrm>
+          <a:prstGeom prst="rect">
+            <a:avLst/>
+          </a:prstGeom>
+          <a:noFill/>
+          <a:ln/>
+        </p:spPr>
+        <p:txBody>
+          <a:bodyPr wrap="square" lIns="0" tIns="0" rIns="0" bIns="0" rtlCol="0" anchor="ctr"/>
+          <a:lstStyle/>
+          <a:p>
+            <a:pPr indent="0" marL="0">
+              <a:buNone/>
+            </a:pPr>
+            <a:r>
+              <a:rPr lang="en-US" sz="1350" b="1" dirty="0">
                 <a:solidFill>
                   <a:srgbClr val="1E2761"/>
                 </a:solidFill>
@@ -10061,38 +9973,59 @@
                 <a:ea typeface="Calibri" pitchFamily="34" charset="-122"/>
                 <a:cs typeface="Calibri" pitchFamily="34" charset="-120"/>
               </a:rPr>
-              <a:t>Egress SLA &amp; yield</a:t>
-            </a:r>
-            <a:endParaRPr lang="en-US" sz="1450" dirty="0"/>
-          </a:p>
-        </p:txBody>
-      </p:sp>
-      <p:sp>
-        <p:nvSpPr>
-          <p:cNvPr id="20" name="Text 15"/>
-          <p:cNvSpPr/>
-          <p:nvPr/>
-        </p:nvSpPr>
-        <p:spPr>
-          <a:xfrm>
-            <a:off x="8356397" y="2468880"/>
-            <a:ext cx="3058058" cy="1051560"/>
-          </a:xfrm>
-          <a:prstGeom prst="rect">
-            <a:avLst/>
-          </a:prstGeom>
-          <a:noFill/>
-          <a:ln/>
-        </p:spPr>
-        <p:txBody>
-          <a:bodyPr wrap="square" lIns="0" tIns="0" rIns="0" bIns="0" rtlCol="0" anchor="ctr"/>
-          <a:lstStyle/>
+              <a:t>Outbound spec pipeline at scale</a:t>
+            </a:r>
+            <a:endParaRPr lang="en-US" sz="1350" dirty="0"/>
+          </a:p>
           <a:p>
             <a:pPr indent="0" marL="0">
               <a:buNone/>
             </a:pPr>
             <a:r>
-              <a:rPr lang="en-US" sz="1100" dirty="0">
+              <a:rPr lang="en-US" sz="1350" b="1" dirty="0">
+                <a:solidFill>
+                  <a:srgbClr val="1E2761"/>
+                </a:solidFill>
+                <a:latin typeface="Calibri" pitchFamily="34" charset="0"/>
+                <a:ea typeface="Calibri" pitchFamily="34" charset="-122"/>
+                <a:cs typeface="Calibri" pitchFamily="34" charset="-120"/>
+              </a:rPr>
+              <a:t>(mo 6–14, overlaps)</a:t>
+            </a:r>
+            <a:endParaRPr lang="en-US" sz="1350" dirty="0"/>
+          </a:p>
+        </p:txBody>
+      </p:sp>
+      <p:sp>
+        <p:nvSpPr>
+          <p:cNvPr id="17" name="Text 15"/>
+          <p:cNvSpPr/>
+          <p:nvPr/>
+        </p:nvSpPr>
+        <p:spPr>
+          <a:xfrm>
+            <a:off x="6393028" y="2880360"/>
+            <a:ext cx="2236394" cy="2834640"/>
+          </a:xfrm>
+          <a:prstGeom prst="rect">
+            <a:avLst/>
+          </a:prstGeom>
+          <a:noFill/>
+          <a:ln/>
+        </p:spPr>
+        <p:txBody>
+          <a:bodyPr wrap="square" lIns="0" tIns="0" rIns="0" bIns="0" rtlCol="0" anchor="ctr"/>
+          <a:lstStyle/>
+          <a:p>
+            <a:pPr marL="342900" indent="-342900">
+              <a:spcAft>
+                <a:spcPts val="600"/>
+              </a:spcAft>
+              <a:buSzPct val="100000"/>
+              <a:buChar char="•"/>
+            </a:pPr>
+            <a:r>
+              <a:rPr lang="en-US" sz="980" dirty="0">
                 <a:solidFill>
                   <a:srgbClr val="1B2440"/>
                 </a:solidFill>
@@ -10100,30 +10033,93 @@
                 <a:ea typeface="Calibri" pitchFamily="34" charset="-122"/>
                 <a:cs typeface="Calibri" pitchFamily="34" charset="-120"/>
               </a:rPr>
-              <a:t>Gate turnaround vs. matrix targets, and % of packages passing Gate 0 clean first try. Falling yield = checklist or tooling gap.</a:t>
-            </a:r>
-            <a:endParaRPr lang="en-US" sz="1100" dirty="0"/>
-          </a:p>
-        </p:txBody>
-      </p:sp>
-      <p:sp>
-        <p:nvSpPr>
-          <p:cNvPr id="21" name="Shape 16"/>
-          <p:cNvSpPr/>
-          <p:nvPr/>
-        </p:nvSpPr>
-        <p:spPr>
-          <a:xfrm>
-            <a:off x="548640" y="3886200"/>
-            <a:ext cx="3515258" cy="2011680"/>
+              <a:t>Spec-package tooling hardened; Tier-0 standing approvals in force</a:t>
+            </a:r>
+            <a:endParaRPr lang="en-US" sz="980" dirty="0"/>
+          </a:p>
+          <a:p>
+            <a:pPr marL="342900" indent="-342900">
+              <a:spcAft>
+                <a:spcPts val="600"/>
+              </a:spcAft>
+              <a:buSzPct val="100000"/>
+              <a:buChar char="•"/>
+            </a:pPr>
+            <a:r>
+              <a:rPr lang="en-US" sz="980" dirty="0">
+                <a:solidFill>
+                  <a:srgbClr val="1B2440"/>
+                </a:solidFill>
+                <a:latin typeface="Calibri" pitchFamily="34" charset="0"/>
+                <a:ea typeface="Calibri" pitchFamily="34" charset="-122"/>
+                <a:cs typeface="Calibri" pitchFamily="34" charset="-120"/>
+              </a:rPr>
+              <a:t>Angular inventory complete; migration factory running per-feature</a:t>
+            </a:r>
+            <a:endParaRPr lang="en-US" sz="980" dirty="0"/>
+          </a:p>
+          <a:p>
+            <a:pPr marL="342900" indent="-342900">
+              <a:spcAft>
+                <a:spcPts val="600"/>
+              </a:spcAft>
+              <a:buSzPct val="100000"/>
+              <a:buChar char="•"/>
+            </a:pPr>
+            <a:r>
+              <a:rPr lang="en-US" sz="980" dirty="0">
+                <a:solidFill>
+                  <a:srgbClr val="1B2440"/>
+                </a:solidFill>
+                <a:latin typeface="Calibri" pitchFamily="34" charset="0"/>
+                <a:ea typeface="Calibri" pitchFamily="34" charset="-122"/>
+                <a:cs typeface="Calibri" pitchFamily="34" charset="-120"/>
+              </a:rPr>
+              <a:t>Sensitizer = logic-pack compiler + validators, fully inside</a:t>
+            </a:r>
+            <a:endParaRPr lang="en-US" sz="980" dirty="0"/>
+          </a:p>
+          <a:p>
+            <a:pPr marL="342900" indent="-342900">
+              <a:spcAft>
+                <a:spcPts val="600"/>
+              </a:spcAft>
+              <a:buSzPct val="100000"/>
+              <a:buChar char="•"/>
+            </a:pPr>
+            <a:r>
+              <a:rPr lang="en-US" sz="980" dirty="0">
+                <a:solidFill>
+                  <a:srgbClr val="1B2440"/>
+                </a:solidFill>
+                <a:latin typeface="Calibri" pitchFamily="34" charset="0"/>
+                <a:ea typeface="Calibri" pitchFamily="34" charset="-122"/>
+                <a:cs typeface="Calibri" pitchFamily="34" charset="-120"/>
+              </a:rPr>
+              <a:t>Exit: egress SLA met 90%+; zero security incidents; parity scoreboard trending to done</a:t>
+            </a:r>
+            <a:endParaRPr lang="en-US" sz="980" dirty="0"/>
+          </a:p>
+        </p:txBody>
+      </p:sp>
+      <p:sp>
+        <p:nvSpPr>
+          <p:cNvPr id="18" name="Shape 16"/>
+          <p:cNvSpPr/>
+          <p:nvPr/>
+        </p:nvSpPr>
+        <p:spPr>
+          <a:xfrm>
+            <a:off x="9040901" y="1691640"/>
+            <a:ext cx="2602154" cy="4206240"/>
           </a:xfrm>
           <a:prstGeom prst="roundRect">
             <a:avLst>
-              <a:gd name="adj" fmla="val 3636"/>
+              <a:gd name="adj" fmla="val 2811"/>
             </a:avLst>
           </a:prstGeom>
           <a:solidFill>
-            <a:srgbClr val="EDF3FC"/>
+            <a:srgbClr val="EAF4EF"/>
           </a:solidFill>
           <a:ln/>
           <a:effectLst>
@@ -10137,58 +10133,14 @@
       </p:sp>
       <p:sp>
         <p:nvSpPr>
-          <p:cNvPr id="22" name="Shape 17"/>
-          <p:cNvSpPr/>
-          <p:nvPr/>
-        </p:nvSpPr>
-        <p:spPr>
-          <a:xfrm>
-            <a:off x="749808" y="4087368"/>
-            <a:ext cx="502920" cy="502920"/>
-          </a:xfrm>
-          <a:prstGeom prst="ellipse">
-            <a:avLst/>
-          </a:prstGeom>
-          <a:solidFill>
-            <a:srgbClr val="1E2761"/>
-          </a:solidFill>
-          <a:ln/>
-        </p:spPr>
-      </p:sp>
-      <p:pic>
-        <p:nvPicPr>
-          <p:cNvPr id="23" name="Image 3" descr="preencoded.png">    </p:cNvPr>
-          <p:cNvPicPr>
-            <a:picLocks noChangeAspect="1"/>
-          </p:cNvPicPr>
-          <p:nvPr/>
-        </p:nvPicPr>
-        <p:blipFill>
-          <a:blip r:embed="rId4"/>
-          <a:stretch>
-            <a:fillRect/>
-          </a:stretch>
-        </p:blipFill>
-        <p:spPr>
-          <a:xfrm>
-            <a:off x="880567" y="4218127"/>
-            <a:ext cx="241402" cy="241402"/>
-          </a:xfrm>
-          <a:prstGeom prst="rect">
-            <a:avLst/>
-          </a:prstGeom>
-        </p:spPr>
-      </p:pic>
-      <p:sp>
-        <p:nvSpPr>
-          <p:cNvPr id="24" name="Text 18"/>
-          <p:cNvSpPr/>
-          <p:nvPr/>
-        </p:nvSpPr>
-        <p:spPr>
-          <a:xfrm>
-            <a:off x="1389888" y="4142232"/>
-            <a:ext cx="2509418" cy="384048"/>
+          <p:cNvPr id="19" name="Text 17"/>
+          <p:cNvSpPr/>
+          <p:nvPr/>
+        </p:nvSpPr>
+        <p:spPr>
+          <a:xfrm>
+            <a:off x="9223781" y="1828800"/>
+            <a:ext cx="2236394" cy="274320"/>
           </a:xfrm>
           <a:prstGeom prst="rect">
             <a:avLst/>
@@ -10204,7 +10156,46 @@
               <a:buNone/>
             </a:pPr>
             <a:r>
-              <a:rPr lang="en-US" sz="1450" b="1" dirty="0">
+              <a:rPr lang="en-US" sz="1100" b="1" spc="200" kern="0" dirty="0">
+                <a:solidFill>
+                  <a:srgbClr val="2E7D5B"/>
+                </a:solidFill>
+                <a:latin typeface="Calibri" pitchFamily="34" charset="0"/>
+                <a:ea typeface="Calibri" pitchFamily="34" charset="-122"/>
+                <a:cs typeface="Calibri" pitchFamily="34" charset="-120"/>
+              </a:rPr>
+              <a:t>PHASE 3</a:t>
+            </a:r>
+            <a:endParaRPr lang="en-US" sz="1100" dirty="0"/>
+          </a:p>
+        </p:txBody>
+      </p:sp>
+      <p:sp>
+        <p:nvSpPr>
+          <p:cNvPr id="20" name="Text 18"/>
+          <p:cNvSpPr/>
+          <p:nvPr/>
+        </p:nvSpPr>
+        <p:spPr>
+          <a:xfrm>
+            <a:off x="9223781" y="2103120"/>
+            <a:ext cx="2236394" cy="685800"/>
+          </a:xfrm>
+          <a:prstGeom prst="rect">
+            <a:avLst/>
+          </a:prstGeom>
+          <a:noFill/>
+          <a:ln/>
+        </p:spPr>
+        <p:txBody>
+          <a:bodyPr wrap="square" lIns="0" tIns="0" rIns="0" bIns="0" rtlCol="0" anchor="ctr"/>
+          <a:lstStyle/>
+          <a:p>
+            <a:pPr indent="0" marL="0">
+              <a:buNone/>
+            </a:pPr>
+            <a:r>
+              <a:rPr lang="en-US" sz="1350" b="1" dirty="0">
                 <a:solidFill>
                   <a:srgbClr val="1E2761"/>
                 </a:solidFill>
@@ -10212,38 +10203,59 @@
                 <a:ea typeface="Calibri" pitchFamily="34" charset="-122"/>
                 <a:cs typeface="Calibri" pitchFamily="34" charset="-120"/>
               </a:rPr>
-              <a:t>Pack coverage</a:t>
-            </a:r>
-            <a:endParaRPr lang="en-US" sz="1450" dirty="0"/>
-          </a:p>
-        </p:txBody>
-      </p:sp>
-      <p:sp>
-        <p:nvSpPr>
-          <p:cNvPr id="25" name="Text 19"/>
-          <p:cNvSpPr/>
-          <p:nvPr/>
-        </p:nvSpPr>
-        <p:spPr>
-          <a:xfrm>
-            <a:off x="777240" y="4663440"/>
-            <a:ext cx="3058058" cy="1051560"/>
-          </a:xfrm>
-          <a:prstGeom prst="rect">
-            <a:avLst/>
-          </a:prstGeom>
-          <a:noFill/>
-          <a:ln/>
-        </p:spPr>
-        <p:txBody>
-          <a:bodyPr wrap="square" lIns="0" tIns="0" rIns="0" bIns="0" rtlCol="0" anchor="ctr"/>
-          <a:lstStyle/>
+              <a:t>Core-team absorption</a:t>
+            </a:r>
+            <a:endParaRPr lang="en-US" sz="1350" dirty="0"/>
+          </a:p>
           <a:p>
             <a:pPr indent="0" marL="0">
               <a:buNone/>
             </a:pPr>
             <a:r>
-              <a:rPr lang="en-US" sz="1100" dirty="0">
+              <a:rPr lang="en-US" sz="1350" b="1" dirty="0">
+                <a:solidFill>
+                  <a:srgbClr val="1E2761"/>
+                </a:solidFill>
+                <a:latin typeface="Calibri" pitchFamily="34" charset="0"/>
+                <a:ea typeface="Calibri" pitchFamily="34" charset="-122"/>
+                <a:cs typeface="Calibri" pitchFamily="34" charset="-120"/>
+              </a:rPr>
+              <a:t>(trigger-based)</a:t>
+            </a:r>
+            <a:endParaRPr lang="en-US" sz="1350" dirty="0"/>
+          </a:p>
+        </p:txBody>
+      </p:sp>
+      <p:sp>
+        <p:nvSpPr>
+          <p:cNvPr id="21" name="Text 19"/>
+          <p:cNvSpPr/>
+          <p:nvPr/>
+        </p:nvSpPr>
+        <p:spPr>
+          <a:xfrm>
+            <a:off x="9223781" y="2880360"/>
+            <a:ext cx="2236394" cy="2834640"/>
+          </a:xfrm>
+          <a:prstGeom prst="rect">
+            <a:avLst/>
+          </a:prstGeom>
+          <a:noFill/>
+          <a:ln/>
+        </p:spPr>
+        <p:txBody>
+          <a:bodyPr wrap="square" lIns="0" tIns="0" rIns="0" bIns="0" rtlCol="0" anchor="ctr"/>
+          <a:lstStyle/>
+          <a:p>
+            <a:pPr marL="342900" indent="-342900">
+              <a:spcAft>
+                <a:spcPts val="600"/>
+              </a:spcAft>
+              <a:buSzPct val="100000"/>
+              <a:buChar char="•"/>
+            </a:pPr>
+            <a:r>
+              <a:rPr lang="en-US" sz="980" dirty="0">
                 <a:solidFill>
                   <a:srgbClr val="1B2440"/>
                 </a:solidFill>
@@ -10251,111 +10263,101 @@
                 <a:ea typeface="Calibri" pitchFamily="34" charset="-122"/>
                 <a:cs typeface="Calibri" pitchFamily="34" charset="-120"/>
               </a:rPr>
-              <a:t>% of business rules expressed as logic-pack data vs. escape-hatch code. Higher = less inside-only work = Phase 3 readiness.</a:t>
-            </a:r>
-            <a:endParaRPr lang="en-US" sz="1100" dirty="0"/>
-          </a:p>
-        </p:txBody>
-      </p:sp>
-      <p:sp>
-        <p:nvSpPr>
-          <p:cNvPr id="26" name="Shape 20"/>
-          <p:cNvSpPr/>
-          <p:nvPr/>
-        </p:nvSpPr>
-        <p:spPr>
-          <a:xfrm>
-            <a:off x="4338218" y="3886200"/>
-            <a:ext cx="3515258" cy="2011680"/>
-          </a:xfrm>
-          <a:prstGeom prst="roundRect">
-            <a:avLst>
-              <a:gd name="adj" fmla="val 3636"/>
-            </a:avLst>
-          </a:prstGeom>
-          <a:solidFill>
-            <a:srgbClr val="EDF3FC"/>
-          </a:solidFill>
-          <a:ln/>
-          <a:effectLst>
-            <a:outerShdw sx="100000" sy="100000" kx="0" ky="0" algn="bl" rotWithShape="0" blurRad="76200" dist="12700" dir="5400000">
-              <a:srgbClr val="9AA7C4">
-                <a:alpha val="25000"/>
-              </a:srgbClr>
-            </a:outerShdw>
-          </a:effectLst>
-        </p:spPr>
-      </p:sp>
-      <p:sp>
-        <p:nvSpPr>
-          <p:cNvPr id="27" name="Shape 21"/>
-          <p:cNvSpPr/>
-          <p:nvPr/>
-        </p:nvSpPr>
-        <p:spPr>
-          <a:xfrm>
-            <a:off x="4539386" y="4087368"/>
-            <a:ext cx="502920" cy="502920"/>
-          </a:xfrm>
-          <a:prstGeom prst="ellipse">
-            <a:avLst/>
-          </a:prstGeom>
-          <a:solidFill>
-            <a:srgbClr val="1E2761"/>
-          </a:solidFill>
-          <a:ln/>
-        </p:spPr>
-      </p:sp>
-      <p:pic>
-        <p:nvPicPr>
-          <p:cNvPr id="28" name="Image 4" descr="preencoded.png">    </p:cNvPr>
-          <p:cNvPicPr>
-            <a:picLocks noChangeAspect="1"/>
-          </p:cNvPicPr>
-          <p:nvPr/>
-        </p:nvPicPr>
-        <p:blipFill>
-          <a:blip r:embed="rId5"/>
-          <a:stretch>
-            <a:fillRect/>
-          </a:stretch>
-        </p:blipFill>
-        <p:spPr>
-          <a:xfrm>
-            <a:off x="4670146" y="4218127"/>
-            <a:ext cx="241402" cy="241402"/>
-          </a:xfrm>
-          <a:prstGeom prst="rect">
-            <a:avLst/>
-          </a:prstGeom>
-        </p:spPr>
-      </p:pic>
-      <p:sp>
-        <p:nvSpPr>
-          <p:cNvPr id="29" name="Text 22"/>
-          <p:cNvSpPr/>
-          <p:nvPr/>
-        </p:nvSpPr>
-        <p:spPr>
-          <a:xfrm>
-            <a:off x="5179466" y="4142232"/>
-            <a:ext cx="2509418" cy="384048"/>
-          </a:xfrm>
-          <a:prstGeom prst="rect">
-            <a:avLst/>
-          </a:prstGeom>
-          <a:noFill/>
-          <a:ln/>
-        </p:spPr>
-        <p:txBody>
-          <a:bodyPr wrap="square" lIns="0" tIns="0" rIns="0" bIns="0" rtlCol="0" anchor="ctr"/>
-          <a:lstStyle/>
-          <a:p>
-            <a:pPr indent="0" marL="0">
-              <a:buNone/>
-            </a:pPr>
-            <a:r>
-              <a:rPr lang="en-US" sz="1450" b="1" dirty="0">
+              <a:t>Trigger: contractor reduction mandate — readiness is built in Phases 1–2, not when the memo lands</a:t>
+            </a:r>
+            <a:endParaRPr lang="en-US" sz="980" dirty="0"/>
+          </a:p>
+          <a:p>
+            <a:pPr marL="342900" indent="-342900">
+              <a:spcAft>
+                <a:spcPts val="600"/>
+              </a:spcAft>
+              <a:buSzPct val="100000"/>
+              <a:buChar char="•"/>
+            </a:pPr>
+            <a:r>
+              <a:rPr lang="en-US" sz="980" dirty="0">
+                <a:solidFill>
+                  <a:srgbClr val="1B2440"/>
+                </a:solidFill>
+                <a:latin typeface="Calibri" pitchFamily="34" charset="0"/>
+                <a:ea typeface="Calibri" pitchFamily="34" charset="-122"/>
+                <a:cs typeface="Calibri" pitchFamily="34" charset="-120"/>
+              </a:rPr>
+              <a:t>Every contractor duty has a documented runbook + a core-team owner who has already done it (rotation in Phase 2)</a:t>
+            </a:r>
+            <a:endParaRPr lang="en-US" sz="980" dirty="0"/>
+          </a:p>
+          <a:p>
+            <a:pPr marL="342900" indent="-342900">
+              <a:spcAft>
+                <a:spcPts val="600"/>
+              </a:spcAft>
+              <a:buSzPct val="100000"/>
+              <a:buChar char="•"/>
+            </a:pPr>
+            <a:r>
+              <a:rPr lang="en-US" sz="980" dirty="0">
+                <a:solidFill>
+                  <a:srgbClr val="1B2440"/>
+                </a:solidFill>
+                <a:latin typeface="Calibri" pitchFamily="34" charset="0"/>
+                <a:ea typeface="Calibri" pitchFamily="34" charset="-122"/>
+                <a:cs typeface="Calibri" pitchFamily="34" charset="-120"/>
+              </a:rPr>
+              <a:t>Automate the residue: integration scripts, mapping validators, config lint</a:t>
+            </a:r>
+            <a:endParaRPr lang="en-US" sz="980" dirty="0"/>
+          </a:p>
+          <a:p>
+            <a:pPr marL="342900" indent="-342900">
+              <a:spcAft>
+                <a:spcPts val="600"/>
+              </a:spcAft>
+              <a:buSzPct val="100000"/>
+              <a:buChar char="•"/>
+            </a:pPr>
+            <a:r>
+              <a:rPr lang="en-US" sz="980" dirty="0">
+                <a:solidFill>
+                  <a:srgbClr val="1B2440"/>
+                </a:solidFill>
+                <a:latin typeface="Calibri" pitchFamily="34" charset="0"/>
+                <a:ea typeface="Calibri" pitchFamily="34" charset="-122"/>
+                <a:cs typeface="Calibri" pitchFamily="34" charset="-120"/>
+              </a:rPr>
+              <a:t>Exit: full loop runs with core team only, one release proven</a:t>
+            </a:r>
+            <a:endParaRPr lang="en-US" sz="980" dirty="0"/>
+          </a:p>
+        </p:txBody>
+      </p:sp>
+      <p:sp>
+        <p:nvSpPr>
+          <p:cNvPr id="22" name="Text 20"/>
+          <p:cNvSpPr/>
+          <p:nvPr/>
+        </p:nvSpPr>
+        <p:spPr>
+          <a:xfrm>
+            <a:off x="548640" y="6035040"/>
+            <a:ext cx="11094415" cy="411480"/>
+          </a:xfrm>
+          <a:prstGeom prst="rect">
+            <a:avLst/>
+          </a:prstGeom>
+          <a:noFill/>
+          <a:ln/>
+        </p:spPr>
+        <p:txBody>
+          <a:bodyPr wrap="square" lIns="0" tIns="0" rIns="0" bIns="0" rtlCol="0" anchor="ctr"/>
+          <a:lstStyle/>
+          <a:p>
+            <a:pPr algn="ctr" indent="0" marL="0">
+              <a:buNone/>
+            </a:pPr>
+            <a:r>
+              <a:rPr lang="en-US" sz="1250" b="1" dirty="0">
                 <a:solidFill>
                   <a:srgbClr val="1E2761"/>
                 </a:solidFill>
@@ -10363,38 +10365,13 @@
                 <a:ea typeface="Calibri" pitchFamily="34" charset="-122"/>
                 <a:cs typeface="Calibri" pitchFamily="34" charset="-120"/>
               </a:rPr>
-              <a:t>Security incidents</a:t>
-            </a:r>
-            <a:endParaRPr lang="en-US" sz="1450" dirty="0"/>
-          </a:p>
-        </p:txBody>
-      </p:sp>
-      <p:sp>
-        <p:nvSpPr>
-          <p:cNvPr id="30" name="Text 23"/>
-          <p:cNvSpPr/>
-          <p:nvPr/>
-        </p:nvSpPr>
-        <p:spPr>
-          <a:xfrm>
-            <a:off x="4566818" y="4663440"/>
-            <a:ext cx="3058058" cy="1051560"/>
-          </a:xfrm>
-          <a:prstGeom prst="rect">
-            <a:avLst/>
-          </a:prstGeom>
-          <a:noFill/>
-          <a:ln/>
-        </p:spPr>
-        <p:txBody>
-          <a:bodyPr wrap="square" lIns="0" tIns="0" rIns="0" bIns="0" rtlCol="0" anchor="ctr"/>
-          <a:lstStyle/>
-          <a:p>
-            <a:pPr indent="0" marL="0">
-              <a:buNone/>
-            </a:pPr>
-            <a:r>
-              <a:rPr lang="en-US" sz="1100" dirty="0">
+              <a:t>Honest expectation: </a:t>
+            </a:r>
+            <a:pPr algn="ctr" indent="0" marL="0">
+              <a:buNone/>
+            </a:pPr>
+            <a:r>
+              <a:rPr lang="en-US" sz="1250" dirty="0">
                 <a:solidFill>
                   <a:srgbClr val="1B2440"/>
                 </a:solidFill>
@@ -10402,197 +10379,7 @@
                 <a:ea typeface="Calibri" pitchFamily="34" charset="-122"/>
                 <a:cs typeface="Calibri" pitchFamily="34" charset="-120"/>
               </a:rPr>
-              <a:t>Confirmed leakage events past Gate 3. The only acceptable number is zero; one incident likely ends the program.</a:t>
-            </a:r>
-            <a:endParaRPr lang="en-US" sz="1100" dirty="0"/>
-          </a:p>
-        </p:txBody>
-      </p:sp>
-      <p:sp>
-        <p:nvSpPr>
-          <p:cNvPr id="31" name="Shape 24"/>
-          <p:cNvSpPr/>
-          <p:nvPr/>
-        </p:nvSpPr>
-        <p:spPr>
-          <a:xfrm>
-            <a:off x="8127797" y="3886200"/>
-            <a:ext cx="3515258" cy="2011680"/>
-          </a:xfrm>
-          <a:prstGeom prst="roundRect">
-            <a:avLst>
-              <a:gd name="adj" fmla="val 3636"/>
-            </a:avLst>
-          </a:prstGeom>
-          <a:solidFill>
-            <a:srgbClr val="EDF3FC"/>
-          </a:solidFill>
-          <a:ln/>
-          <a:effectLst>
-            <a:outerShdw sx="100000" sy="100000" kx="0" ky="0" algn="bl" rotWithShape="0" blurRad="76200" dist="12700" dir="5400000">
-              <a:srgbClr val="9AA7C4">
-                <a:alpha val="25000"/>
-              </a:srgbClr>
-            </a:outerShdw>
-          </a:effectLst>
-        </p:spPr>
-      </p:sp>
-      <p:sp>
-        <p:nvSpPr>
-          <p:cNvPr id="32" name="Shape 25"/>
-          <p:cNvSpPr/>
-          <p:nvPr/>
-        </p:nvSpPr>
-        <p:spPr>
-          <a:xfrm>
-            <a:off x="8328965" y="4087368"/>
-            <a:ext cx="502920" cy="502920"/>
-          </a:xfrm>
-          <a:prstGeom prst="ellipse">
-            <a:avLst/>
-          </a:prstGeom>
-          <a:solidFill>
-            <a:srgbClr val="1E2761"/>
-          </a:solidFill>
-          <a:ln/>
-        </p:spPr>
-      </p:sp>
-      <p:pic>
-        <p:nvPicPr>
-          <p:cNvPr id="33" name="Image 5" descr="preencoded.png">    </p:cNvPr>
-          <p:cNvPicPr>
-            <a:picLocks noChangeAspect="1"/>
-          </p:cNvPicPr>
-          <p:nvPr/>
-        </p:nvPicPr>
-        <p:blipFill>
-          <a:blip r:embed="rId6"/>
-          <a:stretch>
-            <a:fillRect/>
-          </a:stretch>
-        </p:blipFill>
-        <p:spPr>
-          <a:xfrm>
-            <a:off x="8459724" y="4218127"/>
-            <a:ext cx="241402" cy="241402"/>
-          </a:xfrm>
-          <a:prstGeom prst="rect">
-            <a:avLst/>
-          </a:prstGeom>
-        </p:spPr>
-      </p:pic>
-      <p:sp>
-        <p:nvSpPr>
-          <p:cNvPr id="34" name="Text 26"/>
-          <p:cNvSpPr/>
-          <p:nvPr/>
-        </p:nvSpPr>
-        <p:spPr>
-          <a:xfrm>
-            <a:off x="8969045" y="4142232"/>
-            <a:ext cx="2509418" cy="384048"/>
-          </a:xfrm>
-          <a:prstGeom prst="rect">
-            <a:avLst/>
-          </a:prstGeom>
-          <a:noFill/>
-          <a:ln/>
-        </p:spPr>
-        <p:txBody>
-          <a:bodyPr wrap="square" lIns="0" tIns="0" rIns="0" bIns="0" rtlCol="0" anchor="ctr"/>
-          <a:lstStyle/>
-          <a:p>
-            <a:pPr indent="0" marL="0">
-              <a:buNone/>
-            </a:pPr>
-            <a:r>
-              <a:rPr lang="en-US" sz="1450" b="1" dirty="0">
-                <a:solidFill>
-                  <a:srgbClr val="1E2761"/>
-                </a:solidFill>
-                <a:latin typeface="Calibri" pitchFamily="34" charset="0"/>
-                <a:ea typeface="Calibri" pitchFamily="34" charset="-122"/>
-                <a:cs typeface="Calibri" pitchFamily="34" charset="-120"/>
-              </a:rPr>
-              <a:t>Bus-factor spread</a:t>
-            </a:r>
-            <a:endParaRPr lang="en-US" sz="1450" dirty="0"/>
-          </a:p>
-        </p:txBody>
-      </p:sp>
-      <p:sp>
-        <p:nvSpPr>
-          <p:cNvPr id="35" name="Text 27"/>
-          <p:cNvSpPr/>
-          <p:nvPr/>
-        </p:nvSpPr>
-        <p:spPr>
-          <a:xfrm>
-            <a:off x="8356397" y="4663440"/>
-            <a:ext cx="3058058" cy="1051560"/>
-          </a:xfrm>
-          <a:prstGeom prst="rect">
-            <a:avLst/>
-          </a:prstGeom>
-          <a:noFill/>
-          <a:ln/>
-        </p:spPr>
-        <p:txBody>
-          <a:bodyPr wrap="square" lIns="0" tIns="0" rIns="0" bIns="0" rtlCol="0" anchor="ctr"/>
-          <a:lstStyle/>
-          <a:p>
-            <a:pPr indent="0" marL="0">
-              <a:buNone/>
-            </a:pPr>
-            <a:r>
-              <a:rPr lang="en-US" sz="1100" dirty="0">
-                <a:solidFill>
-                  <a:srgbClr val="1B2440"/>
-                </a:solidFill>
-                <a:latin typeface="Calibri" pitchFamily="34" charset="0"/>
-                <a:ea typeface="Calibri" pitchFamily="34" charset="-122"/>
-                <a:cs typeface="Calibri" pitchFamily="34" charset="-120"/>
-              </a:rPr>
-              <a:t>Per contractor duty: runbook exists + a core-team member has executed it this quarter. 100% = Phase 3 can trigger any day.</a:t>
-            </a:r>
-            <a:endParaRPr lang="en-US" sz="1100" dirty="0"/>
-          </a:p>
-        </p:txBody>
-      </p:sp>
-      <p:sp>
-        <p:nvSpPr>
-          <p:cNvPr id="36" name="Text 28"/>
-          <p:cNvSpPr/>
-          <p:nvPr/>
-        </p:nvSpPr>
-        <p:spPr>
-          <a:xfrm>
-            <a:off x="548640" y="5989320"/>
-            <a:ext cx="11094415" cy="365760"/>
-          </a:xfrm>
-          <a:prstGeom prst="rect">
-            <a:avLst/>
-          </a:prstGeom>
-          <a:noFill/>
-          <a:ln/>
-        </p:spPr>
-        <p:txBody>
-          <a:bodyPr wrap="square" lIns="0" tIns="0" rIns="0" bIns="0" rtlCol="0" anchor="ctr"/>
-          <a:lstStyle/>
-          <a:p>
-            <a:pPr algn="ctr" indent="0" marL="0">
-              <a:buNone/>
-            </a:pPr>
-            <a:r>
-              <a:rPr lang="en-US" sz="1250" i="1" dirty="0">
-                <a:solidFill>
-                  <a:srgbClr val="5A6B8C"/>
-                </a:solidFill>
-                <a:latin typeface="Calibri" pitchFamily="34" charset="0"/>
-                <a:ea typeface="Calibri" pitchFamily="34" charset="-122"/>
-                <a:cs typeface="Calibri" pitchFamily="34" charset="-120"/>
-              </a:rPr>
-              <a:t>Publish the scoreboard monthly — to stakeholders, not just the team. Transparency is the counter-narrative.</a:t>
+              <a:t>the first loop will be slower than today — you are building the factory while running it. Speed compounds from MFE #3 onward. Say this out loud on day one, or month 3 will be read as failure.</a:t>
             </a:r>
             <a:endParaRPr lang="en-US" sz="1250" dirty="0"/>
           </a:p>
@@ -10609,6 +10396,1139 @@
 <file path=ppt/slides/slide18.xml><?xml version="1.0" encoding="utf-8"?>
 <p:sld xmlns:a="http://schemas.openxmlformats.org/drawingml/2006/main" xmlns:r="http://schemas.openxmlformats.org/officeDocument/2006/relationships" xmlns:p="http://schemas.openxmlformats.org/presentationml/2006/main">
   <p:cSld name="Slide 18">
+    <p:bg>
+      <p:bgPr>
+        <a:solidFill>
+          <a:srgbClr val="FFFFFF"/>
+        </a:solidFill>
+      </p:bgPr>
+    </p:bg>
+    <p:spTree>
+      <p:nvGrpSpPr>
+        <p:cNvPr id="1" name=""/>
+        <p:cNvGrpSpPr/>
+        <p:nvPr/>
+      </p:nvGrpSpPr>
+      <p:grpSpPr>
+        <a:xfrm>
+          <a:off x="0" y="0"/>
+          <a:ext cx="0" cy="0"/>
+          <a:chOff x="0" y="0"/>
+          <a:chExt cx="0" cy="0"/>
+        </a:xfrm>
+      </p:grpSpPr>
+      <p:sp>
+        <p:nvSpPr>
+          <p:cNvPr id="2" name="Text 0"/>
+          <p:cNvSpPr/>
+          <p:nvPr/>
+        </p:nvSpPr>
+        <p:spPr>
+          <a:xfrm>
+            <a:off x="548640" y="6473952"/>
+            <a:ext cx="3657600" cy="274320"/>
+          </a:xfrm>
+          <a:prstGeom prst="rect">
+            <a:avLst/>
+          </a:prstGeom>
+          <a:noFill/>
+          <a:ln/>
+        </p:spPr>
+        <p:txBody>
+          <a:bodyPr wrap="square" lIns="0" tIns="0" rIns="0" bIns="0" rtlCol="0" anchor="ctr"/>
+          <a:lstStyle/>
+          <a:p>
+            <a:pPr algn="l" indent="0" marL="0">
+              <a:buNone/>
+            </a:pPr>
+            <a:r>
+              <a:rPr lang="en-US" sz="900" dirty="0">
+                <a:solidFill>
+                  <a:srgbClr val="5A6B8C"/>
+                </a:solidFill>
+                <a:latin typeface="Calibri" pitchFamily="34" charset="0"/>
+                <a:ea typeface="Calibri" pitchFamily="34" charset="-122"/>
+                <a:cs typeface="Calibri" pitchFamily="34" charset="-120"/>
+              </a:rPr>
+              <a:t>Internet-First, Airgap-Final</a:t>
+            </a:r>
+            <a:endParaRPr lang="en-US" sz="900" dirty="0"/>
+          </a:p>
+        </p:txBody>
+      </p:sp>
+      <p:sp>
+        <p:nvSpPr>
+          <p:cNvPr id="3" name="Text 1"/>
+          <p:cNvSpPr/>
+          <p:nvPr/>
+        </p:nvSpPr>
+        <p:spPr>
+          <a:xfrm>
+            <a:off x="11094415" y="6473952"/>
+            <a:ext cx="548640" cy="274320"/>
+          </a:xfrm>
+          <a:prstGeom prst="rect">
+            <a:avLst/>
+          </a:prstGeom>
+          <a:noFill/>
+          <a:ln/>
+        </p:spPr>
+        <p:txBody>
+          <a:bodyPr wrap="square" lIns="0" tIns="0" rIns="0" bIns="0" rtlCol="0" anchor="ctr"/>
+          <a:lstStyle/>
+          <a:p>
+            <a:pPr algn="r" indent="0" marL="0">
+              <a:buNone/>
+            </a:pPr>
+            <a:r>
+              <a:rPr lang="en-US" sz="900" dirty="0">
+                <a:solidFill>
+                  <a:srgbClr val="5A6B8C"/>
+                </a:solidFill>
+                <a:latin typeface="Calibri" pitchFamily="34" charset="0"/>
+                <a:ea typeface="Calibri" pitchFamily="34" charset="-122"/>
+                <a:cs typeface="Calibri" pitchFamily="34" charset="-120"/>
+              </a:rPr>
+              <a:t>18</a:t>
+            </a:r>
+            <a:endParaRPr lang="en-US" sz="900" dirty="0"/>
+          </a:p>
+        </p:txBody>
+      </p:sp>
+      <p:sp>
+        <p:nvSpPr>
+          <p:cNvPr id="4" name="Text 2"/>
+          <p:cNvSpPr/>
+          <p:nvPr/>
+        </p:nvSpPr>
+        <p:spPr>
+          <a:xfrm>
+            <a:off x="548640" y="384048"/>
+            <a:ext cx="11094415" cy="274320"/>
+          </a:xfrm>
+          <a:prstGeom prst="rect">
+            <a:avLst/>
+          </a:prstGeom>
+          <a:noFill/>
+          <a:ln/>
+        </p:spPr>
+        <p:txBody>
+          <a:bodyPr wrap="square" lIns="0" tIns="0" rIns="0" bIns="0" rtlCol="0" anchor="ctr"/>
+          <a:lstStyle/>
+          <a:p>
+            <a:pPr indent="0" marL="0">
+              <a:buNone/>
+            </a:pPr>
+            <a:r>
+              <a:rPr lang="en-US" sz="1200" b="1" spc="300" kern="0" dirty="0">
+                <a:solidFill>
+                  <a:srgbClr val="5A6B8C"/>
+                </a:solidFill>
+                <a:latin typeface="Calibri" pitchFamily="34" charset="0"/>
+                <a:ea typeface="Calibri" pitchFamily="34" charset="-122"/>
+                <a:cs typeface="Calibri" pitchFamily="34" charset="-120"/>
+              </a:rPr>
+              <a:t>MEASURING IT · THE COUNTER-NARRATIVE</a:t>
+            </a:r>
+            <a:endParaRPr lang="en-US" sz="1200" dirty="0"/>
+          </a:p>
+        </p:txBody>
+      </p:sp>
+      <p:sp>
+        <p:nvSpPr>
+          <p:cNvPr id="5" name="Text 3"/>
+          <p:cNvSpPr/>
+          <p:nvPr/>
+        </p:nvSpPr>
+        <p:spPr>
+          <a:xfrm>
+            <a:off x="548640" y="658368"/>
+            <a:ext cx="11094415" cy="621792"/>
+          </a:xfrm>
+          <a:prstGeom prst="rect">
+            <a:avLst/>
+          </a:prstGeom>
+          <a:noFill/>
+          <a:ln/>
+        </p:spPr>
+        <p:txBody>
+          <a:bodyPr wrap="square" lIns="0" tIns="0" rIns="0" bIns="0" rtlCol="0" anchor="t"/>
+          <a:lstStyle/>
+          <a:p>
+            <a:pPr indent="0" marL="0">
+              <a:buNone/>
+            </a:pPr>
+            <a:r>
+              <a:rPr lang="en-US" sz="3000" b="1" dirty="0">
+                <a:solidFill>
+                  <a:srgbClr val="1E2761"/>
+                </a:solidFill>
+                <a:latin typeface="Cambria" pitchFamily="34" charset="0"/>
+                <a:ea typeface="Cambria" pitchFamily="34" charset="-122"/>
+                <a:cs typeface="Cambria" pitchFamily="34" charset="-120"/>
+              </a:rPr>
+              <a:t>The scoreboard that wins the argument</a:t>
+            </a:r>
+            <a:endParaRPr lang="en-US" sz="3000" dirty="0"/>
+          </a:p>
+        </p:txBody>
+      </p:sp>
+      <p:sp>
+        <p:nvSpPr>
+          <p:cNvPr id="6" name="Shape 4"/>
+          <p:cNvSpPr/>
+          <p:nvPr/>
+        </p:nvSpPr>
+        <p:spPr>
+          <a:xfrm>
+            <a:off x="548640" y="1691640"/>
+            <a:ext cx="3515258" cy="2011680"/>
+          </a:xfrm>
+          <a:prstGeom prst="roundRect">
+            <a:avLst>
+              <a:gd name="adj" fmla="val 3636"/>
+            </a:avLst>
+          </a:prstGeom>
+          <a:solidFill>
+            <a:srgbClr val="EDF3FC"/>
+          </a:solidFill>
+          <a:ln/>
+          <a:effectLst>
+            <a:outerShdw sx="100000" sy="100000" kx="0" ky="0" algn="bl" rotWithShape="0" blurRad="76200" dist="12700" dir="5400000">
+              <a:srgbClr val="9AA7C4">
+                <a:alpha val="25000"/>
+              </a:srgbClr>
+            </a:outerShdw>
+          </a:effectLst>
+        </p:spPr>
+      </p:sp>
+      <p:sp>
+        <p:nvSpPr>
+          <p:cNvPr id="7" name="Shape 5"/>
+          <p:cNvSpPr/>
+          <p:nvPr/>
+        </p:nvSpPr>
+        <p:spPr>
+          <a:xfrm>
+            <a:off x="749808" y="1892808"/>
+            <a:ext cx="502920" cy="502920"/>
+          </a:xfrm>
+          <a:prstGeom prst="ellipse">
+            <a:avLst/>
+          </a:prstGeom>
+          <a:solidFill>
+            <a:srgbClr val="1E2761"/>
+          </a:solidFill>
+          <a:ln/>
+        </p:spPr>
+      </p:sp>
+      <p:pic>
+        <p:nvPicPr>
+          <p:cNvPr id="8" name="Image 0" descr="preencoded.png">    </p:cNvPr>
+          <p:cNvPicPr>
+            <a:picLocks noChangeAspect="1"/>
+          </p:cNvPicPr>
+          <p:nvPr/>
+        </p:nvPicPr>
+        <p:blipFill>
+          <a:blip r:embed="rId1"/>
+          <a:stretch>
+            <a:fillRect/>
+          </a:stretch>
+        </p:blipFill>
+        <p:spPr>
+          <a:xfrm>
+            <a:off x="880567" y="2023567"/>
+            <a:ext cx="241402" cy="241402"/>
+          </a:xfrm>
+          <a:prstGeom prst="rect">
+            <a:avLst/>
+          </a:prstGeom>
+        </p:spPr>
+      </p:pic>
+      <p:sp>
+        <p:nvSpPr>
+          <p:cNvPr id="9" name="Text 6"/>
+          <p:cNvSpPr/>
+          <p:nvPr/>
+        </p:nvSpPr>
+        <p:spPr>
+          <a:xfrm>
+            <a:off x="1389888" y="1947672"/>
+            <a:ext cx="2509418" cy="384048"/>
+          </a:xfrm>
+          <a:prstGeom prst="rect">
+            <a:avLst/>
+          </a:prstGeom>
+          <a:noFill/>
+          <a:ln/>
+        </p:spPr>
+        <p:txBody>
+          <a:bodyPr wrap="square" lIns="0" tIns="0" rIns="0" bIns="0" rtlCol="0" anchor="ctr"/>
+          <a:lstStyle/>
+          <a:p>
+            <a:pPr indent="0" marL="0">
+              <a:buNone/>
+            </a:pPr>
+            <a:r>
+              <a:rPr lang="en-US" sz="1450" b="1" dirty="0">
+                <a:solidFill>
+                  <a:srgbClr val="1E2761"/>
+                </a:solidFill>
+                <a:latin typeface="Calibri" pitchFamily="34" charset="0"/>
+                <a:ea typeface="Calibri" pitchFamily="34" charset="-122"/>
+                <a:cs typeface="Calibri" pitchFamily="34" charset="-120"/>
+              </a:rPr>
+              <a:t>Two clocks</a:t>
+            </a:r>
+            <a:endParaRPr lang="en-US" sz="1450" dirty="0"/>
+          </a:p>
+        </p:txBody>
+      </p:sp>
+      <p:sp>
+        <p:nvSpPr>
+          <p:cNvPr id="10" name="Text 7"/>
+          <p:cNvSpPr/>
+          <p:nvPr/>
+        </p:nvSpPr>
+        <p:spPr>
+          <a:xfrm>
+            <a:off x="777240" y="2468880"/>
+            <a:ext cx="3058058" cy="1051560"/>
+          </a:xfrm>
+          <a:prstGeom prst="rect">
+            <a:avLst/>
+          </a:prstGeom>
+          <a:noFill/>
+          <a:ln/>
+        </p:spPr>
+        <p:txBody>
+          <a:bodyPr wrap="square" lIns="0" tIns="0" rIns="0" bIns="0" rtlCol="0" anchor="ctr"/>
+          <a:lstStyle/>
+          <a:p>
+            <a:pPr indent="0" marL="0">
+              <a:buNone/>
+            </a:pPr>
+            <a:r>
+              <a:rPr lang="en-US" sz="1100" dirty="0">
+                <a:solidFill>
+                  <a:srgbClr val="1B2440"/>
+                </a:solidFill>
+                <a:latin typeface="Calibri" pitchFamily="34" charset="0"/>
+                <a:ea typeface="Calibri" pitchFamily="34" charset="-122"/>
+                <a:cs typeface="Calibri" pitchFamily="34" charset="-120"/>
+              </a:rPr>
+              <a:t>Time-to-DEMO (spec → clickable mock) and time-to-PRODUCTION (spec → running in Confi), published side-by-side. The demo clock matches the vibe-coders; the production clock is the finish line only we reach.</a:t>
+            </a:r>
+            <a:endParaRPr lang="en-US" sz="1100" dirty="0"/>
+          </a:p>
+        </p:txBody>
+      </p:sp>
+      <p:sp>
+        <p:nvSpPr>
+          <p:cNvPr id="11" name="Shape 8"/>
+          <p:cNvSpPr/>
+          <p:nvPr/>
+        </p:nvSpPr>
+        <p:spPr>
+          <a:xfrm>
+            <a:off x="4338218" y="1691640"/>
+            <a:ext cx="3515258" cy="2011680"/>
+          </a:xfrm>
+          <a:prstGeom prst="roundRect">
+            <a:avLst>
+              <a:gd name="adj" fmla="val 3636"/>
+            </a:avLst>
+          </a:prstGeom>
+          <a:solidFill>
+            <a:srgbClr val="EDF3FC"/>
+          </a:solidFill>
+          <a:ln/>
+          <a:effectLst>
+            <a:outerShdw sx="100000" sy="100000" kx="0" ky="0" algn="bl" rotWithShape="0" blurRad="76200" dist="12700" dir="5400000">
+              <a:srgbClr val="9AA7C4">
+                <a:alpha val="25000"/>
+              </a:srgbClr>
+            </a:outerShdw>
+          </a:effectLst>
+        </p:spPr>
+      </p:sp>
+      <p:sp>
+        <p:nvSpPr>
+          <p:cNvPr id="12" name="Shape 9"/>
+          <p:cNvSpPr/>
+          <p:nvPr/>
+        </p:nvSpPr>
+        <p:spPr>
+          <a:xfrm>
+            <a:off x="4539386" y="1892808"/>
+            <a:ext cx="502920" cy="502920"/>
+          </a:xfrm>
+          <a:prstGeom prst="ellipse">
+            <a:avLst/>
+          </a:prstGeom>
+          <a:solidFill>
+            <a:srgbClr val="1E2761"/>
+          </a:solidFill>
+          <a:ln/>
+        </p:spPr>
+      </p:sp>
+      <p:pic>
+        <p:nvPicPr>
+          <p:cNvPr id="13" name="Image 1" descr="preencoded.png">    </p:cNvPr>
+          <p:cNvPicPr>
+            <a:picLocks noChangeAspect="1"/>
+          </p:cNvPicPr>
+          <p:nvPr/>
+        </p:nvPicPr>
+        <p:blipFill>
+          <a:blip r:embed="rId2"/>
+          <a:stretch>
+            <a:fillRect/>
+          </a:stretch>
+        </p:blipFill>
+        <p:spPr>
+          <a:xfrm>
+            <a:off x="4670146" y="2023567"/>
+            <a:ext cx="241402" cy="241402"/>
+          </a:xfrm>
+          <a:prstGeom prst="rect">
+            <a:avLst/>
+          </a:prstGeom>
+        </p:spPr>
+      </p:pic>
+      <p:sp>
+        <p:nvSpPr>
+          <p:cNvPr id="14" name="Text 10"/>
+          <p:cNvSpPr/>
+          <p:nvPr/>
+        </p:nvSpPr>
+        <p:spPr>
+          <a:xfrm>
+            <a:off x="5179466" y="1947672"/>
+            <a:ext cx="2509418" cy="384048"/>
+          </a:xfrm>
+          <a:prstGeom prst="rect">
+            <a:avLst/>
+          </a:prstGeom>
+          <a:noFill/>
+          <a:ln/>
+        </p:spPr>
+        <p:txBody>
+          <a:bodyPr wrap="square" lIns="0" tIns="0" rIns="0" bIns="0" rtlCol="0" anchor="ctr"/>
+          <a:lstStyle/>
+          <a:p>
+            <a:pPr indent="0" marL="0">
+              <a:buNone/>
+            </a:pPr>
+            <a:r>
+              <a:rPr lang="en-US" sz="1450" b="1" dirty="0">
+                <a:solidFill>
+                  <a:srgbClr val="1E2761"/>
+                </a:solidFill>
+                <a:latin typeface="Calibri" pitchFamily="34" charset="0"/>
+                <a:ea typeface="Calibri" pitchFamily="34" charset="-122"/>
+                <a:cs typeface="Calibri" pitchFamily="34" charset="-120"/>
+              </a:rPr>
+              <a:t>Integration tax</a:t>
+            </a:r>
+            <a:endParaRPr lang="en-US" sz="1450" dirty="0"/>
+          </a:p>
+        </p:txBody>
+      </p:sp>
+      <p:sp>
+        <p:nvSpPr>
+          <p:cNvPr id="15" name="Text 11"/>
+          <p:cNvSpPr/>
+          <p:nvPr/>
+        </p:nvSpPr>
+        <p:spPr>
+          <a:xfrm>
+            <a:off x="4566818" y="2468880"/>
+            <a:ext cx="3058058" cy="1051560"/>
+          </a:xfrm>
+          <a:prstGeom prst="rect">
+            <a:avLst/>
+          </a:prstGeom>
+          <a:noFill/>
+          <a:ln/>
+        </p:spPr>
+        <p:txBody>
+          <a:bodyPr wrap="square" lIns="0" tIns="0" rIns="0" bIns="0" rtlCol="0" anchor="ctr"/>
+          <a:lstStyle/>
+          <a:p>
+            <a:pPr indent="0" marL="0">
+              <a:buNone/>
+            </a:pPr>
+            <a:r>
+              <a:rPr lang="en-US" sz="1100" dirty="0">
+                <a:solidFill>
+                  <a:srgbClr val="1B2440"/>
+                </a:solidFill>
+                <a:latin typeface="Calibri" pitchFamily="34" charset="0"/>
+                <a:ea typeface="Calibri" pitchFamily="34" charset="-122"/>
+                <a:cs typeface="Calibri" pitchFamily="34" charset="-120"/>
+              </a:rPr>
+              <a:t>% of feature effort spent inside after the tag lands. The paradigm's core health metric. Target ≤ 15%; rising = spec/mock/pack drift.</a:t>
+            </a:r>
+            <a:endParaRPr lang="en-US" sz="1100" dirty="0"/>
+          </a:p>
+        </p:txBody>
+      </p:sp>
+      <p:sp>
+        <p:nvSpPr>
+          <p:cNvPr id="16" name="Shape 12"/>
+          <p:cNvSpPr/>
+          <p:nvPr/>
+        </p:nvSpPr>
+        <p:spPr>
+          <a:xfrm>
+            <a:off x="8127797" y="1691640"/>
+            <a:ext cx="3515258" cy="2011680"/>
+          </a:xfrm>
+          <a:prstGeom prst="roundRect">
+            <a:avLst>
+              <a:gd name="adj" fmla="val 3636"/>
+            </a:avLst>
+          </a:prstGeom>
+          <a:solidFill>
+            <a:srgbClr val="EDF3FC"/>
+          </a:solidFill>
+          <a:ln/>
+          <a:effectLst>
+            <a:outerShdw sx="100000" sy="100000" kx="0" ky="0" algn="bl" rotWithShape="0" blurRad="76200" dist="12700" dir="5400000">
+              <a:srgbClr val="9AA7C4">
+                <a:alpha val="25000"/>
+              </a:srgbClr>
+            </a:outerShdw>
+          </a:effectLst>
+        </p:spPr>
+      </p:sp>
+      <p:sp>
+        <p:nvSpPr>
+          <p:cNvPr id="17" name="Shape 13"/>
+          <p:cNvSpPr/>
+          <p:nvPr/>
+        </p:nvSpPr>
+        <p:spPr>
+          <a:xfrm>
+            <a:off x="8328965" y="1892808"/>
+            <a:ext cx="502920" cy="502920"/>
+          </a:xfrm>
+          <a:prstGeom prst="ellipse">
+            <a:avLst/>
+          </a:prstGeom>
+          <a:solidFill>
+            <a:srgbClr val="1E2761"/>
+          </a:solidFill>
+          <a:ln/>
+        </p:spPr>
+      </p:sp>
+      <p:pic>
+        <p:nvPicPr>
+          <p:cNvPr id="18" name="Image 2" descr="preencoded.png">    </p:cNvPr>
+          <p:cNvPicPr>
+            <a:picLocks noChangeAspect="1"/>
+          </p:cNvPicPr>
+          <p:nvPr/>
+        </p:nvPicPr>
+        <p:blipFill>
+          <a:blip r:embed="rId3"/>
+          <a:stretch>
+            <a:fillRect/>
+          </a:stretch>
+        </p:blipFill>
+        <p:spPr>
+          <a:xfrm>
+            <a:off x="8459724" y="2023567"/>
+            <a:ext cx="241402" cy="241402"/>
+          </a:xfrm>
+          <a:prstGeom prst="rect">
+            <a:avLst/>
+          </a:prstGeom>
+        </p:spPr>
+      </p:pic>
+      <p:sp>
+        <p:nvSpPr>
+          <p:cNvPr id="19" name="Text 14"/>
+          <p:cNvSpPr/>
+          <p:nvPr/>
+        </p:nvSpPr>
+        <p:spPr>
+          <a:xfrm>
+            <a:off x="8969045" y="1947672"/>
+            <a:ext cx="2509418" cy="384048"/>
+          </a:xfrm>
+          <a:prstGeom prst="rect">
+            <a:avLst/>
+          </a:prstGeom>
+          <a:noFill/>
+          <a:ln/>
+        </p:spPr>
+        <p:txBody>
+          <a:bodyPr wrap="square" lIns="0" tIns="0" rIns="0" bIns="0" rtlCol="0" anchor="ctr"/>
+          <a:lstStyle/>
+          <a:p>
+            <a:pPr indent="0" marL="0">
+              <a:buNone/>
+            </a:pPr>
+            <a:r>
+              <a:rPr lang="en-US" sz="1450" b="1" dirty="0">
+                <a:solidFill>
+                  <a:srgbClr val="1E2761"/>
+                </a:solidFill>
+                <a:latin typeface="Calibri" pitchFamily="34" charset="0"/>
+                <a:ea typeface="Calibri" pitchFamily="34" charset="-122"/>
+                <a:cs typeface="Calibri" pitchFamily="34" charset="-120"/>
+              </a:rPr>
+              <a:t>Egress SLA &amp; yield</a:t>
+            </a:r>
+            <a:endParaRPr lang="en-US" sz="1450" dirty="0"/>
+          </a:p>
+        </p:txBody>
+      </p:sp>
+      <p:sp>
+        <p:nvSpPr>
+          <p:cNvPr id="20" name="Text 15"/>
+          <p:cNvSpPr/>
+          <p:nvPr/>
+        </p:nvSpPr>
+        <p:spPr>
+          <a:xfrm>
+            <a:off x="8356397" y="2468880"/>
+            <a:ext cx="3058058" cy="1051560"/>
+          </a:xfrm>
+          <a:prstGeom prst="rect">
+            <a:avLst/>
+          </a:prstGeom>
+          <a:noFill/>
+          <a:ln/>
+        </p:spPr>
+        <p:txBody>
+          <a:bodyPr wrap="square" lIns="0" tIns="0" rIns="0" bIns="0" rtlCol="0" anchor="ctr"/>
+          <a:lstStyle/>
+          <a:p>
+            <a:pPr indent="0" marL="0">
+              <a:buNone/>
+            </a:pPr>
+            <a:r>
+              <a:rPr lang="en-US" sz="1100" dirty="0">
+                <a:solidFill>
+                  <a:srgbClr val="1B2440"/>
+                </a:solidFill>
+                <a:latin typeface="Calibri" pitchFamily="34" charset="0"/>
+                <a:ea typeface="Calibri" pitchFamily="34" charset="-122"/>
+                <a:cs typeface="Calibri" pitchFamily="34" charset="-120"/>
+              </a:rPr>
+              <a:t>Gate turnaround vs. matrix targets, and % of packages passing Gate 0 clean first try. Falling yield = checklist or tooling gap.</a:t>
+            </a:r>
+            <a:endParaRPr lang="en-US" sz="1100" dirty="0"/>
+          </a:p>
+        </p:txBody>
+      </p:sp>
+      <p:sp>
+        <p:nvSpPr>
+          <p:cNvPr id="21" name="Shape 16"/>
+          <p:cNvSpPr/>
+          <p:nvPr/>
+        </p:nvSpPr>
+        <p:spPr>
+          <a:xfrm>
+            <a:off x="548640" y="3886200"/>
+            <a:ext cx="3515258" cy="2011680"/>
+          </a:xfrm>
+          <a:prstGeom prst="roundRect">
+            <a:avLst>
+              <a:gd name="adj" fmla="val 3636"/>
+            </a:avLst>
+          </a:prstGeom>
+          <a:solidFill>
+            <a:srgbClr val="EDF3FC"/>
+          </a:solidFill>
+          <a:ln/>
+          <a:effectLst>
+            <a:outerShdw sx="100000" sy="100000" kx="0" ky="0" algn="bl" rotWithShape="0" blurRad="76200" dist="12700" dir="5400000">
+              <a:srgbClr val="9AA7C4">
+                <a:alpha val="25000"/>
+              </a:srgbClr>
+            </a:outerShdw>
+          </a:effectLst>
+        </p:spPr>
+      </p:sp>
+      <p:sp>
+        <p:nvSpPr>
+          <p:cNvPr id="22" name="Shape 17"/>
+          <p:cNvSpPr/>
+          <p:nvPr/>
+        </p:nvSpPr>
+        <p:spPr>
+          <a:xfrm>
+            <a:off x="749808" y="4087368"/>
+            <a:ext cx="502920" cy="502920"/>
+          </a:xfrm>
+          <a:prstGeom prst="ellipse">
+            <a:avLst/>
+          </a:prstGeom>
+          <a:solidFill>
+            <a:srgbClr val="1E2761"/>
+          </a:solidFill>
+          <a:ln/>
+        </p:spPr>
+      </p:sp>
+      <p:pic>
+        <p:nvPicPr>
+          <p:cNvPr id="23" name="Image 3" descr="preencoded.png">    </p:cNvPr>
+          <p:cNvPicPr>
+            <a:picLocks noChangeAspect="1"/>
+          </p:cNvPicPr>
+          <p:nvPr/>
+        </p:nvPicPr>
+        <p:blipFill>
+          <a:blip r:embed="rId4"/>
+          <a:stretch>
+            <a:fillRect/>
+          </a:stretch>
+        </p:blipFill>
+        <p:spPr>
+          <a:xfrm>
+            <a:off x="880567" y="4218127"/>
+            <a:ext cx="241402" cy="241402"/>
+          </a:xfrm>
+          <a:prstGeom prst="rect">
+            <a:avLst/>
+          </a:prstGeom>
+        </p:spPr>
+      </p:pic>
+      <p:sp>
+        <p:nvSpPr>
+          <p:cNvPr id="24" name="Text 18"/>
+          <p:cNvSpPr/>
+          <p:nvPr/>
+        </p:nvSpPr>
+        <p:spPr>
+          <a:xfrm>
+            <a:off x="1389888" y="4142232"/>
+            <a:ext cx="2509418" cy="384048"/>
+          </a:xfrm>
+          <a:prstGeom prst="rect">
+            <a:avLst/>
+          </a:prstGeom>
+          <a:noFill/>
+          <a:ln/>
+        </p:spPr>
+        <p:txBody>
+          <a:bodyPr wrap="square" lIns="0" tIns="0" rIns="0" bIns="0" rtlCol="0" anchor="ctr"/>
+          <a:lstStyle/>
+          <a:p>
+            <a:pPr indent="0" marL="0">
+              <a:buNone/>
+            </a:pPr>
+            <a:r>
+              <a:rPr lang="en-US" sz="1450" b="1" dirty="0">
+                <a:solidFill>
+                  <a:srgbClr val="1E2761"/>
+                </a:solidFill>
+                <a:latin typeface="Calibri" pitchFamily="34" charset="0"/>
+                <a:ea typeface="Calibri" pitchFamily="34" charset="-122"/>
+                <a:cs typeface="Calibri" pitchFamily="34" charset="-120"/>
+              </a:rPr>
+              <a:t>Pack coverage</a:t>
+            </a:r>
+            <a:endParaRPr lang="en-US" sz="1450" dirty="0"/>
+          </a:p>
+        </p:txBody>
+      </p:sp>
+      <p:sp>
+        <p:nvSpPr>
+          <p:cNvPr id="25" name="Text 19"/>
+          <p:cNvSpPr/>
+          <p:nvPr/>
+        </p:nvSpPr>
+        <p:spPr>
+          <a:xfrm>
+            <a:off x="777240" y="4663440"/>
+            <a:ext cx="3058058" cy="1051560"/>
+          </a:xfrm>
+          <a:prstGeom prst="rect">
+            <a:avLst/>
+          </a:prstGeom>
+          <a:noFill/>
+          <a:ln/>
+        </p:spPr>
+        <p:txBody>
+          <a:bodyPr wrap="square" lIns="0" tIns="0" rIns="0" bIns="0" rtlCol="0" anchor="ctr"/>
+          <a:lstStyle/>
+          <a:p>
+            <a:pPr indent="0" marL="0">
+              <a:buNone/>
+            </a:pPr>
+            <a:r>
+              <a:rPr lang="en-US" sz="1100" dirty="0">
+                <a:solidFill>
+                  <a:srgbClr val="1B2440"/>
+                </a:solidFill>
+                <a:latin typeface="Calibri" pitchFamily="34" charset="0"/>
+                <a:ea typeface="Calibri" pitchFamily="34" charset="-122"/>
+                <a:cs typeface="Calibri" pitchFamily="34" charset="-120"/>
+              </a:rPr>
+              <a:t>% of business rules expressed as logic-pack data vs. escape-hatch code. Higher = less inside-only work = Phase 3 readiness.</a:t>
+            </a:r>
+            <a:endParaRPr lang="en-US" sz="1100" dirty="0"/>
+          </a:p>
+        </p:txBody>
+      </p:sp>
+      <p:sp>
+        <p:nvSpPr>
+          <p:cNvPr id="26" name="Shape 20"/>
+          <p:cNvSpPr/>
+          <p:nvPr/>
+        </p:nvSpPr>
+        <p:spPr>
+          <a:xfrm>
+            <a:off x="4338218" y="3886200"/>
+            <a:ext cx="3515258" cy="2011680"/>
+          </a:xfrm>
+          <a:prstGeom prst="roundRect">
+            <a:avLst>
+              <a:gd name="adj" fmla="val 3636"/>
+            </a:avLst>
+          </a:prstGeom>
+          <a:solidFill>
+            <a:srgbClr val="EDF3FC"/>
+          </a:solidFill>
+          <a:ln/>
+          <a:effectLst>
+            <a:outerShdw sx="100000" sy="100000" kx="0" ky="0" algn="bl" rotWithShape="0" blurRad="76200" dist="12700" dir="5400000">
+              <a:srgbClr val="9AA7C4">
+                <a:alpha val="25000"/>
+              </a:srgbClr>
+            </a:outerShdw>
+          </a:effectLst>
+        </p:spPr>
+      </p:sp>
+      <p:sp>
+        <p:nvSpPr>
+          <p:cNvPr id="27" name="Shape 21"/>
+          <p:cNvSpPr/>
+          <p:nvPr/>
+        </p:nvSpPr>
+        <p:spPr>
+          <a:xfrm>
+            <a:off x="4539386" y="4087368"/>
+            <a:ext cx="502920" cy="502920"/>
+          </a:xfrm>
+          <a:prstGeom prst="ellipse">
+            <a:avLst/>
+          </a:prstGeom>
+          <a:solidFill>
+            <a:srgbClr val="1E2761"/>
+          </a:solidFill>
+          <a:ln/>
+        </p:spPr>
+      </p:sp>
+      <p:pic>
+        <p:nvPicPr>
+          <p:cNvPr id="28" name="Image 4" descr="preencoded.png">    </p:cNvPr>
+          <p:cNvPicPr>
+            <a:picLocks noChangeAspect="1"/>
+          </p:cNvPicPr>
+          <p:nvPr/>
+        </p:nvPicPr>
+        <p:blipFill>
+          <a:blip r:embed="rId5"/>
+          <a:stretch>
+            <a:fillRect/>
+          </a:stretch>
+        </p:blipFill>
+        <p:spPr>
+          <a:xfrm>
+            <a:off x="4670146" y="4218127"/>
+            <a:ext cx="241402" cy="241402"/>
+          </a:xfrm>
+          <a:prstGeom prst="rect">
+            <a:avLst/>
+          </a:prstGeom>
+        </p:spPr>
+      </p:pic>
+      <p:sp>
+        <p:nvSpPr>
+          <p:cNvPr id="29" name="Text 22"/>
+          <p:cNvSpPr/>
+          <p:nvPr/>
+        </p:nvSpPr>
+        <p:spPr>
+          <a:xfrm>
+            <a:off x="5179466" y="4142232"/>
+            <a:ext cx="2509418" cy="384048"/>
+          </a:xfrm>
+          <a:prstGeom prst="rect">
+            <a:avLst/>
+          </a:prstGeom>
+          <a:noFill/>
+          <a:ln/>
+        </p:spPr>
+        <p:txBody>
+          <a:bodyPr wrap="square" lIns="0" tIns="0" rIns="0" bIns="0" rtlCol="0" anchor="ctr"/>
+          <a:lstStyle/>
+          <a:p>
+            <a:pPr indent="0" marL="0">
+              <a:buNone/>
+            </a:pPr>
+            <a:r>
+              <a:rPr lang="en-US" sz="1450" b="1" dirty="0">
+                <a:solidFill>
+                  <a:srgbClr val="1E2761"/>
+                </a:solidFill>
+                <a:latin typeface="Calibri" pitchFamily="34" charset="0"/>
+                <a:ea typeface="Calibri" pitchFamily="34" charset="-122"/>
+                <a:cs typeface="Calibri" pitchFamily="34" charset="-120"/>
+              </a:rPr>
+              <a:t>Security incidents</a:t>
+            </a:r>
+            <a:endParaRPr lang="en-US" sz="1450" dirty="0"/>
+          </a:p>
+        </p:txBody>
+      </p:sp>
+      <p:sp>
+        <p:nvSpPr>
+          <p:cNvPr id="30" name="Text 23"/>
+          <p:cNvSpPr/>
+          <p:nvPr/>
+        </p:nvSpPr>
+        <p:spPr>
+          <a:xfrm>
+            <a:off x="4566818" y="4663440"/>
+            <a:ext cx="3058058" cy="1051560"/>
+          </a:xfrm>
+          <a:prstGeom prst="rect">
+            <a:avLst/>
+          </a:prstGeom>
+          <a:noFill/>
+          <a:ln/>
+        </p:spPr>
+        <p:txBody>
+          <a:bodyPr wrap="square" lIns="0" tIns="0" rIns="0" bIns="0" rtlCol="0" anchor="ctr"/>
+          <a:lstStyle/>
+          <a:p>
+            <a:pPr indent="0" marL="0">
+              <a:buNone/>
+            </a:pPr>
+            <a:r>
+              <a:rPr lang="en-US" sz="1100" dirty="0">
+                <a:solidFill>
+                  <a:srgbClr val="1B2440"/>
+                </a:solidFill>
+                <a:latin typeface="Calibri" pitchFamily="34" charset="0"/>
+                <a:ea typeface="Calibri" pitchFamily="34" charset="-122"/>
+                <a:cs typeface="Calibri" pitchFamily="34" charset="-120"/>
+              </a:rPr>
+              <a:t>Confirmed leakage events past Gate 3. The only acceptable number is zero; one incident likely ends the program.</a:t>
+            </a:r>
+            <a:endParaRPr lang="en-US" sz="1100" dirty="0"/>
+          </a:p>
+        </p:txBody>
+      </p:sp>
+      <p:sp>
+        <p:nvSpPr>
+          <p:cNvPr id="31" name="Shape 24"/>
+          <p:cNvSpPr/>
+          <p:nvPr/>
+        </p:nvSpPr>
+        <p:spPr>
+          <a:xfrm>
+            <a:off x="8127797" y="3886200"/>
+            <a:ext cx="3515258" cy="2011680"/>
+          </a:xfrm>
+          <a:prstGeom prst="roundRect">
+            <a:avLst>
+              <a:gd name="adj" fmla="val 3636"/>
+            </a:avLst>
+          </a:prstGeom>
+          <a:solidFill>
+            <a:srgbClr val="EDF3FC"/>
+          </a:solidFill>
+          <a:ln/>
+          <a:effectLst>
+            <a:outerShdw sx="100000" sy="100000" kx="0" ky="0" algn="bl" rotWithShape="0" blurRad="76200" dist="12700" dir="5400000">
+              <a:srgbClr val="9AA7C4">
+                <a:alpha val="25000"/>
+              </a:srgbClr>
+            </a:outerShdw>
+          </a:effectLst>
+        </p:spPr>
+      </p:sp>
+      <p:sp>
+        <p:nvSpPr>
+          <p:cNvPr id="32" name="Shape 25"/>
+          <p:cNvSpPr/>
+          <p:nvPr/>
+        </p:nvSpPr>
+        <p:spPr>
+          <a:xfrm>
+            <a:off x="8328965" y="4087368"/>
+            <a:ext cx="502920" cy="502920"/>
+          </a:xfrm>
+          <a:prstGeom prst="ellipse">
+            <a:avLst/>
+          </a:prstGeom>
+          <a:solidFill>
+            <a:srgbClr val="1E2761"/>
+          </a:solidFill>
+          <a:ln/>
+        </p:spPr>
+      </p:sp>
+      <p:pic>
+        <p:nvPicPr>
+          <p:cNvPr id="33" name="Image 5" descr="preencoded.png">    </p:cNvPr>
+          <p:cNvPicPr>
+            <a:picLocks noChangeAspect="1"/>
+          </p:cNvPicPr>
+          <p:nvPr/>
+        </p:nvPicPr>
+        <p:blipFill>
+          <a:blip r:embed="rId6"/>
+          <a:stretch>
+            <a:fillRect/>
+          </a:stretch>
+        </p:blipFill>
+        <p:spPr>
+          <a:xfrm>
+            <a:off x="8459724" y="4218127"/>
+            <a:ext cx="241402" cy="241402"/>
+          </a:xfrm>
+          <a:prstGeom prst="rect">
+            <a:avLst/>
+          </a:prstGeom>
+        </p:spPr>
+      </p:pic>
+      <p:sp>
+        <p:nvSpPr>
+          <p:cNvPr id="34" name="Text 26"/>
+          <p:cNvSpPr/>
+          <p:nvPr/>
+        </p:nvSpPr>
+        <p:spPr>
+          <a:xfrm>
+            <a:off x="8969045" y="4142232"/>
+            <a:ext cx="2509418" cy="384048"/>
+          </a:xfrm>
+          <a:prstGeom prst="rect">
+            <a:avLst/>
+          </a:prstGeom>
+          <a:noFill/>
+          <a:ln/>
+        </p:spPr>
+        <p:txBody>
+          <a:bodyPr wrap="square" lIns="0" tIns="0" rIns="0" bIns="0" rtlCol="0" anchor="ctr"/>
+          <a:lstStyle/>
+          <a:p>
+            <a:pPr indent="0" marL="0">
+              <a:buNone/>
+            </a:pPr>
+            <a:r>
+              <a:rPr lang="en-US" sz="1450" b="1" dirty="0">
+                <a:solidFill>
+                  <a:srgbClr val="1E2761"/>
+                </a:solidFill>
+                <a:latin typeface="Calibri" pitchFamily="34" charset="0"/>
+                <a:ea typeface="Calibri" pitchFamily="34" charset="-122"/>
+                <a:cs typeface="Calibri" pitchFamily="34" charset="-120"/>
+              </a:rPr>
+              <a:t>Bus-factor spread</a:t>
+            </a:r>
+            <a:endParaRPr lang="en-US" sz="1450" dirty="0"/>
+          </a:p>
+        </p:txBody>
+      </p:sp>
+      <p:sp>
+        <p:nvSpPr>
+          <p:cNvPr id="35" name="Text 27"/>
+          <p:cNvSpPr/>
+          <p:nvPr/>
+        </p:nvSpPr>
+        <p:spPr>
+          <a:xfrm>
+            <a:off x="8356397" y="4663440"/>
+            <a:ext cx="3058058" cy="1051560"/>
+          </a:xfrm>
+          <a:prstGeom prst="rect">
+            <a:avLst/>
+          </a:prstGeom>
+          <a:noFill/>
+          <a:ln/>
+        </p:spPr>
+        <p:txBody>
+          <a:bodyPr wrap="square" lIns="0" tIns="0" rIns="0" bIns="0" rtlCol="0" anchor="ctr"/>
+          <a:lstStyle/>
+          <a:p>
+            <a:pPr indent="0" marL="0">
+              <a:buNone/>
+            </a:pPr>
+            <a:r>
+              <a:rPr lang="en-US" sz="1100" dirty="0">
+                <a:solidFill>
+                  <a:srgbClr val="1B2440"/>
+                </a:solidFill>
+                <a:latin typeface="Calibri" pitchFamily="34" charset="0"/>
+                <a:ea typeface="Calibri" pitchFamily="34" charset="-122"/>
+                <a:cs typeface="Calibri" pitchFamily="34" charset="-120"/>
+              </a:rPr>
+              <a:t>Per contractor duty: runbook exists + a core-team member has executed it this quarter. 100% = Phase 3 can trigger any day.</a:t>
+            </a:r>
+            <a:endParaRPr lang="en-US" sz="1100" dirty="0"/>
+          </a:p>
+        </p:txBody>
+      </p:sp>
+      <p:sp>
+        <p:nvSpPr>
+          <p:cNvPr id="36" name="Text 28"/>
+          <p:cNvSpPr/>
+          <p:nvPr/>
+        </p:nvSpPr>
+        <p:spPr>
+          <a:xfrm>
+            <a:off x="548640" y="5989320"/>
+            <a:ext cx="11094415" cy="365760"/>
+          </a:xfrm>
+          <a:prstGeom prst="rect">
+            <a:avLst/>
+          </a:prstGeom>
+          <a:noFill/>
+          <a:ln/>
+        </p:spPr>
+        <p:txBody>
+          <a:bodyPr wrap="square" lIns="0" tIns="0" rIns="0" bIns="0" rtlCol="0" anchor="ctr"/>
+          <a:lstStyle/>
+          <a:p>
+            <a:pPr algn="ctr" indent="0" marL="0">
+              <a:buNone/>
+            </a:pPr>
+            <a:r>
+              <a:rPr lang="en-US" sz="1250" i="1" dirty="0">
+                <a:solidFill>
+                  <a:srgbClr val="5A6B8C"/>
+                </a:solidFill>
+                <a:latin typeface="Calibri" pitchFamily="34" charset="0"/>
+                <a:ea typeface="Calibri" pitchFamily="34" charset="-122"/>
+                <a:cs typeface="Calibri" pitchFamily="34" charset="-120"/>
+              </a:rPr>
+              <a:t>Publish the scoreboard monthly — to stakeholders, not just the team. Transparency is the counter-narrative.</a:t>
+            </a:r>
+            <a:endParaRPr lang="en-US" sz="1250" dirty="0"/>
+          </a:p>
+        </p:txBody>
+      </p:sp>
+    </p:spTree>
+  </p:cSld>
+  <p:clrMapOvr>
+    <a:masterClrMapping/>
+  </p:clrMapOvr>
+</p:sld>
+</file>
+
+<file path=ppt/slides/slide19.xml><?xml version="1.0" encoding="utf-8"?>
+<p:sld xmlns:a="http://schemas.openxmlformats.org/drawingml/2006/main" xmlns:r="http://schemas.openxmlformats.org/officeDocument/2006/relationships" xmlns:p="http://schemas.openxmlformats.org/presentationml/2006/main">
+  <p:cSld name="Slide 19">
     <p:bg>
       <p:bgPr>
         <a:solidFill>
@@ -10702,7 +11622,7 @@
                 <a:ea typeface="Calibri" pitchFamily="34" charset="-122"/>
                 <a:cs typeface="Calibri" pitchFamily="34" charset="-120"/>
               </a:rPr>
-              <a:t>18</a:t>
+              <a:t>19</a:t>
             </a:r>
             <a:endParaRPr lang="en-US" sz="900" dirty="0"/>
           </a:p>
@@ -10816,8 +11736,8 @@
         </p:nvSpPr>
         <p:spPr>
           <a:xfrm>
-            <a:off x="548640" y="2377440"/>
-            <a:ext cx="10607040" cy="2377440"/>
+            <a:off x="548640" y="2286000"/>
+            <a:ext cx="10607040" cy="2651760"/>
           </a:xfrm>
           <a:prstGeom prst="rect">
             <a:avLst/>
@@ -10831,13 +11751,13 @@
           <a:p>
             <a:pPr marL="342900" indent="-342900">
               <a:spcAft>
-                <a:spcPts val="1400"/>
+                <a:spcPts val="1200"/>
               </a:spcAft>
               <a:buSzPct val="100000"/>
               <a:buChar char="•"/>
             </a:pPr>
             <a:r>
-              <a:rPr lang="en-US" sz="1600" dirty="0">
+              <a:rPr lang="en-US" sz="1500" dirty="0">
                 <a:solidFill>
                   <a:srgbClr val="CADCFC"/>
                 </a:solidFill>
@@ -10847,18 +11767,18 @@
               </a:rPr>
               <a:t>Authorize a bounded Phase-0 pilot in writing: one feature, defined egress channel, defined gates</a:t>
             </a:r>
-            <a:endParaRPr lang="en-US" sz="1600" dirty="0"/>
+            <a:endParaRPr lang="en-US" sz="1500" dirty="0"/>
           </a:p>
           <a:p>
             <a:pPr marL="342900" indent="-342900">
               <a:spcAft>
-                <a:spcPts val="1400"/>
+                <a:spcPts val="1200"/>
               </a:spcAft>
               <a:buSzPct val="100000"/>
               <a:buChar char="•"/>
             </a:pPr>
             <a:r>
-              <a:rPr lang="en-US" sz="1600" dirty="0">
+              <a:rPr lang="en-US" sz="1500" dirty="0">
                 <a:solidFill>
                   <a:srgbClr val="CADCFC"/>
                 </a:solidFill>
@@ -10868,18 +11788,18 @@
               </a:rPr>
               <a:t>Name the approvers: engineering supervisor for Tiers 1–2, a cyber/SW-assurance fast-track contact for Tier 3</a:t>
             </a:r>
-            <a:endParaRPr lang="en-US" sz="1600" dirty="0"/>
+            <a:endParaRPr lang="en-US" sz="1500" dirty="0"/>
           </a:p>
           <a:p>
             <a:pPr marL="342900" indent="-342900">
               <a:spcAft>
-                <a:spcPts val="1400"/>
+                <a:spcPts val="1200"/>
               </a:spcAft>
               <a:buSzPct val="100000"/>
               <a:buChar char="•"/>
             </a:pPr>
             <a:r>
-              <a:rPr lang="en-US" sz="1600" dirty="0">
+              <a:rPr lang="en-US" sz="1500" dirty="0">
                 <a:solidFill>
                   <a:srgbClr val="CADCFC"/>
                 </a:solidFill>
@@ -10889,18 +11809,18 @@
               </a:rPr>
               <a:t>Fund the gate tooling: scanner integration, egress ledger, logic-pack contract &amp; validators</a:t>
             </a:r>
-            <a:endParaRPr lang="en-US" sz="1600" dirty="0"/>
+            <a:endParaRPr lang="en-US" sz="1500" dirty="0"/>
           </a:p>
           <a:p>
             <a:pPr marL="342900" indent="-342900">
               <a:spcAft>
-                <a:spcPts val="1400"/>
+                <a:spcPts val="1200"/>
               </a:spcAft>
               <a:buSzPct val="100000"/>
               <a:buChar char="•"/>
             </a:pPr>
             <a:r>
-              <a:rPr lang="en-US" sz="1600" dirty="0">
+              <a:rPr lang="en-US" sz="1500" dirty="0">
                 <a:solidFill>
                   <a:srgbClr val="CADCFC"/>
                 </a:solidFill>
@@ -10910,7 +11830,28 @@
               </a:rPr>
               <a:t>Endorse the workforce message: contractors get a real transition story, told early and honestly</a:t>
             </a:r>
-            <a:endParaRPr lang="en-US" sz="1600" dirty="0"/>
+            <a:endParaRPr lang="en-US" sz="1500" dirty="0"/>
+          </a:p>
+          <a:p>
+            <a:pPr marL="342900" indent="-342900">
+              <a:spcAft>
+                <a:spcPts val="1200"/>
+              </a:spcAft>
+              <a:buSzPct val="100000"/>
+              <a:buChar char="•"/>
+            </a:pPr>
+            <a:r>
+              <a:rPr lang="en-US" sz="1500" dirty="0">
+                <a:solidFill>
+                  <a:srgbClr val="CADCFC"/>
+                </a:solidFill>
+                <a:latin typeface="Calibri" pitchFamily="34" charset="0"/>
+                <a:ea typeface="Calibri" pitchFamily="34" charset="-122"/>
+                <a:cs typeface="Calibri" pitchFamily="34" charset="-120"/>
+              </a:rPr>
+              <a:t>Charter a department working group: one gate standard, shared tooling and IR playbook — before N teams invent N processes</a:t>
+            </a:r>
+            <a:endParaRPr lang="en-US" sz="1500" dirty="0"/>
           </a:p>
         </p:txBody>
       </p:sp>

</xml_diff>

<commit_message>
Reframe department strategy: lead by example with Greenlane adoption
Sibling core teams are vibe-coding straight into Confi (no tags, no
pipelines), so the federation slide/section becomes a lead-by-example
play: legislate the standard before the first incident, a Greenlane
certified-inbound pipeline as the adoption engine (evidence-bearing
packages get expedited Confi deployment), and the paradigm shipped as
a forkable starter kit with one sibling team as first adopter.

New Section 8: with AI-commoditized building, the moat is
industrialized trust — certification, ops transformation, adoption,
sustainment; review becomes the bottleneck; built != done; Phase-3
team identity as certifiers and integrators. Greenlane share added
to the KPI scoreboard.

Co-Authored-By: Claude Fable 5 <noreply@anthropic.com>
Claude-Session: https://claude.ai/code/session_01NCQ4pPu4jZQ7AgDqWePsQe
</commit_message>
<xml_diff>
--- a/docs/internet-first-airgap-final.pptx
+++ b/docs/internet-first-airgap-final.pptx
@@ -8536,7 +8536,7 @@
                 <a:ea typeface="Calibri" pitchFamily="34" charset="-122"/>
                 <a:cs typeface="Calibri" pitchFamily="34" charset="-120"/>
               </a:rPr>
-              <a:t>THE DEPARTMENT DIMENSION · SIBLING CORE TEAMS ARE DOING THIS TOO</a:t>
+              <a:t>THE DEPARTMENT DIMENSION · SIBLINGS VIBE-CODE INTO CONFI TODAY</a:t>
             </a:r>
             <a:endParaRPr lang="en-US" sz="1200" dirty="0"/>
           </a:p>
@@ -8575,7 +8575,7 @@
                 <a:ea typeface="Cambria" pitchFamily="34" charset="-122"/>
                 <a:cs typeface="Cambria" pitchFamily="34" charset="-120"/>
               </a:rPr>
-              <a:t>One paradigm, many teams — federate or fragment</a:t>
+              <a:t>Lead by example — make governed the fastest path</a:t>
             </a:r>
             <a:endParaRPr lang="en-US" sz="3000" dirty="0"/>
           </a:p>
@@ -8687,7 +8687,7 @@
                 <a:ea typeface="Calibri" pitchFamily="34" charset="-122"/>
                 <a:cs typeface="Calibri" pitchFamily="34" charset="-120"/>
               </a:rPr>
-              <a:t>Shared fate on incidents</a:t>
+              <a:t>The reality: ungoverned ingress</a:t>
             </a:r>
             <a:endParaRPr lang="en-US" sz="1400" dirty="0"/>
           </a:p>
@@ -8726,7 +8726,7 @@
                 <a:ea typeface="Calibri" pitchFamily="34" charset="-122"/>
                 <a:cs typeface="Calibri" pitchFamily="34" charset="-120"/>
               </a:rPr>
-              <a:t>With N teams running parallel egress workflows, ONE team's leak ends the paradigm for ALL — leadership will not distinguish whose gate failed. The weakest gate in the department now defines our risk. Propose a common department gate standard (gates 0–3, tiers, ledgers), shared scanner + denylist infrastructure, and a JOINT incident-response playbook: who is notified, blast-radius assessment from the egress ledger, remediation (retire aliases, quarantine repos), reporting channel. No team should be inventing IR mid-incident.</a:t>
+              <a:t>We asked: sibling core teams build exactly like our competitors — vibe-code outside, no version tags, no pipelines, straight into Confi to test and deploy. Every such import is an unreviewed, unattested channel into the classified network. Their risk is OUR risk: leadership reacting to an incident will not distinguish whose workflow failed — “the internet development thing caused it” is the headline either way.</a:t>
             </a:r>
             <a:endParaRPr lang="en-US" sz="960" dirty="0"/>
           </a:p>
@@ -8838,7 +8838,7 @@
                 <a:ea typeface="Calibri" pitchFamily="34" charset="-122"/>
                 <a:cs typeface="Calibri" pitchFamily="34" charset="-120"/>
               </a:rPr>
-              <a:t>Fiction hygiene across teams</a:t>
+              <a:t>Legislate before the incident</a:t>
             </a:r>
             <a:endParaRPr lang="en-US" sz="1400" dirty="0"/>
           </a:p>
@@ -8877,7 +8877,7 @@
                 <a:ea typeface="Calibri" pitchFamily="34" charset="-122"/>
                 <a:cs typeface="Calibri" pitchFamily="34" charset="-120"/>
               </a:rPr>
-              <a:t>Multiple fictional universes from the same population of people and orgs is a triangulation gift: shared contributors, shared CI templates, and structurally similar repos let an observer correlate universes and back out the real domain. Rules: one fiction per team, never shared; separate internet orgs; no cross-referencing between universes; share world-BUILDING lessons inside the airgap, never world content outside it.</a:t>
+              <a:t>Post-incident policy is written in panic and will be blunt — most likely “no internet development at all.” Being the team with a working, governed alternative BEFORE the first spill or AI-code outage changes the conversation from “shut it all down” to “make everyone do it like them.” Formalizing our standard with cyber is now time-critical, not nice-to-have. First-mover here is survival insurance, not prestige.</a:t>
             </a:r>
             <a:endParaRPr lang="en-US" sz="960" dirty="0"/>
           </a:p>
@@ -8989,7 +8989,7 @@
                 <a:ea typeface="Calibri" pitchFamily="34" charset="-122"/>
                 <a:cs typeface="Calibri" pitchFamily="34" charset="-120"/>
               </a:rPr>
-              <a:t>Write the standard first</a:t>
+              <a:t>Greenlane: discipline as the fast path</a:t>
             </a:r>
             <a:endParaRPr lang="en-US" sz="1400" dirty="0"/>
           </a:p>
@@ -9028,7 +9028,7 @@
                 <a:ea typeface="Calibri" pitchFamily="34" charset="-122"/>
                 <a:cs typeface="Calibri" pitchFamily="34" charset="-120"/>
               </a:rPr>
-              <a:t>Whoever formalizes their gate process first will effectively write the department SOP — everyone else gets audited against it later. We have the head start: the desensitizer exists, the gate design exists. Co-author the standard with cyber NOW and the “desensitizer as internal product” play gains real customers: sibling teams adopt our tooling, and we become the paradigm's platform team rather than one of N users of someone else's rules.</a:t>
+              <a:t>Adoption will not come from mandate — make the governed path the FAST path. A package arriving with evidence (signed tag, green pipeline, SAST report, contract validation) earns the expedited Confi lane: automated Greenlane testing and deployment. Ungoverned code takes the slow lane of full manual review. Teams adopt the gates because gated is faster — carrot, not stick. The Greenlane is the adoption engine.</a:t>
             </a:r>
             <a:endParaRPr lang="en-US" sz="960" dirty="0"/>
           </a:p>
@@ -9140,7 +9140,7 @@
                 <a:ea typeface="Calibri" pitchFamily="34" charset="-122"/>
                 <a:cs typeface="Calibri" pitchFamily="34" charset="-120"/>
               </a:rPr>
-              <a:t>Cross-team leverage</a:t>
+              <a:t>Ship the standard as a starter kit</a:t>
             </a:r>
             <a:endParaRPr lang="en-US" sz="1400" dirty="0"/>
           </a:p>
@@ -9179,7 +9179,7 @@
                 <a:ea typeface="Calibri" pitchFamily="34" charset="-122"/>
                 <a:cs typeface="Calibri" pitchFamily="34" charset="-120"/>
               </a:rPr>
-              <a:t>Sibling teams solve our hardest staffing problems: Gate-2 reviewers borrowed across teams are GENUINELY fresh eyes (they don't share our context, so residual meaning jumps out); shared inner-source tooling (passive-shell engine, MSW scaffolds, dependency-delta job, mapping registry) amortizes platform cost across the department; and KPI benchmarking across teams will happen anyway — co-defining the metrics beats being measured by someone else's.</a:t>
+              <a:t>Nobody adopts a policy document. Publish the paradigm as a template repo — pipelines, lint/SAST configs, MSW scaffold, extractor integration, world-bible template — adoptable by a sibling team in a day. Then onboard ONE sibling team as the first external user; their success is the proof of generality that makes this the department standard, written by us. Fiction hygiene rule stands: separate orgs, one universe per team, never cross-referenced.</a:t>
             </a:r>
             <a:endParaRPr lang="en-US" sz="960" dirty="0"/>
           </a:p>
@@ -9218,7 +9218,7 @@
                 <a:ea typeface="Calibri" pitchFamily="34" charset="-122"/>
                 <a:cs typeface="Calibri" pitchFamily="34" charset="-120"/>
               </a:rPr>
-              <a:t>Blue = risks to close jointly · Green = advantages of moving first. And scale the approvers: N teams need a cyber rota, not a named hero.</a:t>
+              <a:t>Everyone is fast now — building is commoditized. The scarce asset is industrialized trust: certified production from cheap AI code.</a:t>
             </a:r>
             <a:endParaRPr lang="en-US" sz="1100" dirty="0"/>
           </a:p>

</xml_diff>